<commit_message>
Optimize presentation layout + add bilingual speaking notes
Presentation improvements:
- Cleaner header bar design (0.9" height)
- Better figure placement and sizing
- Consistent caption formatting
- Three-column layout on conclusion slide
- Improved color contrast

Speaking notes (speaking_notes.md):
- Full bilingual script (English + Chinese)
- ~10-12 minute presentation timing
- Slide-by-slide breakdown
- Q&A preparation section

Co-Authored-By: Claude Opus 4.5 <noreply@anthropic.com>
</commit_message>
<xml_diff>
--- a/CFRM522_Presentation.pptx
+++ b/CFRM522_Presentation.pptx
@@ -3118,8 +3118,8 @@
         </p:nvSpPr>
         <p:spPr>
           <a:xfrm>
-            <a:off x="0" y="2560320"/>
-            <a:ext cx="12191695" cy="91440"/>
+            <a:off x="731520" y="2743200"/>
+            <a:ext cx="10698480" cy="54864"/>
           </a:xfrm>
           <a:prstGeom prst="rect">
             <a:avLst/>
@@ -3161,7 +3161,7 @@
         </p:nvSpPr>
         <p:spPr>
           <a:xfrm>
-            <a:off x="731520" y="1371600"/>
+            <a:off x="731520" y="1645920"/>
             <a:ext cx="10058400" cy="914400"/>
           </a:xfrm>
           <a:prstGeom prst="rect">
@@ -3176,7 +3176,7 @@
           <a:lstStyle/>
           <a:p>
             <a:pPr algn="l">
-              <a:defRPr sz="4400" b="1">
+              <a:defRPr sz="4800" b="1">
                 <a:solidFill>
                   <a:srgbClr val="FFFFFF"/>
                 </a:solidFill>
@@ -3197,7 +3197,7 @@
         </p:nvSpPr>
         <p:spPr>
           <a:xfrm>
-            <a:off x="731520" y="2926080"/>
+            <a:off x="731520" y="3108960"/>
             <a:ext cx="10058400" cy="548640"/>
           </a:xfrm>
           <a:prstGeom prst="rect">
@@ -3220,7 +3220,7 @@
               </a:defRPr>
             </a:pPr>
             <a:r>
-              <a:t>BTC-USDT Perpetual Futures on Binance</a:t>
+              <a:t>BTC-USDT Perpetual Futures | Binance</a:t>
             </a:r>
           </a:p>
         </p:txBody>
@@ -3234,7 +3234,7 @@
         <p:spPr>
           <a:xfrm>
             <a:off x="731520" y="5029200"/>
-            <a:ext cx="4572000" cy="914400"/>
+            <a:ext cx="4572000" cy="457200"/>
           </a:xfrm>
           <a:prstGeom prst="rect">
             <a:avLst/>
@@ -3248,7 +3248,7 @@
           <a:lstStyle/>
           <a:p>
             <a:pPr algn="l">
-              <a:defRPr sz="2000" b="0">
+              <a:defRPr sz="2200" b="0">
                 <a:solidFill>
                   <a:srgbClr val="FFFFFF"/>
                 </a:solidFill>
@@ -3258,9 +3258,41 @@
             <a:r>
               <a:t>Adeline Wen</a:t>
             </a:r>
-            <a:br/>
-            <a:r>
-              <a:t>CFRM 522 — Winter 2026</a:t>
+          </a:p>
+        </p:txBody>
+      </p:sp>
+      <p:sp>
+        <p:nvSpPr>
+          <p:cNvPr id="6" name="TextBox 5"/>
+          <p:cNvSpPr txBox="1"/>
+          <p:nvPr/>
+        </p:nvSpPr>
+        <p:spPr>
+          <a:xfrm>
+            <a:off x="731520" y="5486400"/>
+            <a:ext cx="4572000" cy="457200"/>
+          </a:xfrm>
+          <a:prstGeom prst="rect">
+            <a:avLst/>
+          </a:prstGeom>
+          <a:noFill/>
+        </p:spPr>
+        <p:txBody>
+          <a:bodyPr wrap="square">
+            <a:spAutoFit/>
+          </a:bodyPr>
+          <a:lstStyle/>
+          <a:p>
+            <a:pPr algn="l">
+              <a:defRPr sz="1800" b="0">
+                <a:solidFill>
+                  <a:srgbClr val="E8E3D3"/>
+                </a:solidFill>
+                <a:latin typeface="Arial"/>
+              </a:defRPr>
+            </a:pPr>
+            <a:r>
+              <a:t>CFRM 522 · Winter 2026</a:t>
             </a:r>
           </a:p>
         </p:txBody>
@@ -3300,7 +3332,7 @@
         <p:spPr>
           <a:xfrm>
             <a:off x="0" y="0"/>
-            <a:ext cx="12191695" cy="914400"/>
+            <a:ext cx="12191695" cy="822960"/>
           </a:xfrm>
           <a:prstGeom prst="rect">
             <a:avLst/>
@@ -3336,50 +3368,14 @@
       </p:sp>
       <p:sp>
         <p:nvSpPr>
-          <p:cNvPr id="3" name="TextBox 2"/>
-          <p:cNvSpPr txBox="1"/>
-          <p:nvPr/>
-        </p:nvSpPr>
-        <p:spPr>
-          <a:xfrm>
-            <a:off x="457200" y="228600"/>
-            <a:ext cx="10972800" cy="548640"/>
-          </a:xfrm>
-          <a:prstGeom prst="rect">
-            <a:avLst/>
-          </a:prstGeom>
-          <a:noFill/>
-        </p:spPr>
-        <p:txBody>
-          <a:bodyPr wrap="none">
-            <a:spAutoFit/>
-          </a:bodyPr>
-          <a:lstStyle/>
-          <a:p>
-            <a:pPr>
-              <a:defRPr sz="2600" b="1">
-                <a:solidFill>
-                  <a:srgbClr val="FFFFFF"/>
-                </a:solidFill>
-                <a:latin typeface="Arial"/>
-              </a:defRPr>
-            </a:pPr>
-            <a:r>
-              <a:t>Parameter Optimization: Sensitivity Analysis</a:t>
-            </a:r>
-          </a:p>
-        </p:txBody>
-      </p:sp>
-      <p:sp>
-        <p:nvSpPr>
-          <p:cNvPr id="4" name="Rectangle 3"/>
+          <p:cNvPr id="3" name="Rectangle 2"/>
           <p:cNvSpPr/>
           <p:nvPr/>
         </p:nvSpPr>
         <p:spPr>
           <a:xfrm>
-            <a:off x="0" y="914400"/>
-            <a:ext cx="12191695" cy="36576"/>
+            <a:off x="0" y="822960"/>
+            <a:ext cx="12191695" cy="32004"/>
           </a:xfrm>
           <a:prstGeom prst="rect">
             <a:avLst/>
@@ -3410,6 +3406,42 @@
           <a:lstStyle/>
           <a:p>
             <a:pPr algn="ctr"/>
+          </a:p>
+        </p:txBody>
+      </p:sp>
+      <p:sp>
+        <p:nvSpPr>
+          <p:cNvPr id="4" name="TextBox 3"/>
+          <p:cNvSpPr txBox="1"/>
+          <p:nvPr/>
+        </p:nvSpPr>
+        <p:spPr>
+          <a:xfrm>
+            <a:off x="457200" y="201168"/>
+            <a:ext cx="10972800" cy="502920"/>
+          </a:xfrm>
+          <a:prstGeom prst="rect">
+            <a:avLst/>
+          </a:prstGeom>
+          <a:noFill/>
+        </p:spPr>
+        <p:txBody>
+          <a:bodyPr wrap="square">
+            <a:spAutoFit/>
+          </a:bodyPr>
+          <a:lstStyle/>
+          <a:p>
+            <a:pPr algn="l">
+              <a:defRPr sz="2800" b="1">
+                <a:solidFill>
+                  <a:srgbClr val="FFFFFF"/>
+                </a:solidFill>
+                <a:latin typeface="Arial"/>
+              </a:defRPr>
+            </a:pPr>
+            <a:r>
+              <a:t>Parameter Optimization: Sensitivity Analysis</a:t>
+            </a:r>
           </a:p>
         </p:txBody>
       </p:sp>
@@ -3429,8 +3461,8 @@
         </p:blipFill>
         <p:spPr>
           <a:xfrm>
-            <a:off x="182880" y="1051560"/>
-            <a:ext cx="11795760" cy="3089209"/>
+            <a:off x="274320" y="960120"/>
+            <a:ext cx="11612880" cy="3041314"/>
           </a:xfrm>
           <a:prstGeom prst="rect">
             <a:avLst/>
@@ -3445,8 +3477,8 @@
         </p:nvSpPr>
         <p:spPr>
           <a:xfrm>
-            <a:off x="457200" y="6217920"/>
-            <a:ext cx="10972800" cy="457200"/>
+            <a:off x="457200" y="6309360"/>
+            <a:ext cx="11247120" cy="365760"/>
           </a:xfrm>
           <a:prstGeom prst="rect">
             <a:avLst/>
@@ -3459,22 +3491,16 @@
           </a:bodyPr>
           <a:lstStyle/>
           <a:p>
-            <a:pPr>
-              <a:spcBef>
-                <a:spcPts val="400"/>
-              </a:spcBef>
-              <a:spcAft>
-                <a:spcPts val="400"/>
-              </a:spcAft>
-              <a:defRPr sz="1400">
-                <a:solidFill>
-                  <a:srgbClr val="333333"/>
-                </a:solidFill>
-                <a:latin typeface="Arial"/>
-              </a:defRPr>
-            </a:pPr>
-            <a:r>
-              <a:t>Flat curve = robust to parameter choice • Sharp peak = potential overfit • Threshold most sensitive parameter</a:t>
+            <a:pPr algn="ctr">
+              <a:defRPr sz="1300" b="0">
+                <a:solidFill>
+                  <a:srgbClr val="666666"/>
+                </a:solidFill>
+                <a:latin typeface="Arial"/>
+              </a:defRPr>
+            </a:pPr>
+            <a:r>
+              <a:t>Flat = robust to choice  •  Sharp peak = overfit risk  •  Threshold is most sensitive parameter</a:t>
             </a:r>
           </a:p>
         </p:txBody>
@@ -3514,7 +3540,7 @@
         <p:spPr>
           <a:xfrm>
             <a:off x="0" y="0"/>
-            <a:ext cx="12191695" cy="914400"/>
+            <a:ext cx="12191695" cy="822960"/>
           </a:xfrm>
           <a:prstGeom prst="rect">
             <a:avLst/>
@@ -3550,50 +3576,14 @@
       </p:sp>
       <p:sp>
         <p:nvSpPr>
-          <p:cNvPr id="3" name="TextBox 2"/>
-          <p:cNvSpPr txBox="1"/>
-          <p:nvPr/>
-        </p:nvSpPr>
-        <p:spPr>
-          <a:xfrm>
-            <a:off x="457200" y="228600"/>
-            <a:ext cx="10972800" cy="548640"/>
-          </a:xfrm>
-          <a:prstGeom prst="rect">
-            <a:avLst/>
-          </a:prstGeom>
-          <a:noFill/>
-        </p:spPr>
-        <p:txBody>
-          <a:bodyPr wrap="none">
-            <a:spAutoFit/>
-          </a:bodyPr>
-          <a:lstStyle/>
-          <a:p>
-            <a:pPr>
-              <a:defRPr sz="2600" b="1">
-                <a:solidFill>
-                  <a:srgbClr val="FFFFFF"/>
-                </a:solidFill>
-                <a:latin typeface="Arial"/>
-              </a:defRPr>
-            </a:pPr>
-            <a:r>
-              <a:t>Walk-Forward Analysis (Out-of-Sample)</a:t>
-            </a:r>
-          </a:p>
-        </p:txBody>
-      </p:sp>
-      <p:sp>
-        <p:nvSpPr>
-          <p:cNvPr id="4" name="Rectangle 3"/>
+          <p:cNvPr id="3" name="Rectangle 2"/>
           <p:cNvSpPr/>
           <p:nvPr/>
         </p:nvSpPr>
         <p:spPr>
           <a:xfrm>
-            <a:off x="0" y="914400"/>
-            <a:ext cx="12191695" cy="36576"/>
+            <a:off x="0" y="822960"/>
+            <a:ext cx="12191695" cy="32004"/>
           </a:xfrm>
           <a:prstGeom prst="rect">
             <a:avLst/>
@@ -3624,6 +3614,42 @@
           <a:lstStyle/>
           <a:p>
             <a:pPr algn="ctr"/>
+          </a:p>
+        </p:txBody>
+      </p:sp>
+      <p:sp>
+        <p:nvSpPr>
+          <p:cNvPr id="4" name="TextBox 3"/>
+          <p:cNvSpPr txBox="1"/>
+          <p:nvPr/>
+        </p:nvSpPr>
+        <p:spPr>
+          <a:xfrm>
+            <a:off x="457200" y="201168"/>
+            <a:ext cx="10972800" cy="502920"/>
+          </a:xfrm>
+          <a:prstGeom prst="rect">
+            <a:avLst/>
+          </a:prstGeom>
+          <a:noFill/>
+        </p:spPr>
+        <p:txBody>
+          <a:bodyPr wrap="square">
+            <a:spAutoFit/>
+          </a:bodyPr>
+          <a:lstStyle/>
+          <a:p>
+            <a:pPr algn="l">
+              <a:defRPr sz="2800" b="1">
+                <a:solidFill>
+                  <a:srgbClr val="FFFFFF"/>
+                </a:solidFill>
+                <a:latin typeface="Arial"/>
+              </a:defRPr>
+            </a:pPr>
+            <a:r>
+              <a:t>Walk-Forward Analysis (Out-of-Sample)</a:t>
+            </a:r>
           </a:p>
         </p:txBody>
       </p:sp>
@@ -3643,8 +3669,8 @@
         </p:blipFill>
         <p:spPr>
           <a:xfrm>
-            <a:off x="274320" y="1005840"/>
-            <a:ext cx="11612880" cy="7720258"/>
+            <a:off x="365760" y="914400"/>
+            <a:ext cx="11430000" cy="7598679"/>
           </a:xfrm>
           <a:prstGeom prst="rect">
             <a:avLst/>
@@ -3659,8 +3685,8 @@
         </p:nvSpPr>
         <p:spPr>
           <a:xfrm>
-            <a:off x="457200" y="6217920"/>
-            <a:ext cx="10972800" cy="457200"/>
+            <a:off x="457200" y="6309360"/>
+            <a:ext cx="11247120" cy="365760"/>
           </a:xfrm>
           <a:prstGeom prst="rect">
             <a:avLst/>
@@ -3673,22 +3699,16 @@
           </a:bodyPr>
           <a:lstStyle/>
           <a:p>
-            <a:pPr>
-              <a:spcBef>
-                <a:spcPts val="400"/>
-              </a:spcBef>
-              <a:spcAft>
-                <a:spcPts val="400"/>
-              </a:spcAft>
-              <a:defRPr sz="1400">
-                <a:solidFill>
-                  <a:srgbClr val="333333"/>
-                </a:solidFill>
-                <a:latin typeface="Arial"/>
-              </a:defRPr>
-            </a:pPr>
-            <a:r>
-              <a:t>Most OOS windows positive • WF ratio ~0.3-0.6 • Parameter drift suggests regime dependence • H4 PARTIALLY SUPPORTED</a:t>
+            <a:pPr algn="ctr">
+              <a:defRPr sz="1300" b="0">
+                <a:solidFill>
+                  <a:srgbClr val="666666"/>
+                </a:solidFill>
+                <a:latin typeface="Arial"/>
+              </a:defRPr>
+            </a:pPr>
+            <a:r>
+              <a:t>Most OOS windows positive  •  WF ratio 0.3-0.6  •  Parameter drift → regime dependence  •  H4 PARTIALLY SUPPORTED</a:t>
             </a:r>
           </a:p>
         </p:txBody>
@@ -3728,7 +3748,7 @@
         <p:spPr>
           <a:xfrm>
             <a:off x="0" y="0"/>
-            <a:ext cx="12191695" cy="914400"/>
+            <a:ext cx="12191695" cy="822960"/>
           </a:xfrm>
           <a:prstGeom prst="rect">
             <a:avLst/>
@@ -3764,50 +3784,14 @@
       </p:sp>
       <p:sp>
         <p:nvSpPr>
-          <p:cNvPr id="3" name="TextBox 2"/>
-          <p:cNvSpPr txBox="1"/>
-          <p:nvPr/>
-        </p:nvSpPr>
-        <p:spPr>
-          <a:xfrm>
-            <a:off x="457200" y="228600"/>
-            <a:ext cx="10972800" cy="548640"/>
-          </a:xfrm>
-          <a:prstGeom prst="rect">
-            <a:avLst/>
-          </a:prstGeom>
-          <a:noFill/>
-        </p:spPr>
-        <p:txBody>
-          <a:bodyPr wrap="none">
-            <a:spAutoFit/>
-          </a:bodyPr>
-          <a:lstStyle/>
-          <a:p>
-            <a:pPr>
-              <a:defRPr sz="2600" b="1">
-                <a:solidFill>
-                  <a:srgbClr val="FFFFFF"/>
-                </a:solidFill>
-                <a:latin typeface="Arial"/>
-              </a:defRPr>
-            </a:pPr>
-            <a:r>
-              <a:t>Overfitting: Bootstrap Sharpe Distribution</a:t>
-            </a:r>
-          </a:p>
-        </p:txBody>
-      </p:sp>
-      <p:sp>
-        <p:nvSpPr>
-          <p:cNvPr id="4" name="Rectangle 3"/>
+          <p:cNvPr id="3" name="Rectangle 2"/>
           <p:cNvSpPr/>
           <p:nvPr/>
         </p:nvSpPr>
         <p:spPr>
           <a:xfrm>
-            <a:off x="0" y="914400"/>
-            <a:ext cx="12191695" cy="36576"/>
+            <a:off x="0" y="822960"/>
+            <a:ext cx="12191695" cy="32004"/>
           </a:xfrm>
           <a:prstGeom prst="rect">
             <a:avLst/>
@@ -3838,6 +3822,42 @@
           <a:lstStyle/>
           <a:p>
             <a:pPr algn="ctr"/>
+          </a:p>
+        </p:txBody>
+      </p:sp>
+      <p:sp>
+        <p:nvSpPr>
+          <p:cNvPr id="4" name="TextBox 3"/>
+          <p:cNvSpPr txBox="1"/>
+          <p:nvPr/>
+        </p:nvSpPr>
+        <p:spPr>
+          <a:xfrm>
+            <a:off x="457200" y="201168"/>
+            <a:ext cx="10972800" cy="502920"/>
+          </a:xfrm>
+          <a:prstGeom prst="rect">
+            <a:avLst/>
+          </a:prstGeom>
+          <a:noFill/>
+        </p:spPr>
+        <p:txBody>
+          <a:bodyPr wrap="square">
+            <a:spAutoFit/>
+          </a:bodyPr>
+          <a:lstStyle/>
+          <a:p>
+            <a:pPr algn="l">
+              <a:defRPr sz="2800" b="1">
+                <a:solidFill>
+                  <a:srgbClr val="FFFFFF"/>
+                </a:solidFill>
+                <a:latin typeface="Arial"/>
+              </a:defRPr>
+            </a:pPr>
+            <a:r>
+              <a:t>Overfitting Diagnostics</a:t>
+            </a:r>
           </a:p>
         </p:txBody>
       </p:sp>
@@ -3857,8 +3877,8 @@
         </p:blipFill>
         <p:spPr>
           <a:xfrm>
-            <a:off x="1828800" y="1097280"/>
-            <a:ext cx="8229600" cy="3609609"/>
+            <a:off x="365760" y="1005840"/>
+            <a:ext cx="6858000" cy="3008007"/>
           </a:xfrm>
           <a:prstGeom prst="rect">
             <a:avLst/>
@@ -3873,7 +3893,7 @@
         </p:nvSpPr>
         <p:spPr>
           <a:xfrm>
-            <a:off x="457200" y="5029200"/>
+            <a:off x="7498079" y="1097280"/>
             <a:ext cx="4572000" cy="365760"/>
           </a:xfrm>
           <a:prstGeom prst="rect">
@@ -3896,7 +3916,7 @@
               </a:defRPr>
             </a:pPr>
             <a:r>
-              <a:t>Deflated Sharpe Ratio (DSR)</a:t>
+              <a:t>Deflated Sharpe Ratio</a:t>
             </a:r>
           </a:p>
         </p:txBody>
@@ -3909,8 +3929,8 @@
         </p:nvSpPr>
         <p:spPr>
           <a:xfrm>
-            <a:off x="457200" y="5394960"/>
-            <a:ext cx="4572000" cy="1097280"/>
+            <a:off x="7498079" y="1508760"/>
+            <a:ext cx="4114800" cy="1645920"/>
           </a:xfrm>
           <a:prstGeom prst="rect">
             <a:avLst/>
@@ -3925,58 +3945,58 @@
           <a:p>
             <a:pPr>
               <a:spcBef>
-                <a:spcPts val="400"/>
+                <a:spcPts val="800"/>
               </a:spcBef>
               <a:spcAft>
-                <a:spcPts val="400"/>
+                <a:spcPts val="800"/>
               </a:spcAft>
               <a:defRPr sz="1500">
                 <a:solidFill>
-                  <a:srgbClr val="333333"/>
-                </a:solidFill>
-                <a:latin typeface="Arial"/>
-              </a:defRPr>
-            </a:pPr>
-            <a:r>
-              <a:t>Accounts for 120+ parameter trials</a:t>
+                  <a:srgbClr val="2D2D2D"/>
+                </a:solidFill>
+                <a:latin typeface="Arial"/>
+              </a:defRPr>
+            </a:pPr>
+            <a:r>
+              <a:t>• Accounts for 120+ trials</a:t>
             </a:r>
           </a:p>
           <a:p>
             <a:pPr>
               <a:spcBef>
-                <a:spcPts val="400"/>
+                <a:spcPts val="800"/>
               </a:spcBef>
               <a:spcAft>
-                <a:spcPts val="400"/>
+                <a:spcPts val="800"/>
               </a:spcAft>
               <a:defRPr sz="1500">
                 <a:solidFill>
-                  <a:srgbClr val="333333"/>
-                </a:solidFill>
-                <a:latin typeface="Arial"/>
-              </a:defRPr>
-            </a:pPr>
-            <a:r>
-              <a:t>DSR adjusts for selection bias</a:t>
+                  <a:srgbClr val="2D2D2D"/>
+                </a:solidFill>
+                <a:latin typeface="Arial"/>
+              </a:defRPr>
+            </a:pPr>
+            <a:r>
+              <a:t>• Adjusts for selection bias</a:t>
             </a:r>
           </a:p>
           <a:p>
             <a:pPr>
               <a:spcBef>
-                <a:spcPts val="400"/>
+                <a:spcPts val="800"/>
               </a:spcBef>
               <a:spcAft>
-                <a:spcPts val="400"/>
+                <a:spcPts val="800"/>
               </a:spcAft>
               <a:defRPr sz="1500">
                 <a:solidFill>
-                  <a:srgbClr val="333333"/>
-                </a:solidFill>
-                <a:latin typeface="Arial"/>
-              </a:defRPr>
-            </a:pPr>
-            <a:r>
-              <a:t>Wide CI reflects sample uncertainty</a:t>
+                  <a:srgbClr val="2D2D2D"/>
+                </a:solidFill>
+                <a:latin typeface="Arial"/>
+              </a:defRPr>
+            </a:pPr>
+            <a:r>
+              <a:t>• Wide CI reflects uncertainty</a:t>
             </a:r>
           </a:p>
         </p:txBody>
@@ -3989,7 +4009,7 @@
         </p:nvSpPr>
         <p:spPr>
           <a:xfrm>
-            <a:off x="6400800" y="5029200"/>
+            <a:off x="7498079" y="3291840"/>
             <a:ext cx="4572000" cy="365760"/>
           </a:xfrm>
           <a:prstGeom prst="rect">
@@ -4025,8 +4045,8 @@
         </p:nvSpPr>
         <p:spPr>
           <a:xfrm>
-            <a:off x="6400800" y="5394960"/>
-            <a:ext cx="5029200" cy="1097280"/>
+            <a:off x="7498079" y="3703320"/>
+            <a:ext cx="4114800" cy="1645920"/>
           </a:xfrm>
           <a:prstGeom prst="rect">
             <a:avLst/>
@@ -4041,58 +4061,130 @@
           <a:p>
             <a:pPr>
               <a:spcBef>
-                <a:spcPts val="400"/>
+                <a:spcPts val="800"/>
               </a:spcBef>
               <a:spcAft>
-                <a:spcPts val="400"/>
+                <a:spcPts val="800"/>
               </a:spcAft>
               <a:defRPr sz="1500">
                 <a:solidFill>
-                  <a:srgbClr val="333333"/>
-                </a:solidFill>
-                <a:latin typeface="Arial"/>
-              </a:defRPr>
-            </a:pPr>
-            <a:r>
-              <a:t>Remove best 20 trades</a:t>
+                  <a:srgbClr val="2D2D2D"/>
+                </a:solidFill>
+                <a:latin typeface="Arial"/>
+              </a:defRPr>
+            </a:pPr>
+            <a:r>
+              <a:t>• Remove best 20 trades</a:t>
             </a:r>
           </a:p>
           <a:p>
             <a:pPr>
               <a:spcBef>
-                <a:spcPts val="400"/>
+                <a:spcPts val="800"/>
               </a:spcBef>
               <a:spcAft>
-                <a:spcPts val="400"/>
+                <a:spcPts val="800"/>
               </a:spcAft>
               <a:defRPr sz="1500">
                 <a:solidFill>
-                  <a:srgbClr val="333333"/>
-                </a:solidFill>
-                <a:latin typeface="Arial"/>
-              </a:defRPr>
-            </a:pPr>
-            <a:r>
-              <a:t>Still profitable → distributed edge</a:t>
+                  <a:srgbClr val="2D2D2D"/>
+                </a:solidFill>
+                <a:latin typeface="Arial"/>
+              </a:defRPr>
+            </a:pPr>
+            <a:r>
+              <a:t>• Still profitable</a:t>
             </a:r>
           </a:p>
           <a:p>
             <a:pPr>
               <a:spcBef>
-                <a:spcPts val="400"/>
+                <a:spcPts val="800"/>
               </a:spcBef>
               <a:spcAft>
-                <a:spcPts val="400"/>
+                <a:spcPts val="800"/>
               </a:spcAft>
               <a:defRPr sz="1500">
                 <a:solidFill>
-                  <a:srgbClr val="333333"/>
-                </a:solidFill>
-                <a:latin typeface="Arial"/>
-              </a:defRPr>
-            </a:pPr>
-            <a:r>
-              <a:t>Not outlier-driven</a:t>
+                  <a:srgbClr val="2D2D2D"/>
+                </a:solidFill>
+                <a:latin typeface="Arial"/>
+              </a:defRPr>
+            </a:pPr>
+            <a:r>
+              <a:t>• Edge is distributed, not outlier-driven</a:t>
+            </a:r>
+          </a:p>
+        </p:txBody>
+      </p:sp>
+      <p:sp>
+        <p:nvSpPr>
+          <p:cNvPr id="10" name="TextBox 9"/>
+          <p:cNvSpPr txBox="1"/>
+          <p:nvPr/>
+        </p:nvSpPr>
+        <p:spPr>
+          <a:xfrm>
+            <a:off x="7498079" y="5303520"/>
+            <a:ext cx="4572000" cy="365760"/>
+          </a:xfrm>
+          <a:prstGeom prst="rect">
+            <a:avLst/>
+          </a:prstGeom>
+          <a:noFill/>
+        </p:spPr>
+        <p:txBody>
+          <a:bodyPr wrap="square">
+            <a:spAutoFit/>
+          </a:bodyPr>
+          <a:lstStyle/>
+          <a:p>
+            <a:pPr algn="l">
+              <a:defRPr sz="1800" b="1">
+                <a:solidFill>
+                  <a:srgbClr val="4B2E83"/>
+                </a:solidFill>
+                <a:latin typeface="Arial"/>
+              </a:defRPr>
+            </a:pPr>
+            <a:r>
+              <a:t>PBO Cross-Test</a:t>
+            </a:r>
+          </a:p>
+        </p:txBody>
+      </p:sp>
+      <p:sp>
+        <p:nvSpPr>
+          <p:cNvPr id="11" name="TextBox 10"/>
+          <p:cNvSpPr txBox="1"/>
+          <p:nvPr/>
+        </p:nvSpPr>
+        <p:spPr>
+          <a:xfrm>
+            <a:off x="7498079" y="5669280"/>
+            <a:ext cx="4114800" cy="548640"/>
+          </a:xfrm>
+          <a:prstGeom prst="rect">
+            <a:avLst/>
+          </a:prstGeom>
+          <a:noFill/>
+        </p:spPr>
+        <p:txBody>
+          <a:bodyPr wrap="square">
+            <a:spAutoFit/>
+          </a:bodyPr>
+          <a:lstStyle/>
+          <a:p>
+            <a:pPr algn="l">
+              <a:defRPr sz="1400" b="0">
+                <a:solidFill>
+                  <a:srgbClr val="666666"/>
+                </a:solidFill>
+                <a:latin typeface="Arial"/>
+              </a:defRPr>
+            </a:pPr>
+            <a:r>
+              <a:t>Half-sample optimization shows moderate parameter stability across time</a:t>
             </a:r>
           </a:p>
         </p:txBody>
@@ -4132,7 +4224,7 @@
         <p:spPr>
           <a:xfrm>
             <a:off x="0" y="0"/>
-            <a:ext cx="12191695" cy="914400"/>
+            <a:ext cx="12191695" cy="822960"/>
           </a:xfrm>
           <a:prstGeom prst="rect">
             <a:avLst/>
@@ -4168,50 +4260,14 @@
       </p:sp>
       <p:sp>
         <p:nvSpPr>
-          <p:cNvPr id="3" name="TextBox 2"/>
-          <p:cNvSpPr txBox="1"/>
-          <p:nvPr/>
-        </p:nvSpPr>
-        <p:spPr>
-          <a:xfrm>
-            <a:off x="457200" y="228600"/>
-            <a:ext cx="10972800" cy="548640"/>
-          </a:xfrm>
-          <a:prstGeom prst="rect">
-            <a:avLst/>
-          </a:prstGeom>
-          <a:noFill/>
-        </p:spPr>
-        <p:txBody>
-          <a:bodyPr wrap="none">
-            <a:spAutoFit/>
-          </a:bodyPr>
-          <a:lstStyle/>
-          <a:p>
-            <a:pPr>
-              <a:defRPr sz="2600" b="1">
-                <a:solidFill>
-                  <a:srgbClr val="FFFFFF"/>
-                </a:solidFill>
-                <a:latin typeface="Arial"/>
-              </a:defRPr>
-            </a:pPr>
-            <a:r>
-              <a:t>Extension: Cross-Asset &amp; ETH</a:t>
-            </a:r>
-          </a:p>
-        </p:txBody>
-      </p:sp>
-      <p:sp>
-        <p:nvSpPr>
-          <p:cNvPr id="4" name="Rectangle 3"/>
+          <p:cNvPr id="3" name="Rectangle 2"/>
           <p:cNvSpPr/>
           <p:nvPr/>
         </p:nvSpPr>
         <p:spPr>
           <a:xfrm>
-            <a:off x="0" y="914400"/>
-            <a:ext cx="12191695" cy="36576"/>
+            <a:off x="0" y="822960"/>
+            <a:ext cx="12191695" cy="32004"/>
           </a:xfrm>
           <a:prstGeom prst="rect">
             <a:avLst/>
@@ -4242,6 +4298,42 @@
           <a:lstStyle/>
           <a:p>
             <a:pPr algn="ctr"/>
+          </a:p>
+        </p:txBody>
+      </p:sp>
+      <p:sp>
+        <p:nvSpPr>
+          <p:cNvPr id="4" name="TextBox 3"/>
+          <p:cNvSpPr txBox="1"/>
+          <p:nvPr/>
+        </p:nvSpPr>
+        <p:spPr>
+          <a:xfrm>
+            <a:off x="457200" y="201168"/>
+            <a:ext cx="10972800" cy="502920"/>
+          </a:xfrm>
+          <a:prstGeom prst="rect">
+            <a:avLst/>
+          </a:prstGeom>
+          <a:noFill/>
+        </p:spPr>
+        <p:txBody>
+          <a:bodyPr wrap="square">
+            <a:spAutoFit/>
+          </a:bodyPr>
+          <a:lstStyle/>
+          <a:p>
+            <a:pPr algn="l">
+              <a:defRPr sz="2800" b="1">
+                <a:solidFill>
+                  <a:srgbClr val="FFFFFF"/>
+                </a:solidFill>
+                <a:latin typeface="Arial"/>
+              </a:defRPr>
+            </a:pPr>
+            <a:r>
+              <a:t>Extension: Cross-Asset Validation</a:t>
+            </a:r>
           </a:p>
         </p:txBody>
       </p:sp>
@@ -4261,8 +4353,8 @@
         </p:blipFill>
         <p:spPr>
           <a:xfrm>
-            <a:off x="274320" y="1051560"/>
-            <a:ext cx="5486400" cy="2711336"/>
+            <a:off x="274320" y="1005840"/>
+            <a:ext cx="5303520" cy="2620958"/>
           </a:xfrm>
           <a:prstGeom prst="rect">
             <a:avLst/>
@@ -4285,8 +4377,8 @@
         </p:blipFill>
         <p:spPr>
           <a:xfrm>
-            <a:off x="5943600" y="1051560"/>
-            <a:ext cx="5943600" cy="1952374"/>
+            <a:off x="5760720" y="1005840"/>
+            <a:ext cx="6126480" cy="2012448"/>
           </a:xfrm>
           <a:prstGeom prst="rect">
             <a:avLst/>
@@ -4301,8 +4393,8 @@
         </p:nvSpPr>
         <p:spPr>
           <a:xfrm>
-            <a:off x="457200" y="5303520"/>
-            <a:ext cx="10972800" cy="731520"/>
+            <a:off x="457200" y="5029200"/>
+            <a:ext cx="5029200" cy="365760"/>
           </a:xfrm>
           <a:prstGeom prst="rect">
             <a:avLst/>
@@ -4315,41 +4407,131 @@
           </a:bodyPr>
           <a:lstStyle/>
           <a:p>
-            <a:pPr>
-              <a:spcBef>
-                <a:spcPts val="400"/>
-              </a:spcBef>
-              <a:spcAft>
-                <a:spcPts val="400"/>
-              </a:spcAft>
-              <a:defRPr sz="1500">
-                <a:solidFill>
-                  <a:srgbClr val="333333"/>
-                </a:solidFill>
-                <a:latin typeface="Arial"/>
-              </a:defRPr>
-            </a:pPr>
-            <a:r>
-              <a:t>Left: BTC-ETH funding correlation ~0.7+ (macro-driven, limited diversification)</a:t>
-            </a:r>
-          </a:p>
-          <a:p>
-            <a:pPr>
-              <a:spcBef>
-                <a:spcPts val="400"/>
-              </a:spcBef>
-              <a:spcAft>
-                <a:spcPts val="400"/>
-              </a:spcAft>
-              <a:defRPr sz="1500">
-                <a:solidFill>
-                  <a:srgbClr val="333333"/>
-                </a:solidFill>
-                <a:latin typeface="Arial"/>
-              </a:defRPr>
-            </a:pPr>
-            <a:r>
-              <a:t>Right: ETH positive Calmar with BTC-optimized params (no re-fitting) → genuine microstructure effect</a:t>
+            <a:pPr algn="l">
+              <a:defRPr sz="1400" b="0">
+                <a:solidFill>
+                  <a:srgbClr val="666666"/>
+                </a:solidFill>
+                <a:latin typeface="Arial"/>
+              </a:defRPr>
+            </a:pPr>
+            <a:r>
+              <a:t>BTC-ETH correlation ~0.7+ (macro-driven)</a:t>
+            </a:r>
+          </a:p>
+        </p:txBody>
+      </p:sp>
+      <p:sp>
+        <p:nvSpPr>
+          <p:cNvPr id="8" name="TextBox 7"/>
+          <p:cNvSpPr txBox="1"/>
+          <p:nvPr/>
+        </p:nvSpPr>
+        <p:spPr>
+          <a:xfrm>
+            <a:off x="5943600" y="5029200"/>
+            <a:ext cx="5760720" cy="365760"/>
+          </a:xfrm>
+          <a:prstGeom prst="rect">
+            <a:avLst/>
+          </a:prstGeom>
+          <a:noFill/>
+        </p:spPr>
+        <p:txBody>
+          <a:bodyPr wrap="square">
+            <a:spAutoFit/>
+          </a:bodyPr>
+          <a:lstStyle/>
+          <a:p>
+            <a:pPr algn="l">
+              <a:defRPr sz="1400" b="0">
+                <a:solidFill>
+                  <a:srgbClr val="666666"/>
+                </a:solidFill>
+                <a:latin typeface="Arial"/>
+              </a:defRPr>
+            </a:pPr>
+            <a:r>
+              <a:t>ETH positive Calmar with BTC params (no re-fit) → genuine effect</a:t>
+            </a:r>
+          </a:p>
+        </p:txBody>
+      </p:sp>
+      <p:sp>
+        <p:nvSpPr>
+          <p:cNvPr id="9" name="Rounded Rectangle 8"/>
+          <p:cNvSpPr/>
+          <p:nvPr/>
+        </p:nvSpPr>
+        <p:spPr>
+          <a:xfrm>
+            <a:off x="457200" y="5669280"/>
+            <a:ext cx="11247120" cy="640080"/>
+          </a:xfrm>
+          <a:prstGeom prst="roundRect">
+            <a:avLst/>
+          </a:prstGeom>
+          <a:solidFill>
+            <a:srgbClr val="E8E3D3"/>
+          </a:solidFill>
+          <a:ln>
+            <a:noFill/>
+          </a:ln>
+        </p:spPr>
+        <p:style>
+          <a:lnRef idx="1">
+            <a:schemeClr val="accent1"/>
+          </a:lnRef>
+          <a:fillRef idx="3">
+            <a:schemeClr val="accent1"/>
+          </a:fillRef>
+          <a:effectRef idx="2">
+            <a:schemeClr val="accent1"/>
+          </a:effectRef>
+          <a:fontRef idx="minor">
+            <a:schemeClr val="lt1"/>
+          </a:fontRef>
+        </p:style>
+        <p:txBody>
+          <a:bodyPr rtlCol="0" anchor="ctr"/>
+          <a:lstStyle/>
+          <a:p>
+            <a:pPr algn="ctr"/>
+          </a:p>
+        </p:txBody>
+      </p:sp>
+      <p:sp>
+        <p:nvSpPr>
+          <p:cNvPr id="10" name="TextBox 9"/>
+          <p:cNvSpPr txBox="1"/>
+          <p:nvPr/>
+        </p:nvSpPr>
+        <p:spPr>
+          <a:xfrm>
+            <a:off x="640080" y="5806440"/>
+            <a:ext cx="10972800" cy="457200"/>
+          </a:xfrm>
+          <a:prstGeom prst="rect">
+            <a:avLst/>
+          </a:prstGeom>
+          <a:noFill/>
+        </p:spPr>
+        <p:txBody>
+          <a:bodyPr wrap="square">
+            <a:spAutoFit/>
+          </a:bodyPr>
+          <a:lstStyle/>
+          <a:p>
+            <a:pPr algn="ctr">
+              <a:defRPr sz="1500" b="1">
+                <a:solidFill>
+                  <a:srgbClr val="4B2E83"/>
+                </a:solidFill>
+                <a:latin typeface="Arial"/>
+              </a:defRPr>
+            </a:pPr>
+            <a:r>
+              <a:t>Cross-asset validation confirms: funding rate contrarian is a market microstructure effect, not BTC-specific noise</a:t>
             </a:r>
           </a:p>
         </p:txBody>
@@ -4389,7 +4571,7 @@
         <p:spPr>
           <a:xfrm>
             <a:off x="0" y="0"/>
-            <a:ext cx="12191695" cy="914400"/>
+            <a:ext cx="12191695" cy="822960"/>
           </a:xfrm>
           <a:prstGeom prst="rect">
             <a:avLst/>
@@ -4425,50 +4607,14 @@
       </p:sp>
       <p:sp>
         <p:nvSpPr>
-          <p:cNvPr id="3" name="TextBox 2"/>
-          <p:cNvSpPr txBox="1"/>
-          <p:nvPr/>
-        </p:nvSpPr>
-        <p:spPr>
-          <a:xfrm>
-            <a:off x="457200" y="228600"/>
-            <a:ext cx="10972800" cy="548640"/>
-          </a:xfrm>
-          <a:prstGeom prst="rect">
-            <a:avLst/>
-          </a:prstGeom>
-          <a:noFill/>
-        </p:spPr>
-        <p:txBody>
-          <a:bodyPr wrap="none">
-            <a:spAutoFit/>
-          </a:bodyPr>
-          <a:lstStyle/>
-          <a:p>
-            <a:pPr>
-              <a:defRPr sz="2600" b="1">
-                <a:solidFill>
-                  <a:srgbClr val="FFFFFF"/>
-                </a:solidFill>
-                <a:latin typeface="Arial"/>
-              </a:defRPr>
-            </a:pPr>
-            <a:r>
-              <a:t>Conclusion</a:t>
-            </a:r>
-          </a:p>
-        </p:txBody>
-      </p:sp>
-      <p:sp>
-        <p:nvSpPr>
-          <p:cNvPr id="4" name="Rectangle 3"/>
+          <p:cNvPr id="3" name="Rectangle 2"/>
           <p:cNvSpPr/>
           <p:nvPr/>
         </p:nvSpPr>
         <p:spPr>
           <a:xfrm>
-            <a:off x="0" y="914400"/>
-            <a:ext cx="12191695" cy="36576"/>
+            <a:off x="0" y="822960"/>
+            <a:ext cx="12191695" cy="32004"/>
           </a:xfrm>
           <a:prstGeom prst="rect">
             <a:avLst/>
@@ -4504,14 +4650,14 @@
       </p:sp>
       <p:sp>
         <p:nvSpPr>
-          <p:cNvPr id="5" name="TextBox 4"/>
+          <p:cNvPr id="4" name="TextBox 3"/>
           <p:cNvSpPr txBox="1"/>
           <p:nvPr/>
         </p:nvSpPr>
         <p:spPr>
           <a:xfrm>
-            <a:off x="457200" y="1188720"/>
-            <a:ext cx="4572000" cy="457200"/>
+            <a:off x="457200" y="201168"/>
+            <a:ext cx="10972800" cy="502920"/>
           </a:xfrm>
           <a:prstGeom prst="rect">
             <a:avLst/>
@@ -4525,29 +4671,29 @@
           <a:lstStyle/>
           <a:p>
             <a:pPr algn="l">
-              <a:defRPr sz="2000" b="1">
-                <a:solidFill>
-                  <a:srgbClr val="4B2E83"/>
-                </a:solidFill>
-                <a:latin typeface="Arial"/>
-              </a:defRPr>
-            </a:pPr>
-            <a:r>
-              <a:t>Key Findings</a:t>
-            </a:r>
-          </a:p>
-        </p:txBody>
-      </p:sp>
-      <p:sp>
-        <p:nvSpPr>
-          <p:cNvPr id="6" name="TextBox 5"/>
+              <a:defRPr sz="2800" b="1">
+                <a:solidFill>
+                  <a:srgbClr val="FFFFFF"/>
+                </a:solidFill>
+                <a:latin typeface="Arial"/>
+              </a:defRPr>
+            </a:pPr>
+            <a:r>
+              <a:t>Conclusion</a:t>
+            </a:r>
+          </a:p>
+        </p:txBody>
+      </p:sp>
+      <p:sp>
+        <p:nvSpPr>
+          <p:cNvPr id="5" name="TextBox 4"/>
           <p:cNvSpPr txBox="1"/>
           <p:nvPr/>
         </p:nvSpPr>
         <p:spPr>
           <a:xfrm>
-            <a:off x="457200" y="1645920"/>
-            <a:ext cx="5029200" cy="2286000"/>
+            <a:off x="457200" y="1097280"/>
+            <a:ext cx="4572000" cy="365760"/>
           </a:xfrm>
           <a:prstGeom prst="rect">
             <a:avLst/>
@@ -4560,112 +4706,30 @@
           </a:bodyPr>
           <a:lstStyle/>
           <a:p>
-            <a:pPr>
-              <a:spcBef>
-                <a:spcPts val="400"/>
-              </a:spcBef>
-              <a:spcAft>
-                <a:spcPts val="400"/>
-              </a:spcAft>
-              <a:defRPr sz="1600">
-                <a:solidFill>
-                  <a:srgbClr val="333333"/>
-                </a:solidFill>
-                <a:latin typeface="Arial"/>
-              </a:defRPr>
-            </a:pPr>
-            <a:r>
-              <a:t>Funding rate contrarian effect is real</a:t>
-            </a:r>
-          </a:p>
-          <a:p>
-            <a:pPr>
-              <a:spcBef>
-                <a:spcPts val="400"/>
-              </a:spcBef>
-              <a:spcAft>
-                <a:spcPts val="400"/>
-              </a:spcAft>
-              <a:defRPr sz="1600">
-                <a:solidFill>
-                  <a:srgbClr val="333333"/>
-                </a:solidFill>
-                <a:latin typeface="Arial"/>
-              </a:defRPr>
-            </a:pPr>
-            <a:r>
-              <a:t>Economic basis: crowding + margin pressure</a:t>
-            </a:r>
-          </a:p>
-          <a:p>
-            <a:pPr>
-              <a:spcBef>
-                <a:spcPts val="400"/>
-              </a:spcBef>
-              <a:spcAft>
-                <a:spcPts val="400"/>
-              </a:spcAft>
-              <a:defRPr sz="1600">
-                <a:solidFill>
-                  <a:srgbClr val="333333"/>
-                </a:solidFill>
-                <a:latin typeface="Arial"/>
-              </a:defRPr>
-            </a:pPr>
-            <a:r>
-              <a:t>IC statistically significant at 24h</a:t>
-            </a:r>
-          </a:p>
-          <a:p>
-            <a:pPr>
-              <a:spcBef>
-                <a:spcPts val="400"/>
-              </a:spcBef>
-              <a:spcAft>
-                <a:spcPts val="400"/>
-              </a:spcAft>
-              <a:defRPr sz="1600">
-                <a:solidFill>
-                  <a:srgbClr val="333333"/>
-                </a:solidFill>
-                <a:latin typeface="Arial"/>
-              </a:defRPr>
-            </a:pPr>
-            <a:r>
-              <a:t>OOS performance positive (40-60% degradation typical)</a:t>
-            </a:r>
-          </a:p>
-          <a:p>
-            <a:pPr>
-              <a:spcBef>
-                <a:spcPts val="400"/>
-              </a:spcBef>
-              <a:spcAft>
-                <a:spcPts val="400"/>
-              </a:spcAft>
-              <a:defRPr sz="1600">
-                <a:solidFill>
-                  <a:srgbClr val="333333"/>
-                </a:solidFill>
-                <a:latin typeface="Arial"/>
-              </a:defRPr>
-            </a:pPr>
-            <a:r>
-              <a:t>Cross-asset validation on ETH</a:t>
-            </a:r>
-          </a:p>
-        </p:txBody>
-      </p:sp>
-      <p:sp>
-        <p:nvSpPr>
-          <p:cNvPr id="7" name="TextBox 6"/>
+            <a:pPr algn="l">
+              <a:defRPr sz="1800" b="1">
+                <a:solidFill>
+                  <a:srgbClr val="4B2E83"/>
+                </a:solidFill>
+                <a:latin typeface="Arial"/>
+              </a:defRPr>
+            </a:pPr>
+            <a:r>
+              <a:t>Key Findings</a:t>
+            </a:r>
+          </a:p>
+        </p:txBody>
+      </p:sp>
+      <p:sp>
+        <p:nvSpPr>
+          <p:cNvPr id="6" name="TextBox 5"/>
           <p:cNvSpPr txBox="1"/>
           <p:nvPr/>
         </p:nvSpPr>
         <p:spPr>
           <a:xfrm>
-            <a:off x="5943600" y="1188720"/>
-            <a:ext cx="4572000" cy="457200"/>
+            <a:off x="457200" y="1508760"/>
+            <a:ext cx="3657600" cy="2560320"/>
           </a:xfrm>
           <a:prstGeom prst="rect">
             <a:avLst/>
@@ -4678,30 +4742,112 @@
           </a:bodyPr>
           <a:lstStyle/>
           <a:p>
-            <a:pPr algn="l">
-              <a:defRPr sz="2000" b="1">
-                <a:solidFill>
-                  <a:srgbClr val="4B2E83"/>
-                </a:solidFill>
-                <a:latin typeface="Arial"/>
-              </a:defRPr>
-            </a:pPr>
-            <a:r>
-              <a:t>Backtest Results</a:t>
-            </a:r>
-          </a:p>
-        </p:txBody>
-      </p:sp>
-      <p:sp>
-        <p:nvSpPr>
-          <p:cNvPr id="8" name="TextBox 7"/>
+            <a:pPr>
+              <a:spcBef>
+                <a:spcPts val="800"/>
+              </a:spcBef>
+              <a:spcAft>
+                <a:spcPts val="800"/>
+              </a:spcAft>
+              <a:defRPr sz="1400">
+                <a:solidFill>
+                  <a:srgbClr val="2D2D2D"/>
+                </a:solidFill>
+                <a:latin typeface="Arial"/>
+              </a:defRPr>
+            </a:pPr>
+            <a:r>
+              <a:t>• Funding contrarian effect is real</a:t>
+            </a:r>
+          </a:p>
+          <a:p>
+            <a:pPr>
+              <a:spcBef>
+                <a:spcPts val="800"/>
+              </a:spcBef>
+              <a:spcAft>
+                <a:spcPts val="800"/>
+              </a:spcAft>
+              <a:defRPr sz="1400">
+                <a:solidFill>
+                  <a:srgbClr val="2D2D2D"/>
+                </a:solidFill>
+                <a:latin typeface="Arial"/>
+              </a:defRPr>
+            </a:pPr>
+            <a:r>
+              <a:t>• Economic basis: crowding + margin</a:t>
+            </a:r>
+          </a:p>
+          <a:p>
+            <a:pPr>
+              <a:spcBef>
+                <a:spcPts val="800"/>
+              </a:spcBef>
+              <a:spcAft>
+                <a:spcPts val="800"/>
+              </a:spcAft>
+              <a:defRPr sz="1400">
+                <a:solidFill>
+                  <a:srgbClr val="2D2D2D"/>
+                </a:solidFill>
+                <a:latin typeface="Arial"/>
+              </a:defRPr>
+            </a:pPr>
+            <a:r>
+              <a:t>• IC significant at 24h</a:t>
+            </a:r>
+          </a:p>
+          <a:p>
+            <a:pPr>
+              <a:spcBef>
+                <a:spcPts val="800"/>
+              </a:spcBef>
+              <a:spcAft>
+                <a:spcPts val="800"/>
+              </a:spcAft>
+              <a:defRPr sz="1400">
+                <a:solidFill>
+                  <a:srgbClr val="2D2D2D"/>
+                </a:solidFill>
+                <a:latin typeface="Arial"/>
+              </a:defRPr>
+            </a:pPr>
+            <a:r>
+              <a:t>• OOS positive (40-60% degradation)</a:t>
+            </a:r>
+          </a:p>
+          <a:p>
+            <a:pPr>
+              <a:spcBef>
+                <a:spcPts val="800"/>
+              </a:spcBef>
+              <a:spcAft>
+                <a:spcPts val="800"/>
+              </a:spcAft>
+              <a:defRPr sz="1400">
+                <a:solidFill>
+                  <a:srgbClr val="2D2D2D"/>
+                </a:solidFill>
+                <a:latin typeface="Arial"/>
+              </a:defRPr>
+            </a:pPr>
+            <a:r>
+              <a:t>• Cross-asset validated</a:t>
+            </a:r>
+          </a:p>
+        </p:txBody>
+      </p:sp>
+      <p:sp>
+        <p:nvSpPr>
+          <p:cNvPr id="7" name="TextBox 6"/>
           <p:cNvSpPr txBox="1"/>
           <p:nvPr/>
         </p:nvSpPr>
         <p:spPr>
           <a:xfrm>
-            <a:off x="5943600" y="1645920"/>
-            <a:ext cx="5486400" cy="2286000"/>
+            <a:off x="4389120" y="1097280"/>
+            <a:ext cx="4572000" cy="365760"/>
           </a:xfrm>
           <a:prstGeom prst="rect">
             <a:avLst/>
@@ -4714,112 +4860,30 @@
           </a:bodyPr>
           <a:lstStyle/>
           <a:p>
-            <a:pPr>
-              <a:spcBef>
-                <a:spcPts val="400"/>
-              </a:spcBef>
-              <a:spcAft>
-                <a:spcPts val="400"/>
-              </a:spcAft>
-              <a:defRPr sz="1600">
-                <a:solidFill>
-                  <a:srgbClr val="333333"/>
-                </a:solidFill>
-                <a:latin typeface="Arial"/>
-              </a:defRPr>
-            </a:pPr>
-            <a:r>
-              <a:t>Calmar Ratio: ~0.11</a:t>
-            </a:r>
-          </a:p>
-          <a:p>
-            <a:pPr>
-              <a:spcBef>
-                <a:spcPts val="400"/>
-              </a:spcBef>
-              <a:spcAft>
-                <a:spcPts val="400"/>
-              </a:spcAft>
-              <a:defRPr sz="1600">
-                <a:solidFill>
-                  <a:srgbClr val="333333"/>
-                </a:solidFill>
-                <a:latin typeface="Arial"/>
-              </a:defRPr>
-            </a:pPr>
-            <a:r>
-              <a:t>Sharpe Ratio: ~0.77</a:t>
-            </a:r>
-          </a:p>
-          <a:p>
-            <a:pPr>
-              <a:spcBef>
-                <a:spcPts val="400"/>
-              </a:spcBef>
-              <a:spcAft>
-                <a:spcPts val="400"/>
-              </a:spcAft>
-              <a:defRPr sz="1600">
-                <a:solidFill>
-                  <a:srgbClr val="333333"/>
-                </a:solidFill>
-                <a:latin typeface="Arial"/>
-              </a:defRPr>
-            </a:pPr>
-            <a:r>
-              <a:t>Max Drawdown: ~14%</a:t>
-            </a:r>
-          </a:p>
-          <a:p>
-            <a:pPr>
-              <a:spcBef>
-                <a:spcPts val="400"/>
-              </a:spcBef>
-              <a:spcAft>
-                <a:spcPts val="400"/>
-              </a:spcAft>
-              <a:defRPr sz="1600">
-                <a:solidFill>
-                  <a:srgbClr val="333333"/>
-                </a:solidFill>
-                <a:latin typeface="Arial"/>
-              </a:defRPr>
-            </a:pPr>
-            <a:r>
-              <a:t>Win Rate: ~54%</a:t>
-            </a:r>
-          </a:p>
-          <a:p>
-            <a:pPr>
-              <a:spcBef>
-                <a:spcPts val="400"/>
-              </a:spcBef>
-              <a:spcAft>
-                <a:spcPts val="400"/>
-              </a:spcAft>
-              <a:defRPr sz="1600">
-                <a:solidFill>
-                  <a:srgbClr val="333333"/>
-                </a:solidFill>
-                <a:latin typeface="Arial"/>
-              </a:defRPr>
-            </a:pPr>
-            <a:r>
-              <a:t>Total Trades: ~125 (2020-2024)</a:t>
-            </a:r>
-          </a:p>
-        </p:txBody>
-      </p:sp>
-      <p:sp>
-        <p:nvSpPr>
-          <p:cNvPr id="9" name="TextBox 8"/>
+            <a:pPr algn="l">
+              <a:defRPr sz="1800" b="1">
+                <a:solidFill>
+                  <a:srgbClr val="4B2E83"/>
+                </a:solidFill>
+                <a:latin typeface="Arial"/>
+              </a:defRPr>
+            </a:pPr>
+            <a:r>
+              <a:t>Backtest Results</a:t>
+            </a:r>
+          </a:p>
+        </p:txBody>
+      </p:sp>
+      <p:sp>
+        <p:nvSpPr>
+          <p:cNvPr id="8" name="TextBox 7"/>
           <p:cNvSpPr txBox="1"/>
           <p:nvPr/>
         </p:nvSpPr>
         <p:spPr>
           <a:xfrm>
-            <a:off x="457200" y="4114800"/>
-            <a:ext cx="10972800" cy="457200"/>
+            <a:off x="4389120" y="1508760"/>
+            <a:ext cx="3200400" cy="2560320"/>
           </a:xfrm>
           <a:prstGeom prst="rect">
             <a:avLst/>
@@ -4832,30 +4896,112 @@
           </a:bodyPr>
           <a:lstStyle/>
           <a:p>
-            <a:pPr algn="l">
-              <a:defRPr sz="2000" b="1">
-                <a:solidFill>
-                  <a:srgbClr val="4B2E83"/>
-                </a:solidFill>
-                <a:latin typeface="Arial"/>
-              </a:defRPr>
-            </a:pPr>
-            <a:r>
-              <a:t>Risks &amp; Limitations</a:t>
-            </a:r>
-          </a:p>
-        </p:txBody>
-      </p:sp>
-      <p:sp>
-        <p:nvSpPr>
-          <p:cNvPr id="10" name="TextBox 9"/>
+            <a:pPr>
+              <a:spcBef>
+                <a:spcPts val="800"/>
+              </a:spcBef>
+              <a:spcAft>
+                <a:spcPts val="800"/>
+              </a:spcAft>
+              <a:defRPr sz="1400">
+                <a:solidFill>
+                  <a:srgbClr val="2D2D2D"/>
+                </a:solidFill>
+                <a:latin typeface="Arial"/>
+              </a:defRPr>
+            </a:pPr>
+            <a:r>
+              <a:t>• Calmar: ~0.11</a:t>
+            </a:r>
+          </a:p>
+          <a:p>
+            <a:pPr>
+              <a:spcBef>
+                <a:spcPts val="800"/>
+              </a:spcBef>
+              <a:spcAft>
+                <a:spcPts val="800"/>
+              </a:spcAft>
+              <a:defRPr sz="1400">
+                <a:solidFill>
+                  <a:srgbClr val="2D2D2D"/>
+                </a:solidFill>
+                <a:latin typeface="Arial"/>
+              </a:defRPr>
+            </a:pPr>
+            <a:r>
+              <a:t>• Sharpe: ~0.77</a:t>
+            </a:r>
+          </a:p>
+          <a:p>
+            <a:pPr>
+              <a:spcBef>
+                <a:spcPts val="800"/>
+              </a:spcBef>
+              <a:spcAft>
+                <a:spcPts val="800"/>
+              </a:spcAft>
+              <a:defRPr sz="1400">
+                <a:solidFill>
+                  <a:srgbClr val="2D2D2D"/>
+                </a:solidFill>
+                <a:latin typeface="Arial"/>
+              </a:defRPr>
+            </a:pPr>
+            <a:r>
+              <a:t>• Max DD: ~14%</a:t>
+            </a:r>
+          </a:p>
+          <a:p>
+            <a:pPr>
+              <a:spcBef>
+                <a:spcPts val="800"/>
+              </a:spcBef>
+              <a:spcAft>
+                <a:spcPts val="800"/>
+              </a:spcAft>
+              <a:defRPr sz="1400">
+                <a:solidFill>
+                  <a:srgbClr val="2D2D2D"/>
+                </a:solidFill>
+                <a:latin typeface="Arial"/>
+              </a:defRPr>
+            </a:pPr>
+            <a:r>
+              <a:t>• Win Rate: ~54%</a:t>
+            </a:r>
+          </a:p>
+          <a:p>
+            <a:pPr>
+              <a:spcBef>
+                <a:spcPts val="800"/>
+              </a:spcBef>
+              <a:spcAft>
+                <a:spcPts val="800"/>
+              </a:spcAft>
+              <a:defRPr sz="1400">
+                <a:solidFill>
+                  <a:srgbClr val="2D2D2D"/>
+                </a:solidFill>
+                <a:latin typeface="Arial"/>
+              </a:defRPr>
+            </a:pPr>
+            <a:r>
+              <a:t>• Trades: ~125</a:t>
+            </a:r>
+          </a:p>
+        </p:txBody>
+      </p:sp>
+      <p:sp>
+        <p:nvSpPr>
+          <p:cNvPr id="9" name="TextBox 8"/>
           <p:cNvSpPr txBox="1"/>
           <p:nvPr/>
         </p:nvSpPr>
         <p:spPr>
           <a:xfrm>
-            <a:off x="457200" y="4572000"/>
-            <a:ext cx="10972800" cy="1371600"/>
+            <a:off x="8046720" y="1097280"/>
+            <a:ext cx="4572000" cy="365760"/>
           </a:xfrm>
           <a:prstGeom prst="rect">
             <a:avLst/>
@@ -4868,79 +5014,250 @@
           </a:bodyPr>
           <a:lstStyle/>
           <a:p>
+            <a:pPr algn="l">
+              <a:defRPr sz="1800" b="1">
+                <a:solidFill>
+                  <a:srgbClr val="4B2E83"/>
+                </a:solidFill>
+                <a:latin typeface="Arial"/>
+              </a:defRPr>
+            </a:pPr>
+            <a:r>
+              <a:t>Hypothesis Results</a:t>
+            </a:r>
+          </a:p>
+        </p:txBody>
+      </p:sp>
+      <p:sp>
+        <p:nvSpPr>
+          <p:cNvPr id="10" name="TextBox 9"/>
+          <p:cNvSpPr txBox="1"/>
+          <p:nvPr/>
+        </p:nvSpPr>
+        <p:spPr>
+          <a:xfrm>
+            <a:off x="8046720" y="1508760"/>
+            <a:ext cx="3657600" cy="2011680"/>
+          </a:xfrm>
+          <a:prstGeom prst="rect">
+            <a:avLst/>
+          </a:prstGeom>
+          <a:noFill/>
+        </p:spPr>
+        <p:txBody>
+          <a:bodyPr wrap="square">
+            <a:spAutoFit/>
+          </a:bodyPr>
+          <a:lstStyle/>
+          <a:p>
             <a:pPr>
               <a:spcBef>
-                <a:spcPts val="400"/>
+                <a:spcPts val="800"/>
               </a:spcBef>
               <a:spcAft>
-                <a:spcPts val="400"/>
+                <a:spcPts val="800"/>
               </a:spcAft>
-              <a:defRPr sz="1600">
-                <a:solidFill>
-                  <a:srgbClr val="333333"/>
-                </a:solidFill>
-                <a:latin typeface="Arial"/>
-              </a:defRPr>
-            </a:pPr>
-            <a:r>
-              <a:t>Tail events: LUNA-style collapse where funding stays extreme</a:t>
+              <a:defRPr sz="1400">
+                <a:solidFill>
+                  <a:srgbClr val="2D2D2D"/>
+                </a:solidFill>
+                <a:latin typeface="Arial"/>
+              </a:defRPr>
+            </a:pPr>
+            <a:r>
+              <a:t>• H1: ✓ Supported</a:t>
             </a:r>
           </a:p>
           <a:p>
             <a:pPr>
               <a:spcBef>
-                <a:spcPts val="400"/>
+                <a:spcPts val="800"/>
               </a:spcBef>
               <a:spcAft>
-                <a:spcPts val="400"/>
+                <a:spcPts val="800"/>
               </a:spcAft>
-              <a:defRPr sz="1600">
-                <a:solidFill>
-                  <a:srgbClr val="333333"/>
-                </a:solidFill>
-                <a:latin typeface="Arial"/>
-              </a:defRPr>
-            </a:pPr>
-            <a:r>
-              <a:t>Regime dependence: better in high-volatility periods</a:t>
+              <a:defRPr sz="1400">
+                <a:solidFill>
+                  <a:srgbClr val="2D2D2D"/>
+                </a:solidFill>
+                <a:latin typeface="Arial"/>
+              </a:defRPr>
+            </a:pPr>
+            <a:r>
+              <a:t>• H2: ~ Mixed</a:t>
             </a:r>
           </a:p>
           <a:p>
             <a:pPr>
               <a:spcBef>
-                <a:spcPts val="400"/>
+                <a:spcPts val="800"/>
               </a:spcBef>
               <a:spcAft>
-                <a:spcPts val="400"/>
+                <a:spcPts val="800"/>
               </a:spcAft>
-              <a:defRPr sz="1600">
-                <a:solidFill>
-                  <a:srgbClr val="333333"/>
-                </a:solidFill>
-                <a:latin typeface="Arial"/>
-              </a:defRPr>
-            </a:pPr>
-            <a:r>
-              <a:t>Market structure change post-FTX may reduce future effectiveness</a:t>
+              <a:defRPr sz="1400">
+                <a:solidFill>
+                  <a:srgbClr val="2D2D2D"/>
+                </a:solidFill>
+                <a:latin typeface="Arial"/>
+              </a:defRPr>
+            </a:pPr>
+            <a:r>
+              <a:t>• H3: ✓ Supported</a:t>
             </a:r>
           </a:p>
           <a:p>
             <a:pPr>
               <a:spcBef>
-                <a:spcPts val="400"/>
+                <a:spcPts val="800"/>
               </a:spcBef>
               <a:spcAft>
-                <a:spcPts val="400"/>
+                <a:spcPts val="800"/>
               </a:spcAft>
-              <a:defRPr sz="1600">
-                <a:solidFill>
-                  <a:srgbClr val="333333"/>
-                </a:solidFill>
-                <a:latin typeface="Arial"/>
-              </a:defRPr>
-            </a:pPr>
-            <a:r>
-              <a:t>Crowding risk if strategy becomes widely known</a:t>
+              <a:defRPr sz="1400">
+                <a:solidFill>
+                  <a:srgbClr val="2D2D2D"/>
+                </a:solidFill>
+                <a:latin typeface="Arial"/>
+              </a:defRPr>
+            </a:pPr>
+            <a:r>
+              <a:t>• H4: ~ Partial</a:t>
+            </a:r>
+          </a:p>
+        </p:txBody>
+      </p:sp>
+      <p:sp>
+        <p:nvSpPr>
+          <p:cNvPr id="11" name="TextBox 10"/>
+          <p:cNvSpPr txBox="1"/>
+          <p:nvPr/>
+        </p:nvSpPr>
+        <p:spPr>
+          <a:xfrm>
+            <a:off x="457200" y="4206240"/>
+            <a:ext cx="4572000" cy="365760"/>
+          </a:xfrm>
+          <a:prstGeom prst="rect">
+            <a:avLst/>
+          </a:prstGeom>
+          <a:noFill/>
+        </p:spPr>
+        <p:txBody>
+          <a:bodyPr wrap="square">
+            <a:spAutoFit/>
+          </a:bodyPr>
+          <a:lstStyle/>
+          <a:p>
+            <a:pPr algn="l">
+              <a:defRPr sz="1800" b="1">
+                <a:solidFill>
+                  <a:srgbClr val="4B2E83"/>
+                </a:solidFill>
+                <a:latin typeface="Arial"/>
+              </a:defRPr>
+            </a:pPr>
+            <a:r>
+              <a:t>Risks &amp; Limitations</a:t>
+            </a:r>
+          </a:p>
+        </p:txBody>
+      </p:sp>
+      <p:sp>
+        <p:nvSpPr>
+          <p:cNvPr id="12" name="TextBox 11"/>
+          <p:cNvSpPr txBox="1"/>
+          <p:nvPr/>
+        </p:nvSpPr>
+        <p:spPr>
+          <a:xfrm>
+            <a:off x="457200" y="4617720"/>
+            <a:ext cx="10972800" cy="1645920"/>
+          </a:xfrm>
+          <a:prstGeom prst="rect">
+            <a:avLst/>
+          </a:prstGeom>
+          <a:noFill/>
+        </p:spPr>
+        <p:txBody>
+          <a:bodyPr wrap="square">
+            <a:spAutoFit/>
+          </a:bodyPr>
+          <a:lstStyle/>
+          <a:p>
+            <a:pPr>
+              <a:spcBef>
+                <a:spcPts val="800"/>
+              </a:spcBef>
+              <a:spcAft>
+                <a:spcPts val="800"/>
+              </a:spcAft>
+              <a:defRPr sz="1400">
+                <a:solidFill>
+                  <a:srgbClr val="2D2D2D"/>
+                </a:solidFill>
+                <a:latin typeface="Arial"/>
+              </a:defRPr>
+            </a:pPr>
+            <a:r>
+              <a:t>• Tail events: LUNA-style collapse where funding stays extreme for extended periods</a:t>
+            </a:r>
+          </a:p>
+          <a:p>
+            <a:pPr>
+              <a:spcBef>
+                <a:spcPts val="800"/>
+              </a:spcBef>
+              <a:spcAft>
+                <a:spcPts val="800"/>
+              </a:spcAft>
+              <a:defRPr sz="1400">
+                <a:solidFill>
+                  <a:srgbClr val="2D2D2D"/>
+                </a:solidFill>
+                <a:latin typeface="Arial"/>
+              </a:defRPr>
+            </a:pPr>
+            <a:r>
+              <a:t>• Regime dependence: strategy performs better in high-volatility periods</a:t>
+            </a:r>
+          </a:p>
+          <a:p>
+            <a:pPr>
+              <a:spcBef>
+                <a:spcPts val="800"/>
+              </a:spcBef>
+              <a:spcAft>
+                <a:spcPts val="800"/>
+              </a:spcAft>
+              <a:defRPr sz="1400">
+                <a:solidFill>
+                  <a:srgbClr val="2D2D2D"/>
+                </a:solidFill>
+                <a:latin typeface="Arial"/>
+              </a:defRPr>
+            </a:pPr>
+            <a:r>
+              <a:t>• Market structure shift: post-FTX changes may reduce future effectiveness</a:t>
+            </a:r>
+          </a:p>
+          <a:p>
+            <a:pPr>
+              <a:spcBef>
+                <a:spcPts val="800"/>
+              </a:spcBef>
+              <a:spcAft>
+                <a:spcPts val="800"/>
+              </a:spcAft>
+              <a:defRPr sz="1400">
+                <a:solidFill>
+                  <a:srgbClr val="2D2D2D"/>
+                </a:solidFill>
+                <a:latin typeface="Arial"/>
+              </a:defRPr>
+            </a:pPr>
+            <a:r>
+              <a:t>• Crowding risk: if strategy becomes widely known, edge may disappear</a:t>
             </a:r>
           </a:p>
         </p:txBody>
@@ -4980,7 +5297,7 @@
         <p:spPr>
           <a:xfrm>
             <a:off x="0" y="0"/>
-            <a:ext cx="12191695" cy="914400"/>
+            <a:ext cx="12191695" cy="822960"/>
           </a:xfrm>
           <a:prstGeom prst="rect">
             <a:avLst/>
@@ -5016,50 +5333,14 @@
       </p:sp>
       <p:sp>
         <p:nvSpPr>
-          <p:cNvPr id="3" name="TextBox 2"/>
-          <p:cNvSpPr txBox="1"/>
-          <p:nvPr/>
-        </p:nvSpPr>
-        <p:spPr>
-          <a:xfrm>
-            <a:off x="457200" y="228600"/>
-            <a:ext cx="10972800" cy="548640"/>
-          </a:xfrm>
-          <a:prstGeom prst="rect">
-            <a:avLst/>
-          </a:prstGeom>
-          <a:noFill/>
-        </p:spPr>
-        <p:txBody>
-          <a:bodyPr wrap="none">
-            <a:spAutoFit/>
-          </a:bodyPr>
-          <a:lstStyle/>
-          <a:p>
-            <a:pPr>
-              <a:defRPr sz="2600" b="1">
-                <a:solidFill>
-                  <a:srgbClr val="FFFFFF"/>
-                </a:solidFill>
-                <a:latin typeface="Arial"/>
-              </a:defRPr>
-            </a:pPr>
-            <a:r>
-              <a:t>References</a:t>
-            </a:r>
-          </a:p>
-        </p:txBody>
-      </p:sp>
-      <p:sp>
-        <p:nvSpPr>
-          <p:cNvPr id="4" name="Rectangle 3"/>
+          <p:cNvPr id="3" name="Rectangle 2"/>
           <p:cNvSpPr/>
           <p:nvPr/>
         </p:nvSpPr>
         <p:spPr>
           <a:xfrm>
-            <a:off x="0" y="914400"/>
-            <a:ext cx="12191695" cy="36576"/>
+            <a:off x="0" y="822960"/>
+            <a:ext cx="12191695" cy="32004"/>
           </a:xfrm>
           <a:prstGeom prst="rect">
             <a:avLst/>
@@ -5095,14 +5376,14 @@
       </p:sp>
       <p:sp>
         <p:nvSpPr>
-          <p:cNvPr id="5" name="TextBox 4"/>
+          <p:cNvPr id="4" name="TextBox 3"/>
           <p:cNvSpPr txBox="1"/>
           <p:nvPr/>
         </p:nvSpPr>
         <p:spPr>
           <a:xfrm>
-            <a:off x="457200" y="1371600"/>
-            <a:ext cx="10972800" cy="5029200"/>
+            <a:off x="457200" y="201168"/>
+            <a:ext cx="10972800" cy="502920"/>
           </a:xfrm>
           <a:prstGeom prst="rect">
             <a:avLst/>
@@ -5115,16 +5396,46 @@
           </a:bodyPr>
           <a:lstStyle/>
           <a:p>
+            <a:pPr algn="l">
+              <a:defRPr sz="2800" b="1">
+                <a:solidFill>
+                  <a:srgbClr val="FFFFFF"/>
+                </a:solidFill>
+                <a:latin typeface="Arial"/>
+              </a:defRPr>
+            </a:pPr>
+            <a:r>
+              <a:t>References</a:t>
+            </a:r>
+          </a:p>
+        </p:txBody>
+      </p:sp>
+      <p:sp>
+        <p:nvSpPr>
+          <p:cNvPr id="5" name="TextBox 4"/>
+          <p:cNvSpPr txBox="1"/>
+          <p:nvPr/>
+        </p:nvSpPr>
+        <p:spPr>
+          <a:xfrm>
+            <a:off x="457200" y="1188720"/>
+            <a:ext cx="10972800" cy="5029200"/>
+          </a:xfrm>
+          <a:prstGeom prst="rect">
+            <a:avLst/>
+          </a:prstGeom>
+          <a:noFill/>
+        </p:spPr>
+        <p:txBody>
+          <a:bodyPr wrap="square">
+            <a:spAutoFit/>
+          </a:bodyPr>
+          <a:lstStyle/>
+          <a:p>
             <a:pPr>
-              <a:spcBef>
-                <a:spcPts val="400"/>
-              </a:spcBef>
-              <a:spcAft>
-                <a:spcPts val="400"/>
-              </a:spcAft>
-              <a:defRPr sz="1500">
-                <a:solidFill>
-                  <a:srgbClr val="333333"/>
+              <a:defRPr sz="1400">
+                <a:solidFill>
+                  <a:srgbClr val="2D2D2D"/>
                 </a:solidFill>
                 <a:latin typeface="Arial"/>
               </a:defRPr>
@@ -5135,34 +5446,22 @@
           </a:p>
           <a:p>
             <a:pPr>
-              <a:spcBef>
-                <a:spcPts val="400"/>
-              </a:spcBef>
-              <a:spcAft>
-                <a:spcPts val="400"/>
-              </a:spcAft>
-              <a:defRPr sz="1500">
-                <a:solidFill>
-                  <a:srgbClr val="333333"/>
-                </a:solidFill>
-                <a:latin typeface="Arial"/>
-              </a:defRPr>
-            </a:pPr>
-            <a:r>
-              <a:t>       Journal of Portfolio Management, 40(5), 94-107.</a:t>
+              <a:defRPr sz="1400">
+                <a:solidFill>
+                  <a:srgbClr val="2D2D2D"/>
+                </a:solidFill>
+                <a:latin typeface="Arial"/>
+              </a:defRPr>
+            </a:pPr>
+            <a:r>
+              <a:t>    Journal of Portfolio Management, 40(5), 94-107.</a:t>
             </a:r>
           </a:p>
           <a:p>
             <a:pPr>
-              <a:spcBef>
-                <a:spcPts val="400"/>
-              </a:spcBef>
-              <a:spcAft>
-                <a:spcPts val="400"/>
-              </a:spcAft>
-              <a:defRPr sz="1500">
-                <a:solidFill>
-                  <a:srgbClr val="333333"/>
+              <a:defRPr sz="1400">
+                <a:solidFill>
+                  <a:srgbClr val="2D2D2D"/>
                 </a:solidFill>
                 <a:latin typeface="Arial"/>
               </a:defRPr>
@@ -5170,15 +5469,9 @@
           </a:p>
           <a:p>
             <a:pPr>
-              <a:spcBef>
-                <a:spcPts val="400"/>
-              </a:spcBef>
-              <a:spcAft>
-                <a:spcPts val="400"/>
-              </a:spcAft>
-              <a:defRPr sz="1500">
-                <a:solidFill>
-                  <a:srgbClr val="333333"/>
+              <a:defRPr sz="1400">
+                <a:solidFill>
+                  <a:srgbClr val="2D2D2D"/>
                 </a:solidFill>
                 <a:latin typeface="Arial"/>
               </a:defRPr>
@@ -5189,34 +5482,22 @@
           </a:p>
           <a:p>
             <a:pPr>
-              <a:spcBef>
-                <a:spcPts val="400"/>
-              </a:spcBef>
-              <a:spcAft>
-                <a:spcPts val="400"/>
-              </a:spcAft>
-              <a:defRPr sz="1500">
-                <a:solidFill>
-                  <a:srgbClr val="333333"/>
-                </a:solidFill>
-                <a:latin typeface="Arial"/>
-              </a:defRPr>
-            </a:pPr>
-            <a:r>
-              <a:t>       Review of Financial Studies, 22(6), 2201-2238.</a:t>
+              <a:defRPr sz="1400">
+                <a:solidFill>
+                  <a:srgbClr val="2D2D2D"/>
+                </a:solidFill>
+                <a:latin typeface="Arial"/>
+              </a:defRPr>
+            </a:pPr>
+            <a:r>
+              <a:t>    Review of Financial Studies, 22(6), 2201-2238.</a:t>
             </a:r>
           </a:p>
           <a:p>
             <a:pPr>
-              <a:spcBef>
-                <a:spcPts val="400"/>
-              </a:spcBef>
-              <a:spcAft>
-                <a:spcPts val="400"/>
-              </a:spcAft>
-              <a:defRPr sz="1500">
-                <a:solidFill>
-                  <a:srgbClr val="333333"/>
+              <a:defRPr sz="1400">
+                <a:solidFill>
+                  <a:srgbClr val="2D2D2D"/>
                 </a:solidFill>
                 <a:latin typeface="Arial"/>
               </a:defRPr>
@@ -5224,53 +5505,35 @@
           </a:p>
           <a:p>
             <a:pPr>
-              <a:spcBef>
-                <a:spcPts val="400"/>
-              </a:spcBef>
-              <a:spcAft>
-                <a:spcPts val="400"/>
-              </a:spcAft>
-              <a:defRPr sz="1500">
-                <a:solidFill>
-                  <a:srgbClr val="333333"/>
-                </a:solidFill>
-                <a:latin typeface="Arial"/>
-              </a:defRPr>
-            </a:pPr>
-            <a:r>
-              <a:t>Pardo, R. (2008). The Evaluation and Optimization of Trading Strategies.</a:t>
+              <a:defRPr sz="1400">
+                <a:solidFill>
+                  <a:srgbClr val="2D2D2D"/>
+                </a:solidFill>
+                <a:latin typeface="Arial"/>
+              </a:defRPr>
+            </a:pPr>
+            <a:r>
+              <a:t>Liu, Y., Tsyvinski, A., &amp; Wu, X. (2022). Common Risk Factors in Cryptocurrency.</a:t>
             </a:r>
           </a:p>
           <a:p>
             <a:pPr>
-              <a:spcBef>
-                <a:spcPts val="400"/>
-              </a:spcBef>
-              <a:spcAft>
-                <a:spcPts val="400"/>
-              </a:spcAft>
-              <a:defRPr sz="1500">
-                <a:solidFill>
-                  <a:srgbClr val="333333"/>
-                </a:solidFill>
-                <a:latin typeface="Arial"/>
-              </a:defRPr>
-            </a:pPr>
-            <a:r>
-              <a:t>       John Wiley &amp; Sons.</a:t>
+              <a:defRPr sz="1400">
+                <a:solidFill>
+                  <a:srgbClr val="2D2D2D"/>
+                </a:solidFill>
+                <a:latin typeface="Arial"/>
+              </a:defRPr>
+            </a:pPr>
+            <a:r>
+              <a:t>    Journal of Finance, 77(2), 1133-1177.</a:t>
             </a:r>
           </a:p>
           <a:p>
             <a:pPr>
-              <a:spcBef>
-                <a:spcPts val="400"/>
-              </a:spcBef>
-              <a:spcAft>
-                <a:spcPts val="400"/>
-              </a:spcAft>
-              <a:defRPr sz="1500">
-                <a:solidFill>
-                  <a:srgbClr val="333333"/>
+              <a:defRPr sz="1400">
+                <a:solidFill>
+                  <a:srgbClr val="2D2D2D"/>
                 </a:solidFill>
                 <a:latin typeface="Arial"/>
               </a:defRPr>
@@ -5278,15 +5541,32 @@
           </a:p>
           <a:p>
             <a:pPr>
-              <a:spcBef>
-                <a:spcPts val="400"/>
-              </a:spcBef>
-              <a:spcAft>
-                <a:spcPts val="400"/>
-              </a:spcAft>
-              <a:defRPr sz="1500">
-                <a:solidFill>
-                  <a:srgbClr val="333333"/>
+              <a:defRPr sz="1400">
+                <a:solidFill>
+                  <a:srgbClr val="2D2D2D"/>
+                </a:solidFill>
+                <a:latin typeface="Arial"/>
+              </a:defRPr>
+            </a:pPr>
+            <a:r>
+              <a:t>Pardo, R. (2008). The Evaluation and Optimization of Trading Strategies. Wiley.</a:t>
+            </a:r>
+          </a:p>
+          <a:p>
+            <a:pPr>
+              <a:defRPr sz="1400">
+                <a:solidFill>
+                  <a:srgbClr val="2D2D2D"/>
+                </a:solidFill>
+                <a:latin typeface="Arial"/>
+              </a:defRPr>
+            </a:pPr>
+          </a:p>
+          <a:p>
+            <a:pPr>
+              <a:defRPr sz="1400">
+                <a:solidFill>
+                  <a:srgbClr val="2D2D2D"/>
                 </a:solidFill>
                 <a:latin typeface="Arial"/>
               </a:defRPr>
@@ -5297,75 +5577,15 @@
           </a:p>
           <a:p>
             <a:pPr>
-              <a:spcBef>
-                <a:spcPts val="400"/>
-              </a:spcBef>
-              <a:spcAft>
-                <a:spcPts val="400"/>
-              </a:spcAft>
-              <a:defRPr sz="1500">
-                <a:solidFill>
-                  <a:srgbClr val="333333"/>
-                </a:solidFill>
-                <a:latin typeface="Arial"/>
-              </a:defRPr>
-            </a:pPr>
-            <a:r>
-              <a:t>       Journal of Finance, 52(1), 35-55.</a:t>
-            </a:r>
-          </a:p>
-          <a:p>
-            <a:pPr>
-              <a:spcBef>
-                <a:spcPts val="400"/>
-              </a:spcBef>
-              <a:spcAft>
-                <a:spcPts val="400"/>
-              </a:spcAft>
-              <a:defRPr sz="1500">
-                <a:solidFill>
-                  <a:srgbClr val="333333"/>
-                </a:solidFill>
-                <a:latin typeface="Arial"/>
-              </a:defRPr>
-            </a:pPr>
-          </a:p>
-          <a:p>
-            <a:pPr>
-              <a:spcBef>
-                <a:spcPts val="400"/>
-              </a:spcBef>
-              <a:spcAft>
-                <a:spcPts val="400"/>
-              </a:spcAft>
-              <a:defRPr sz="1500">
-                <a:solidFill>
-                  <a:srgbClr val="333333"/>
-                </a:solidFill>
-                <a:latin typeface="Arial"/>
-              </a:defRPr>
-            </a:pPr>
-            <a:r>
-              <a:t>Liu, Y., Tsyvinski, A., &amp; Wu, X. (2022). Common Risk Factors in Cryptocurrency.</a:t>
-            </a:r>
-          </a:p>
-          <a:p>
-            <a:pPr>
-              <a:spcBef>
-                <a:spcPts val="400"/>
-              </a:spcBef>
-              <a:spcAft>
-                <a:spcPts val="400"/>
-              </a:spcAft>
-              <a:defRPr sz="1500">
-                <a:solidFill>
-                  <a:srgbClr val="333333"/>
-                </a:solidFill>
-                <a:latin typeface="Arial"/>
-              </a:defRPr>
-            </a:pPr>
-            <a:r>
-              <a:t>       Journal of Finance, 77(2), 1133-1177.</a:t>
+              <a:defRPr sz="1400">
+                <a:solidFill>
+                  <a:srgbClr val="2D2D2D"/>
+                </a:solidFill>
+                <a:latin typeface="Arial"/>
+              </a:defRPr>
+            </a:pPr>
+            <a:r>
+              <a:t>    Journal of Finance, 52(1), 35-55.</a:t>
             </a:r>
           </a:p>
         </p:txBody>
@@ -5405,7 +5625,7 @@
         <p:spPr>
           <a:xfrm>
             <a:off x="0" y="0"/>
-            <a:ext cx="12191695" cy="914400"/>
+            <a:ext cx="12191695" cy="822960"/>
           </a:xfrm>
           <a:prstGeom prst="rect">
             <a:avLst/>
@@ -5441,50 +5661,14 @@
       </p:sp>
       <p:sp>
         <p:nvSpPr>
-          <p:cNvPr id="3" name="TextBox 2"/>
-          <p:cNvSpPr txBox="1"/>
-          <p:nvPr/>
-        </p:nvSpPr>
-        <p:spPr>
-          <a:xfrm>
-            <a:off x="457200" y="228600"/>
-            <a:ext cx="10972800" cy="548640"/>
-          </a:xfrm>
-          <a:prstGeom prst="rect">
-            <a:avLst/>
-          </a:prstGeom>
-          <a:noFill/>
-        </p:spPr>
-        <p:txBody>
-          <a:bodyPr wrap="none">
-            <a:spAutoFit/>
-          </a:bodyPr>
-          <a:lstStyle/>
-          <a:p>
-            <a:pPr>
-              <a:defRPr sz="2600" b="1">
-                <a:solidFill>
-                  <a:srgbClr val="FFFFFF"/>
-                </a:solidFill>
-                <a:latin typeface="Arial"/>
-              </a:defRPr>
-            </a:pPr>
-            <a:r>
-              <a:t>Problem &amp; Hypothesis</a:t>
-            </a:r>
-          </a:p>
-        </p:txBody>
-      </p:sp>
-      <p:sp>
-        <p:nvSpPr>
-          <p:cNvPr id="4" name="Rectangle 3"/>
+          <p:cNvPr id="3" name="Rectangle 2"/>
           <p:cNvSpPr/>
           <p:nvPr/>
         </p:nvSpPr>
         <p:spPr>
           <a:xfrm>
-            <a:off x="0" y="914400"/>
-            <a:ext cx="12191695" cy="36576"/>
+            <a:off x="0" y="822960"/>
+            <a:ext cx="12191695" cy="32004"/>
           </a:xfrm>
           <a:prstGeom prst="rect">
             <a:avLst/>
@@ -5520,14 +5704,14 @@
       </p:sp>
       <p:sp>
         <p:nvSpPr>
-          <p:cNvPr id="5" name="TextBox 4"/>
+          <p:cNvPr id="4" name="TextBox 3"/>
           <p:cNvSpPr txBox="1"/>
           <p:nvPr/>
         </p:nvSpPr>
         <p:spPr>
           <a:xfrm>
-            <a:off x="457200" y="1188720"/>
-            <a:ext cx="4572000" cy="457200"/>
+            <a:off x="457200" y="201168"/>
+            <a:ext cx="10972800" cy="502920"/>
           </a:xfrm>
           <a:prstGeom prst="rect">
             <a:avLst/>
@@ -5541,29 +5725,29 @@
           <a:lstStyle/>
           <a:p>
             <a:pPr algn="l">
-              <a:defRPr sz="2000" b="1">
-                <a:solidFill>
-                  <a:srgbClr val="4B2E83"/>
-                </a:solidFill>
-                <a:latin typeface="Arial"/>
-              </a:defRPr>
-            </a:pPr>
-            <a:r>
-              <a:t>Economic Mechanism</a:t>
-            </a:r>
-          </a:p>
-        </p:txBody>
-      </p:sp>
-      <p:sp>
-        <p:nvSpPr>
-          <p:cNvPr id="6" name="TextBox 5"/>
+              <a:defRPr sz="2800" b="1">
+                <a:solidFill>
+                  <a:srgbClr val="FFFFFF"/>
+                </a:solidFill>
+                <a:latin typeface="Arial"/>
+              </a:defRPr>
+            </a:pPr>
+            <a:r>
+              <a:t>Problem &amp; Hypothesis</a:t>
+            </a:r>
+          </a:p>
+        </p:txBody>
+      </p:sp>
+      <p:sp>
+        <p:nvSpPr>
+          <p:cNvPr id="5" name="TextBox 4"/>
           <p:cNvSpPr txBox="1"/>
           <p:nvPr/>
         </p:nvSpPr>
         <p:spPr>
           <a:xfrm>
-            <a:off x="457200" y="1645920"/>
-            <a:ext cx="5029200" cy="2286000"/>
+            <a:off x="457200" y="1097280"/>
+            <a:ext cx="4572000" cy="365760"/>
           </a:xfrm>
           <a:prstGeom prst="rect">
             <a:avLst/>
@@ -5576,112 +5760,30 @@
           </a:bodyPr>
           <a:lstStyle/>
           <a:p>
-            <a:pPr>
-              <a:spcBef>
-                <a:spcPts val="400"/>
-              </a:spcBef>
-              <a:spcAft>
-                <a:spcPts val="400"/>
-              </a:spcAft>
-              <a:defRPr sz="1600">
-                <a:solidFill>
-                  <a:srgbClr val="333333"/>
-                </a:solidFill>
-                <a:latin typeface="Arial"/>
-              </a:defRPr>
-            </a:pPr>
-            <a:r>
-              <a:t>Perpetual futures: funding paid every 8h</a:t>
-            </a:r>
-          </a:p>
-          <a:p>
-            <a:pPr>
-              <a:spcBef>
-                <a:spcPts val="400"/>
-              </a:spcBef>
-              <a:spcAft>
-                <a:spcPts val="400"/>
-              </a:spcAft>
-              <a:defRPr sz="1600">
-                <a:solidFill>
-                  <a:srgbClr val="333333"/>
-                </a:solidFill>
-                <a:latin typeface="Arial"/>
-              </a:defRPr>
-            </a:pPr>
-            <a:r>
-              <a:t>0.01% baseline ≈ 13% annualized</a:t>
-            </a:r>
-          </a:p>
-          <a:p>
-            <a:pPr>
-              <a:spcBef>
-                <a:spcPts val="400"/>
-              </a:spcBef>
-              <a:spcAft>
-                <a:spcPts val="400"/>
-              </a:spcAft>
-              <a:defRPr sz="1600">
-                <a:solidFill>
-                  <a:srgbClr val="333333"/>
-                </a:solidFill>
-                <a:latin typeface="Arial"/>
-              </a:defRPr>
-            </a:pPr>
-            <a:r>
-              <a:t>Extreme funding (0.05%+) → 65%+ annualized</a:t>
-            </a:r>
-          </a:p>
-          <a:p>
-            <a:pPr>
-              <a:spcBef>
-                <a:spcPts val="400"/>
-              </a:spcBef>
-              <a:spcAft>
-                <a:spcPts val="400"/>
-              </a:spcAft>
-              <a:defRPr sz="1600">
-                <a:solidFill>
-                  <a:srgbClr val="333333"/>
-                </a:solidFill>
-                <a:latin typeface="Arial"/>
-              </a:defRPr>
-            </a:pPr>
-            <a:r>
-              <a:t>Crowded longs exit → price decline</a:t>
-            </a:r>
-          </a:p>
-          <a:p>
-            <a:pPr>
-              <a:spcBef>
-                <a:spcPts val="400"/>
-              </a:spcBef>
-              <a:spcAft>
-                <a:spcPts val="400"/>
-              </a:spcAft>
-              <a:defRPr sz="1600">
-                <a:solidFill>
-                  <a:srgbClr val="333333"/>
-                </a:solidFill>
-                <a:latin typeface="Arial"/>
-              </a:defRPr>
-            </a:pPr>
-            <a:r>
-              <a:t>Brunnermeier &amp; Pedersen (2009): funding liquidity spiral</a:t>
-            </a:r>
-          </a:p>
-        </p:txBody>
-      </p:sp>
-      <p:sp>
-        <p:nvSpPr>
-          <p:cNvPr id="7" name="TextBox 6"/>
+            <a:pPr algn="l">
+              <a:defRPr sz="1800" b="1">
+                <a:solidFill>
+                  <a:srgbClr val="4B2E83"/>
+                </a:solidFill>
+                <a:latin typeface="Arial"/>
+              </a:defRPr>
+            </a:pPr>
+            <a:r>
+              <a:t>Economic Mechanism</a:t>
+            </a:r>
+          </a:p>
+        </p:txBody>
+      </p:sp>
+      <p:sp>
+        <p:nvSpPr>
+          <p:cNvPr id="6" name="TextBox 5"/>
           <p:cNvSpPr txBox="1"/>
           <p:nvPr/>
         </p:nvSpPr>
         <p:spPr>
           <a:xfrm>
-            <a:off x="5943600" y="1188720"/>
-            <a:ext cx="5486400" cy="457200"/>
+            <a:off x="457200" y="1508760"/>
+            <a:ext cx="5303520" cy="2560320"/>
           </a:xfrm>
           <a:prstGeom prst="rect">
             <a:avLst/>
@@ -5694,30 +5796,112 @@
           </a:bodyPr>
           <a:lstStyle/>
           <a:p>
-            <a:pPr algn="l">
-              <a:defRPr sz="2000" b="1">
-                <a:solidFill>
-                  <a:srgbClr val="4B2E83"/>
-                </a:solidFill>
-                <a:latin typeface="Arial"/>
-              </a:defRPr>
-            </a:pPr>
-            <a:r>
-              <a:t>Pre-committed Hypotheses</a:t>
-            </a:r>
-          </a:p>
-        </p:txBody>
-      </p:sp>
-      <p:sp>
-        <p:nvSpPr>
-          <p:cNvPr id="8" name="TextBox 7"/>
+            <a:pPr>
+              <a:spcBef>
+                <a:spcPts val="800"/>
+              </a:spcBef>
+              <a:spcAft>
+                <a:spcPts val="800"/>
+              </a:spcAft>
+              <a:defRPr sz="1500">
+                <a:solidFill>
+                  <a:srgbClr val="2D2D2D"/>
+                </a:solidFill>
+                <a:latin typeface="Arial"/>
+              </a:defRPr>
+            </a:pPr>
+            <a:r>
+              <a:t>• Perpetual futures: funding paid every 8 hours</a:t>
+            </a:r>
+          </a:p>
+          <a:p>
+            <a:pPr>
+              <a:spcBef>
+                <a:spcPts val="800"/>
+              </a:spcBef>
+              <a:spcAft>
+                <a:spcPts val="800"/>
+              </a:spcAft>
+              <a:defRPr sz="1500">
+                <a:solidFill>
+                  <a:srgbClr val="2D2D2D"/>
+                </a:solidFill>
+                <a:latin typeface="Arial"/>
+              </a:defRPr>
+            </a:pPr>
+            <a:r>
+              <a:t>• Baseline 0.01% ≈ 13% annualized cost</a:t>
+            </a:r>
+          </a:p>
+          <a:p>
+            <a:pPr>
+              <a:spcBef>
+                <a:spcPts val="800"/>
+              </a:spcBef>
+              <a:spcAft>
+                <a:spcPts val="800"/>
+              </a:spcAft>
+              <a:defRPr sz="1500">
+                <a:solidFill>
+                  <a:srgbClr val="2D2D2D"/>
+                </a:solidFill>
+                <a:latin typeface="Arial"/>
+              </a:defRPr>
+            </a:pPr>
+            <a:r>
+              <a:t>• Extreme 0.05%+ → 65%+ annualized</a:t>
+            </a:r>
+          </a:p>
+          <a:p>
+            <a:pPr>
+              <a:spcBef>
+                <a:spcPts val="800"/>
+              </a:spcBef>
+              <a:spcAft>
+                <a:spcPts val="800"/>
+              </a:spcAft>
+              <a:defRPr sz="1500">
+                <a:solidFill>
+                  <a:srgbClr val="2D2D2D"/>
+                </a:solidFill>
+                <a:latin typeface="Arial"/>
+              </a:defRPr>
+            </a:pPr>
+            <a:r>
+              <a:t>• Crowded longs forced to exit → price drops</a:t>
+            </a:r>
+          </a:p>
+          <a:p>
+            <a:pPr>
+              <a:spcBef>
+                <a:spcPts val="800"/>
+              </a:spcBef>
+              <a:spcAft>
+                <a:spcPts val="800"/>
+              </a:spcAft>
+              <a:defRPr sz="1500">
+                <a:solidFill>
+                  <a:srgbClr val="2D2D2D"/>
+                </a:solidFill>
+                <a:latin typeface="Arial"/>
+              </a:defRPr>
+            </a:pPr>
+            <a:r>
+              <a:t>• Brunnermeier &amp; Pedersen (2009): liquidity spiral</a:t>
+            </a:r>
+          </a:p>
+        </p:txBody>
+      </p:sp>
+      <p:sp>
+        <p:nvSpPr>
+          <p:cNvPr id="7" name="TextBox 6"/>
           <p:cNvSpPr txBox="1"/>
           <p:nvPr/>
         </p:nvSpPr>
         <p:spPr>
           <a:xfrm>
-            <a:off x="5943600" y="1645920"/>
-            <a:ext cx="5486400" cy="1828800"/>
+            <a:off x="6217920" y="1097280"/>
+            <a:ext cx="4572000" cy="365760"/>
           </a:xfrm>
           <a:prstGeom prst="rect">
             <a:avLst/>
@@ -5730,79 +5914,115 @@
           </a:bodyPr>
           <a:lstStyle/>
           <a:p>
+            <a:pPr algn="l">
+              <a:defRPr sz="1800" b="1">
+                <a:solidFill>
+                  <a:srgbClr val="4B2E83"/>
+                </a:solidFill>
+                <a:latin typeface="Arial"/>
+              </a:defRPr>
+            </a:pPr>
+            <a:r>
+              <a:t>Pre-committed Hypotheses</a:t>
+            </a:r>
+          </a:p>
+        </p:txBody>
+      </p:sp>
+      <p:sp>
+        <p:nvSpPr>
+          <p:cNvPr id="8" name="TextBox 7"/>
+          <p:cNvSpPr txBox="1"/>
+          <p:nvPr/>
+        </p:nvSpPr>
+        <p:spPr>
+          <a:xfrm>
+            <a:off x="6217920" y="1508760"/>
+            <a:ext cx="5486400" cy="2011680"/>
+          </a:xfrm>
+          <a:prstGeom prst="rect">
+            <a:avLst/>
+          </a:prstGeom>
+          <a:noFill/>
+        </p:spPr>
+        <p:txBody>
+          <a:bodyPr wrap="square">
+            <a:spAutoFit/>
+          </a:bodyPr>
+          <a:lstStyle/>
+          <a:p>
             <a:pPr>
               <a:spcBef>
-                <a:spcPts val="400"/>
+                <a:spcPts val="800"/>
               </a:spcBef>
               <a:spcAft>
-                <a:spcPts val="400"/>
+                <a:spcPts val="800"/>
               </a:spcAft>
-              <a:defRPr sz="1600">
-                <a:solidFill>
-                  <a:srgbClr val="333333"/>
-                </a:solidFill>
-                <a:latin typeface="Arial"/>
-              </a:defRPr>
-            </a:pPr>
-            <a:r>
-              <a:t>H1: Extreme z-score → 24h reversal (IC &gt; 0.02)</a:t>
+              <a:defRPr sz="1500">
+                <a:solidFill>
+                  <a:srgbClr val="2D2D2D"/>
+                </a:solidFill>
+                <a:latin typeface="Arial"/>
+              </a:defRPr>
+            </a:pPr>
+            <a:r>
+              <a:t>• H1: |z-score| &gt; 1.5 predicts 24h reversal</a:t>
             </a:r>
           </a:p>
           <a:p>
             <a:pPr>
               <a:spcBef>
-                <a:spcPts val="400"/>
+                <a:spcPts val="800"/>
               </a:spcBef>
               <a:spcAft>
-                <a:spcPts val="400"/>
+                <a:spcPts val="800"/>
               </a:spcAft>
-              <a:defRPr sz="1600">
-                <a:solidFill>
-                  <a:srgbClr val="333333"/>
-                </a:solidFill>
-                <a:latin typeface="Arial"/>
-              </a:defRPr>
-            </a:pPr>
-            <a:r>
-              <a:t>H2: High OI amplifies signal</a:t>
+              <a:defRPr sz="1500">
+                <a:solidFill>
+                  <a:srgbClr val="2D2D2D"/>
+                </a:solidFill>
+                <a:latin typeface="Arial"/>
+              </a:defRPr>
+            </a:pPr>
+            <a:r>
+              <a:t>• H2: High OI change amplifies signal</a:t>
             </a:r>
           </a:p>
           <a:p>
             <a:pPr>
               <a:spcBef>
-                <a:spcPts val="400"/>
+                <a:spcPts val="800"/>
               </a:spcBef>
               <a:spcAft>
-                <a:spcPts val="400"/>
+                <a:spcPts val="800"/>
               </a:spcAft>
-              <a:defRPr sz="1600">
-                <a:solidFill>
-                  <a:srgbClr val="333333"/>
-                </a:solidFill>
-                <a:latin typeface="Arial"/>
-              </a:defRPr>
-            </a:pPr>
-            <a:r>
-              <a:t>H3: Optimal threshold is non-linear</a:t>
+              <a:defRPr sz="1500">
+                <a:solidFill>
+                  <a:srgbClr val="2D2D2D"/>
+                </a:solidFill>
+                <a:latin typeface="Arial"/>
+              </a:defRPr>
+            </a:pPr>
+            <a:r>
+              <a:t>• H3: Threshold-Calmar is non-monotonic</a:t>
             </a:r>
           </a:p>
           <a:p>
             <a:pPr>
               <a:spcBef>
-                <a:spcPts val="400"/>
+                <a:spcPts val="800"/>
               </a:spcBef>
               <a:spcAft>
-                <a:spcPts val="400"/>
+                <a:spcPts val="800"/>
               </a:spcAft>
-              <a:defRPr sz="1600">
-                <a:solidFill>
-                  <a:srgbClr val="333333"/>
-                </a:solidFill>
-                <a:latin typeface="Arial"/>
-              </a:defRPr>
-            </a:pPr>
-            <a:r>
-              <a:t>H4: OOS Calmar positive (WF ratio &gt; 0.5)</a:t>
+              <a:defRPr sz="1500">
+                <a:solidFill>
+                  <a:srgbClr val="2D2D2D"/>
+                </a:solidFill>
+                <a:latin typeface="Arial"/>
+              </a:defRPr>
+            </a:pPr>
+            <a:r>
+              <a:t>• H4: WF ratio &gt; 0.5 (OOS positive)</a:t>
             </a:r>
           </a:p>
         </p:txBody>
@@ -5815,8 +6035,8 @@
         </p:nvSpPr>
         <p:spPr>
           <a:xfrm>
-            <a:off x="457200" y="4114800"/>
-            <a:ext cx="10972800" cy="914400"/>
+            <a:off x="457200" y="4206240"/>
+            <a:ext cx="11247120" cy="822960"/>
           </a:xfrm>
           <a:prstGeom prst="roundRect">
             <a:avLst/>
@@ -5858,8 +6078,8 @@
         </p:nvSpPr>
         <p:spPr>
           <a:xfrm>
-            <a:off x="731520" y="4297680"/>
-            <a:ext cx="10058400" cy="640080"/>
+            <a:off x="731520" y="4389120"/>
+            <a:ext cx="10515600" cy="457200"/>
           </a:xfrm>
           <a:prstGeom prst="rect">
             <a:avLst/>
@@ -5872,7 +6092,7 @@
           </a:bodyPr>
           <a:lstStyle/>
           <a:p>
-            <a:pPr algn="l">
+            <a:pPr algn="ctr">
               <a:defRPr sz="2000" b="1">
                 <a:solidFill>
                   <a:srgbClr val="4B2E83"/>
@@ -5881,7 +6101,7 @@
               </a:defRPr>
             </a:pPr>
             <a:r>
-              <a:t>Strategy: Short when z &gt; threshold, Long when z &lt; -threshold</a:t>
+              <a:t>Strategy: Short when z &gt; threshold  |  Long when z &lt; -threshold</a:t>
             </a:r>
           </a:p>
         </p:txBody>
@@ -5895,7 +6115,7 @@
         <p:spPr>
           <a:xfrm>
             <a:off x="457200" y="5303520"/>
-            <a:ext cx="10972800" cy="457200"/>
+            <a:ext cx="4572000" cy="365760"/>
           </a:xfrm>
           <a:prstGeom prst="rect">
             <a:avLst/>
@@ -5917,7 +6137,7 @@
               </a:defRPr>
             </a:pPr>
             <a:r>
-              <a:t>Objective: Calmar Ratio (not Sharpe)</a:t>
+              <a:t>Objective: Calmar Ratio</a:t>
             </a:r>
           </a:p>
         </p:txBody>
@@ -5930,7 +6150,7 @@
         </p:nvSpPr>
         <p:spPr>
           <a:xfrm>
-            <a:off x="457200" y="5760720"/>
+            <a:off x="457200" y="5669280"/>
             <a:ext cx="10972800" cy="457200"/>
           </a:xfrm>
           <a:prstGeom prst="rect">
@@ -5944,22 +6164,16 @@
           </a:bodyPr>
           <a:lstStyle/>
           <a:p>
-            <a:pPr>
-              <a:spcBef>
-                <a:spcPts val="400"/>
-              </a:spcBef>
-              <a:spcAft>
-                <a:spcPts val="400"/>
-              </a:spcAft>
-              <a:defRPr sz="1500">
-                <a:solidFill>
-                  <a:srgbClr val="333333"/>
-                </a:solidFill>
-                <a:latin typeface="Arial"/>
-              </a:defRPr>
-            </a:pPr>
-            <a:r>
-              <a:t>BTC returns: excess kurtosis &gt; 20 → Sharpe assumes normality, inappropriate here</a:t>
+            <a:pPr algn="l">
+              <a:defRPr sz="1400" b="0">
+                <a:solidFill>
+                  <a:srgbClr val="666666"/>
+                </a:solidFill>
+                <a:latin typeface="Arial"/>
+              </a:defRPr>
+            </a:pPr>
+            <a:r>
+              <a:t>BTC has excess kurtosis &gt; 20 — Sharpe assumes normality, Calmar penalizes max drawdown directly</a:t>
             </a:r>
           </a:p>
         </p:txBody>
@@ -5999,7 +6213,7 @@
         <p:spPr>
           <a:xfrm>
             <a:off x="0" y="0"/>
-            <a:ext cx="12191695" cy="914400"/>
+            <a:ext cx="12191695" cy="822960"/>
           </a:xfrm>
           <a:prstGeom prst="rect">
             <a:avLst/>
@@ -6035,50 +6249,14 @@
       </p:sp>
       <p:sp>
         <p:nvSpPr>
-          <p:cNvPr id="3" name="TextBox 2"/>
-          <p:cNvSpPr txBox="1"/>
-          <p:nvPr/>
-        </p:nvSpPr>
-        <p:spPr>
-          <a:xfrm>
-            <a:off x="457200" y="228600"/>
-            <a:ext cx="10972800" cy="548640"/>
-          </a:xfrm>
-          <a:prstGeom prst="rect">
-            <a:avLst/>
-          </a:prstGeom>
-          <a:noFill/>
-        </p:spPr>
-        <p:txBody>
-          <a:bodyPr wrap="none">
-            <a:spAutoFit/>
-          </a:bodyPr>
-          <a:lstStyle/>
-          <a:p>
-            <a:pPr>
-              <a:defRPr sz="2600" b="1">
-                <a:solidFill>
-                  <a:srgbClr val="FFFFFF"/>
-                </a:solidFill>
-                <a:latin typeface="Arial"/>
-              </a:defRPr>
-            </a:pPr>
-            <a:r>
-              <a:t>Data: Funding Rate Distribution</a:t>
-            </a:r>
-          </a:p>
-        </p:txBody>
-      </p:sp>
-      <p:sp>
-        <p:nvSpPr>
-          <p:cNvPr id="4" name="Rectangle 3"/>
+          <p:cNvPr id="3" name="Rectangle 2"/>
           <p:cNvSpPr/>
           <p:nvPr/>
         </p:nvSpPr>
         <p:spPr>
           <a:xfrm>
-            <a:off x="0" y="914400"/>
-            <a:ext cx="12191695" cy="36576"/>
+            <a:off x="0" y="822960"/>
+            <a:ext cx="12191695" cy="32004"/>
           </a:xfrm>
           <a:prstGeom prst="rect">
             <a:avLst/>
@@ -6109,6 +6287,42 @@
           <a:lstStyle/>
           <a:p>
             <a:pPr algn="ctr"/>
+          </a:p>
+        </p:txBody>
+      </p:sp>
+      <p:sp>
+        <p:nvSpPr>
+          <p:cNvPr id="4" name="TextBox 3"/>
+          <p:cNvSpPr txBox="1"/>
+          <p:nvPr/>
+        </p:nvSpPr>
+        <p:spPr>
+          <a:xfrm>
+            <a:off x="457200" y="201168"/>
+            <a:ext cx="10972800" cy="502920"/>
+          </a:xfrm>
+          <a:prstGeom prst="rect">
+            <a:avLst/>
+          </a:prstGeom>
+          <a:noFill/>
+        </p:spPr>
+        <p:txBody>
+          <a:bodyPr wrap="square">
+            <a:spAutoFit/>
+          </a:bodyPr>
+          <a:lstStyle/>
+          <a:p>
+            <a:pPr algn="l">
+              <a:defRPr sz="2800" b="1">
+                <a:solidFill>
+                  <a:srgbClr val="FFFFFF"/>
+                </a:solidFill>
+                <a:latin typeface="Arial"/>
+              </a:defRPr>
+            </a:pPr>
+            <a:r>
+              <a:t>Data: Funding Rate Distribution</a:t>
+            </a:r>
           </a:p>
         </p:txBody>
       </p:sp>
@@ -6128,8 +6342,8 @@
         </p:blipFill>
         <p:spPr>
           <a:xfrm>
-            <a:off x="274320" y="1188720"/>
-            <a:ext cx="11612880" cy="3044721"/>
+            <a:off x="365760" y="1051560"/>
+            <a:ext cx="11430000" cy="2996773"/>
           </a:xfrm>
           <a:prstGeom prst="rect">
             <a:avLst/>
@@ -6144,8 +6358,8 @@
         </p:nvSpPr>
         <p:spPr>
           <a:xfrm>
-            <a:off x="457200" y="6217920"/>
-            <a:ext cx="10972800" cy="457200"/>
+            <a:off x="457200" y="6309360"/>
+            <a:ext cx="11247120" cy="365760"/>
           </a:xfrm>
           <a:prstGeom prst="rect">
             <a:avLst/>
@@ -6158,22 +6372,16 @@
           </a:bodyPr>
           <a:lstStyle/>
           <a:p>
-            <a:pPr>
-              <a:spcBef>
-                <a:spcPts val="400"/>
-              </a:spcBef>
-              <a:spcAft>
-                <a:spcPts val="400"/>
-              </a:spcAft>
-              <a:defRPr sz="1400">
-                <a:solidFill>
-                  <a:srgbClr val="333333"/>
-                </a:solidFill>
-                <a:latin typeface="Arial"/>
-              </a:defRPr>
-            </a:pPr>
-            <a:r>
-              <a:t>Heavy tails (kurtosis &gt; 10) • Slight positive skew (longs dominate) • NOT normally distributed</a:t>
+            <a:pPr algn="ctr">
+              <a:defRPr sz="1300" b="0">
+                <a:solidFill>
+                  <a:srgbClr val="666666"/>
+                </a:solidFill>
+                <a:latin typeface="Arial"/>
+              </a:defRPr>
+            </a:pPr>
+            <a:r>
+              <a:t>Heavy tails (kurtosis &gt; 10)  •  Positive skew (longs dominate)  •  Non-normal → justifies Calmar over Sharpe</a:t>
             </a:r>
           </a:p>
         </p:txBody>
@@ -6213,7 +6421,7 @@
         <p:spPr>
           <a:xfrm>
             <a:off x="0" y="0"/>
-            <a:ext cx="12191695" cy="914400"/>
+            <a:ext cx="12191695" cy="822960"/>
           </a:xfrm>
           <a:prstGeom prst="rect">
             <a:avLst/>
@@ -6249,50 +6457,14 @@
       </p:sp>
       <p:sp>
         <p:nvSpPr>
-          <p:cNvPr id="3" name="TextBox 2"/>
-          <p:cNvSpPr txBox="1"/>
-          <p:nvPr/>
-        </p:nvSpPr>
-        <p:spPr>
-          <a:xfrm>
-            <a:off x="457200" y="228600"/>
-            <a:ext cx="10972800" cy="548640"/>
-          </a:xfrm>
-          <a:prstGeom prst="rect">
-            <a:avLst/>
-          </a:prstGeom>
-          <a:noFill/>
-        </p:spPr>
-        <p:txBody>
-          <a:bodyPr wrap="none">
-            <a:spAutoFit/>
-          </a:bodyPr>
-          <a:lstStyle/>
-          <a:p>
-            <a:pPr>
-              <a:defRPr sz="2600" b="1">
-                <a:solidFill>
-                  <a:srgbClr val="FFFFFF"/>
-                </a:solidFill>
-                <a:latin typeface="Arial"/>
-              </a:defRPr>
-            </a:pPr>
-            <a:r>
-              <a:t>Data: Autocorrelation &amp; Seasonality</a:t>
-            </a:r>
-          </a:p>
-        </p:txBody>
-      </p:sp>
-      <p:sp>
-        <p:nvSpPr>
-          <p:cNvPr id="4" name="Rectangle 3"/>
+          <p:cNvPr id="3" name="Rectangle 2"/>
           <p:cNvSpPr/>
           <p:nvPr/>
         </p:nvSpPr>
         <p:spPr>
           <a:xfrm>
-            <a:off x="0" y="914400"/>
-            <a:ext cx="12191695" cy="36576"/>
+            <a:off x="0" y="822960"/>
+            <a:ext cx="12191695" cy="32004"/>
           </a:xfrm>
           <a:prstGeom prst="rect">
             <a:avLst/>
@@ -6323,6 +6495,42 @@
           <a:lstStyle/>
           <a:p>
             <a:pPr algn="ctr"/>
+          </a:p>
+        </p:txBody>
+      </p:sp>
+      <p:sp>
+        <p:nvSpPr>
+          <p:cNvPr id="4" name="TextBox 3"/>
+          <p:cNvSpPr txBox="1"/>
+          <p:nvPr/>
+        </p:nvSpPr>
+        <p:spPr>
+          <a:xfrm>
+            <a:off x="457200" y="201168"/>
+            <a:ext cx="10972800" cy="502920"/>
+          </a:xfrm>
+          <a:prstGeom prst="rect">
+            <a:avLst/>
+          </a:prstGeom>
+          <a:noFill/>
+        </p:spPr>
+        <p:txBody>
+          <a:bodyPr wrap="square">
+            <a:spAutoFit/>
+          </a:bodyPr>
+          <a:lstStyle/>
+          <a:p>
+            <a:pPr algn="l">
+              <a:defRPr sz="2800" b="1">
+                <a:solidFill>
+                  <a:srgbClr val="FFFFFF"/>
+                </a:solidFill>
+                <a:latin typeface="Arial"/>
+              </a:defRPr>
+            </a:pPr>
+            <a:r>
+              <a:t>Data: Autocorrelation &amp; Seasonality</a:t>
+            </a:r>
           </a:p>
         </p:txBody>
       </p:sp>
@@ -6342,8 +6550,8 @@
         </p:blipFill>
         <p:spPr>
           <a:xfrm>
-            <a:off x="182880" y="1097280"/>
-            <a:ext cx="5852160" cy="1642958"/>
+            <a:off x="274320" y="1005840"/>
+            <a:ext cx="5760720" cy="1617287"/>
           </a:xfrm>
           <a:prstGeom prst="rect">
             <a:avLst/>
@@ -6366,8 +6574,8 @@
         </p:blipFill>
         <p:spPr>
           <a:xfrm>
-            <a:off x="6126480" y="1097280"/>
-            <a:ext cx="5852160" cy="1769258"/>
+            <a:off x="6126480" y="1005840"/>
+            <a:ext cx="5760720" cy="1741613"/>
           </a:xfrm>
           <a:prstGeom prst="rect">
             <a:avLst/>
@@ -6382,8 +6590,8 @@
         </p:nvSpPr>
         <p:spPr>
           <a:xfrm>
-            <a:off x="457200" y="5029200"/>
-            <a:ext cx="10972800" cy="914400"/>
+            <a:off x="457200" y="5120640"/>
+            <a:ext cx="11247120" cy="365760"/>
           </a:xfrm>
           <a:prstGeom prst="rect">
             <a:avLst/>
@@ -6396,41 +6604,16 @@
           </a:bodyPr>
           <a:lstStyle/>
           <a:p>
-            <a:pPr>
-              <a:spcBef>
-                <a:spcPts val="400"/>
-              </a:spcBef>
-              <a:spcAft>
-                <a:spcPts val="400"/>
-              </a:spcAft>
-              <a:defRPr sz="1500">
-                <a:solidFill>
-                  <a:srgbClr val="333333"/>
-                </a:solidFill>
-                <a:latin typeface="Arial"/>
-              </a:defRPr>
-            </a:pPr>
-            <a:r>
-              <a:t>Left: ACF significant at lags 1-3 → short-term persistence, then decay (mean reversion)</a:t>
-            </a:r>
-          </a:p>
-          <a:p>
-            <a:pPr>
-              <a:spcBef>
-                <a:spcPts val="400"/>
-              </a:spcBef>
-              <a:spcAft>
-                <a:spcPts val="400"/>
-              </a:spcAft>
-              <a:defRPr sz="1500">
-                <a:solidFill>
-                  <a:srgbClr val="333333"/>
-                </a:solidFill>
-                <a:latin typeface="Arial"/>
-              </a:defRPr>
-            </a:pPr>
-            <a:r>
-              <a:t>Right: No strong weekday effect — funding driven by market sentiment, not calendar</a:t>
+            <a:pPr algn="ctr">
+              <a:defRPr sz="1300" b="0">
+                <a:solidFill>
+                  <a:srgbClr val="666666"/>
+                </a:solidFill>
+                <a:latin typeface="Arial"/>
+              </a:defRPr>
+            </a:pPr>
+            <a:r>
+              <a:t>ACF decays after lag 3 → supports mean reversion  •  No weekday effect → sentiment-driven, not calendar</a:t>
             </a:r>
           </a:p>
         </p:txBody>
@@ -6470,7 +6653,7 @@
         <p:spPr>
           <a:xfrm>
             <a:off x="0" y="0"/>
-            <a:ext cx="12191695" cy="914400"/>
+            <a:ext cx="12191695" cy="822960"/>
           </a:xfrm>
           <a:prstGeom prst="rect">
             <a:avLst/>
@@ -6506,50 +6689,14 @@
       </p:sp>
       <p:sp>
         <p:nvSpPr>
-          <p:cNvPr id="3" name="TextBox 2"/>
-          <p:cNvSpPr txBox="1"/>
-          <p:nvPr/>
-        </p:nvSpPr>
-        <p:spPr>
-          <a:xfrm>
-            <a:off x="457200" y="228600"/>
-            <a:ext cx="10972800" cy="548640"/>
-          </a:xfrm>
-          <a:prstGeom prst="rect">
-            <a:avLst/>
-          </a:prstGeom>
-          <a:noFill/>
-        </p:spPr>
-        <p:txBody>
-          <a:bodyPr wrap="none">
-            <a:spAutoFit/>
-          </a:bodyPr>
-          <a:lstStyle/>
-          <a:p>
-            <a:pPr>
-              <a:defRPr sz="2600" b="1">
-                <a:solidFill>
-                  <a:srgbClr val="FFFFFF"/>
-                </a:solidFill>
-                <a:latin typeface="Arial"/>
-              </a:defRPr>
-            </a:pPr>
-            <a:r>
-              <a:t>Data: BTC Price &amp; Funding Rate (2020-2024)</a:t>
-            </a:r>
-          </a:p>
-        </p:txBody>
-      </p:sp>
-      <p:sp>
-        <p:nvSpPr>
-          <p:cNvPr id="4" name="Rectangle 3"/>
+          <p:cNvPr id="3" name="Rectangle 2"/>
           <p:cNvSpPr/>
           <p:nvPr/>
         </p:nvSpPr>
         <p:spPr>
           <a:xfrm>
-            <a:off x="0" y="914400"/>
-            <a:ext cx="12191695" cy="36576"/>
+            <a:off x="0" y="822960"/>
+            <a:ext cx="12191695" cy="32004"/>
           </a:xfrm>
           <a:prstGeom prst="rect">
             <a:avLst/>
@@ -6580,6 +6727,42 @@
           <a:lstStyle/>
           <a:p>
             <a:pPr algn="ctr"/>
+          </a:p>
+        </p:txBody>
+      </p:sp>
+      <p:sp>
+        <p:nvSpPr>
+          <p:cNvPr id="4" name="TextBox 3"/>
+          <p:cNvSpPr txBox="1"/>
+          <p:nvPr/>
+        </p:nvSpPr>
+        <p:spPr>
+          <a:xfrm>
+            <a:off x="457200" y="201168"/>
+            <a:ext cx="10972800" cy="502920"/>
+          </a:xfrm>
+          <a:prstGeom prst="rect">
+            <a:avLst/>
+          </a:prstGeom>
+          <a:noFill/>
+        </p:spPr>
+        <p:txBody>
+          <a:bodyPr wrap="square">
+            <a:spAutoFit/>
+          </a:bodyPr>
+          <a:lstStyle/>
+          <a:p>
+            <a:pPr algn="l">
+              <a:defRPr sz="2800" b="1">
+                <a:solidFill>
+                  <a:srgbClr val="FFFFFF"/>
+                </a:solidFill>
+                <a:latin typeface="Arial"/>
+              </a:defRPr>
+            </a:pPr>
+            <a:r>
+              <a:t>Data: BTC Price &amp; Funding Rate (2020-2024)</a:t>
+            </a:r>
           </a:p>
         </p:txBody>
       </p:sp>
@@ -6599,8 +6782,8 @@
         </p:blipFill>
         <p:spPr>
           <a:xfrm>
-            <a:off x="182880" y="1051560"/>
-            <a:ext cx="11795760" cy="3874712"/>
+            <a:off x="274320" y="960120"/>
+            <a:ext cx="11612880" cy="3814639"/>
           </a:xfrm>
           <a:prstGeom prst="rect">
             <a:avLst/>
@@ -6615,8 +6798,8 @@
         </p:nvSpPr>
         <p:spPr>
           <a:xfrm>
-            <a:off x="457200" y="6217920"/>
-            <a:ext cx="10972800" cy="457200"/>
+            <a:off x="457200" y="6309360"/>
+            <a:ext cx="11247120" cy="365760"/>
           </a:xfrm>
           <a:prstGeom prst="rect">
             <a:avLst/>
@@ -6629,22 +6812,16 @@
           </a:bodyPr>
           <a:lstStyle/>
           <a:p>
-            <a:pPr>
-              <a:spcBef>
-                <a:spcPts val="400"/>
-              </a:spcBef>
-              <a:spcAft>
-                <a:spcPts val="400"/>
-              </a:spcAft>
-              <a:defRPr sz="1400">
-                <a:solidFill>
-                  <a:srgbClr val="333333"/>
-                </a:solidFill>
-                <a:latin typeface="Arial"/>
-              </a:defRPr>
-            </a:pPr>
-            <a:r>
-              <a:t>Major events: March 2020 crash • May 2021 selloff • LUNA collapse (May 2022) • FTX collapse (Nov 2022)</a:t>
+            <a:pPr algn="ctr">
+              <a:defRPr sz="1300" b="0">
+                <a:solidFill>
+                  <a:srgbClr val="666666"/>
+                </a:solidFill>
+                <a:latin typeface="Arial"/>
+              </a:defRPr>
+            </a:pPr>
+            <a:r>
+              <a:t>Key events: March 2020 crash  •  May 2021 selloff  •  LUNA (May 2022)  •  FTX (Nov 2022)</a:t>
             </a:r>
           </a:p>
         </p:txBody>
@@ -6684,7 +6861,7 @@
         <p:spPr>
           <a:xfrm>
             <a:off x="0" y="0"/>
-            <a:ext cx="12191695" cy="914400"/>
+            <a:ext cx="12191695" cy="822960"/>
           </a:xfrm>
           <a:prstGeom prst="rect">
             <a:avLst/>
@@ -6720,50 +6897,14 @@
       </p:sp>
       <p:sp>
         <p:nvSpPr>
-          <p:cNvPr id="3" name="TextBox 2"/>
-          <p:cNvSpPr txBox="1"/>
-          <p:nvPr/>
-        </p:nvSpPr>
-        <p:spPr>
-          <a:xfrm>
-            <a:off x="457200" y="228600"/>
-            <a:ext cx="10972800" cy="548640"/>
-          </a:xfrm>
-          <a:prstGeom prst="rect">
-            <a:avLst/>
-          </a:prstGeom>
-          <a:noFill/>
-        </p:spPr>
-        <p:txBody>
-          <a:bodyPr wrap="none">
-            <a:spAutoFit/>
-          </a:bodyPr>
-          <a:lstStyle/>
-          <a:p>
-            <a:pPr>
-              <a:defRPr sz="2600" b="1">
-                <a:solidFill>
-                  <a:srgbClr val="FFFFFF"/>
-                </a:solidFill>
-                <a:latin typeface="Arial"/>
-              </a:defRPr>
-            </a:pPr>
-            <a:r>
-              <a:t>Indicator Testing: Information Coefficient</a:t>
-            </a:r>
-          </a:p>
-        </p:txBody>
-      </p:sp>
-      <p:sp>
-        <p:nvSpPr>
-          <p:cNvPr id="4" name="Rectangle 3"/>
+          <p:cNvPr id="3" name="Rectangle 2"/>
           <p:cNvSpPr/>
           <p:nvPr/>
         </p:nvSpPr>
         <p:spPr>
           <a:xfrm>
-            <a:off x="0" y="914400"/>
-            <a:ext cx="12191695" cy="36576"/>
+            <a:off x="0" y="822960"/>
+            <a:ext cx="12191695" cy="32004"/>
           </a:xfrm>
           <a:prstGeom prst="rect">
             <a:avLst/>
@@ -6794,6 +6935,42 @@
           <a:lstStyle/>
           <a:p>
             <a:pPr algn="ctr"/>
+          </a:p>
+        </p:txBody>
+      </p:sp>
+      <p:sp>
+        <p:nvSpPr>
+          <p:cNvPr id="4" name="TextBox 3"/>
+          <p:cNvSpPr txBox="1"/>
+          <p:nvPr/>
+        </p:nvSpPr>
+        <p:spPr>
+          <a:xfrm>
+            <a:off x="457200" y="201168"/>
+            <a:ext cx="10972800" cy="502920"/>
+          </a:xfrm>
+          <a:prstGeom prst="rect">
+            <a:avLst/>
+          </a:prstGeom>
+          <a:noFill/>
+        </p:spPr>
+        <p:txBody>
+          <a:bodyPr wrap="square">
+            <a:spAutoFit/>
+          </a:bodyPr>
+          <a:lstStyle/>
+          <a:p>
+            <a:pPr algn="l">
+              <a:defRPr sz="2800" b="1">
+                <a:solidFill>
+                  <a:srgbClr val="FFFFFF"/>
+                </a:solidFill>
+                <a:latin typeface="Arial"/>
+              </a:defRPr>
+            </a:pPr>
+            <a:r>
+              <a:t>Indicator Testing: Information Coefficient (IC)</a:t>
+            </a:r>
           </a:p>
         </p:txBody>
       </p:sp>
@@ -6813,8 +6990,8 @@
         </p:blipFill>
         <p:spPr>
           <a:xfrm>
-            <a:off x="182880" y="1051560"/>
-            <a:ext cx="11795760" cy="3087481"/>
+            <a:off x="274320" y="960120"/>
+            <a:ext cx="11612880" cy="3039613"/>
           </a:xfrm>
           <a:prstGeom prst="rect">
             <a:avLst/>
@@ -6829,8 +7006,8 @@
         </p:nvSpPr>
         <p:spPr>
           <a:xfrm>
-            <a:off x="457200" y="6217920"/>
-            <a:ext cx="10972800" cy="457200"/>
+            <a:off x="457200" y="6309360"/>
+            <a:ext cx="11247120" cy="365760"/>
           </a:xfrm>
           <a:prstGeom prst="rect">
             <a:avLst/>
@@ -6843,22 +7020,16 @@
           </a:bodyPr>
           <a:lstStyle/>
           <a:p>
-            <a:pPr>
-              <a:spcBef>
-                <a:spcPts val="400"/>
-              </a:spcBef>
-              <a:spcAft>
-                <a:spcPts val="400"/>
-              </a:spcAft>
-              <a:defRPr sz="1400">
-                <a:solidFill>
-                  <a:srgbClr val="333333"/>
-                </a:solidFill>
-                <a:latin typeface="Arial"/>
-              </a:defRPr>
-            </a:pPr>
-            <a:r>
-              <a:t>Negative slope: higher z-score → lower forward return • H1 SUPPORTED: IC statistically significant at 24h</a:t>
+            <a:pPr algn="ctr">
+              <a:defRPr sz="1300" b="0">
+                <a:solidFill>
+                  <a:srgbClr val="666666"/>
+                </a:solidFill>
+                <a:latin typeface="Arial"/>
+              </a:defRPr>
+            </a:pPr>
+            <a:r>
+              <a:t>Negative slope confirms contrarian hypothesis  •  H1 SUPPORTED: IC significant at 24h horizon (p &lt; 0.05)</a:t>
             </a:r>
           </a:p>
         </p:txBody>
@@ -6898,7 +7069,7 @@
         <p:spPr>
           <a:xfrm>
             <a:off x="0" y="0"/>
-            <a:ext cx="12191695" cy="914400"/>
+            <a:ext cx="12191695" cy="822960"/>
           </a:xfrm>
           <a:prstGeom prst="rect">
             <a:avLst/>
@@ -6934,50 +7105,14 @@
       </p:sp>
       <p:sp>
         <p:nvSpPr>
-          <p:cNvPr id="3" name="TextBox 2"/>
-          <p:cNvSpPr txBox="1"/>
-          <p:nvPr/>
-        </p:nvSpPr>
-        <p:spPr>
-          <a:xfrm>
-            <a:off x="457200" y="228600"/>
-            <a:ext cx="10972800" cy="548640"/>
-          </a:xfrm>
-          <a:prstGeom prst="rect">
-            <a:avLst/>
-          </a:prstGeom>
-          <a:noFill/>
-        </p:spPr>
-        <p:txBody>
-          <a:bodyPr wrap="none">
-            <a:spAutoFit/>
-          </a:bodyPr>
-          <a:lstStyle/>
-          <a:p>
-            <a:pPr>
-              <a:defRPr sz="2600" b="1">
-                <a:solidFill>
-                  <a:srgbClr val="FFFFFF"/>
-                </a:solidFill>
-                <a:latin typeface="Arial"/>
-              </a:defRPr>
-            </a:pPr>
-            <a:r>
-              <a:t>Signal Processing: Timeline (2021-2023)</a:t>
-            </a:r>
-          </a:p>
-        </p:txBody>
-      </p:sp>
-      <p:sp>
-        <p:nvSpPr>
-          <p:cNvPr id="4" name="Rectangle 3"/>
+          <p:cNvPr id="3" name="Rectangle 2"/>
           <p:cNvSpPr/>
           <p:nvPr/>
         </p:nvSpPr>
         <p:spPr>
           <a:xfrm>
-            <a:off x="0" y="914400"/>
-            <a:ext cx="12191695" cy="36576"/>
+            <a:off x="0" y="822960"/>
+            <a:ext cx="12191695" cy="32004"/>
           </a:xfrm>
           <a:prstGeom prst="rect">
             <a:avLst/>
@@ -7008,6 +7143,42 @@
           <a:lstStyle/>
           <a:p>
             <a:pPr algn="ctr"/>
+          </a:p>
+        </p:txBody>
+      </p:sp>
+      <p:sp>
+        <p:nvSpPr>
+          <p:cNvPr id="4" name="TextBox 3"/>
+          <p:cNvSpPr txBox="1"/>
+          <p:nvPr/>
+        </p:nvSpPr>
+        <p:spPr>
+          <a:xfrm>
+            <a:off x="457200" y="201168"/>
+            <a:ext cx="10972800" cy="502920"/>
+          </a:xfrm>
+          <a:prstGeom prst="rect">
+            <a:avLst/>
+          </a:prstGeom>
+          <a:noFill/>
+        </p:spPr>
+        <p:txBody>
+          <a:bodyPr wrap="square">
+            <a:spAutoFit/>
+          </a:bodyPr>
+          <a:lstStyle/>
+          <a:p>
+            <a:pPr algn="l">
+              <a:defRPr sz="2800" b="1">
+                <a:solidFill>
+                  <a:srgbClr val="FFFFFF"/>
+                </a:solidFill>
+                <a:latin typeface="Arial"/>
+              </a:defRPr>
+            </a:pPr>
+            <a:r>
+              <a:t>Signal Processing: Timeline (2021-2023)</a:t>
+            </a:r>
           </a:p>
         </p:txBody>
       </p:sp>
@@ -7027,8 +7198,8 @@
         </p:blipFill>
         <p:spPr>
           <a:xfrm>
-            <a:off x="182880" y="1005840"/>
-            <a:ext cx="11795760" cy="6254128"/>
+            <a:off x="274320" y="914400"/>
+            <a:ext cx="11612880" cy="6157165"/>
           </a:xfrm>
           <a:prstGeom prst="rect">
             <a:avLst/>
@@ -7043,8 +7214,8 @@
         </p:nvSpPr>
         <p:spPr>
           <a:xfrm>
-            <a:off x="457200" y="6217920"/>
-            <a:ext cx="10972800" cy="457200"/>
+            <a:off x="457200" y="6309360"/>
+            <a:ext cx="11247120" cy="365760"/>
           </a:xfrm>
           <a:prstGeom prst="rect">
             <a:avLst/>
@@ -7057,22 +7228,16 @@
           </a:bodyPr>
           <a:lstStyle/>
           <a:p>
-            <a:pPr>
-              <a:spcBef>
-                <a:spcPts val="400"/>
-              </a:spcBef>
-              <a:spcAft>
-                <a:spcPts val="400"/>
-              </a:spcAft>
-              <a:defRPr sz="1400">
-                <a:solidFill>
-                  <a:srgbClr val="333333"/>
-                </a:solidFill>
-                <a:latin typeface="Arial"/>
-              </a:defRPr>
-            </a:pPr>
-            <a:r>
-              <a:t>Green: Long signals (z &lt; -1.5) • Red: Short signals (z &gt; 1.5) • Signals cluster around extreme funding events</a:t>
+            <a:pPr algn="ctr">
+              <a:defRPr sz="1300" b="0">
+                <a:solidFill>
+                  <a:srgbClr val="666666"/>
+                </a:solidFill>
+                <a:latin typeface="Arial"/>
+              </a:defRPr>
+            </a:pPr>
+            <a:r>
+              <a:t>Green = Long (z &lt; -1.5)  •  Red = Short (z &gt; 1.5)  •  Signals cluster around extreme funding events</a:t>
             </a:r>
           </a:p>
         </p:txBody>
@@ -7112,7 +7277,7 @@
         <p:spPr>
           <a:xfrm>
             <a:off x="0" y="0"/>
-            <a:ext cx="12191695" cy="914400"/>
+            <a:ext cx="12191695" cy="822960"/>
           </a:xfrm>
           <a:prstGeom prst="rect">
             <a:avLst/>
@@ -7148,50 +7313,14 @@
       </p:sp>
       <p:sp>
         <p:nvSpPr>
-          <p:cNvPr id="3" name="TextBox 2"/>
-          <p:cNvSpPr txBox="1"/>
-          <p:nvPr/>
-        </p:nvSpPr>
-        <p:spPr>
-          <a:xfrm>
-            <a:off x="457200" y="228600"/>
-            <a:ext cx="10972800" cy="548640"/>
-          </a:xfrm>
-          <a:prstGeom prst="rect">
-            <a:avLst/>
-          </a:prstGeom>
-          <a:noFill/>
-        </p:spPr>
-        <p:txBody>
-          <a:bodyPr wrap="none">
-            <a:spAutoFit/>
-          </a:bodyPr>
-          <a:lstStyle/>
-          <a:p>
-            <a:pPr>
-              <a:defRPr sz="2600" b="1">
-                <a:solidFill>
-                  <a:srgbClr val="FFFFFF"/>
-                </a:solidFill>
-                <a:latin typeface="Arial"/>
-              </a:defRPr>
-            </a:pPr>
-            <a:r>
-              <a:t>Trading Rules: Incremental Equity Curves</a:t>
-            </a:r>
-          </a:p>
-        </p:txBody>
-      </p:sp>
-      <p:sp>
-        <p:nvSpPr>
-          <p:cNvPr id="4" name="Rectangle 3"/>
+          <p:cNvPr id="3" name="Rectangle 2"/>
           <p:cNvSpPr/>
           <p:nvPr/>
         </p:nvSpPr>
         <p:spPr>
           <a:xfrm>
-            <a:off x="0" y="914400"/>
-            <a:ext cx="12191695" cy="36576"/>
+            <a:off x="0" y="822960"/>
+            <a:ext cx="12191695" cy="32004"/>
           </a:xfrm>
           <a:prstGeom prst="rect">
             <a:avLst/>
@@ -7222,6 +7351,42 @@
           <a:lstStyle/>
           <a:p>
             <a:pPr algn="ctr"/>
+          </a:p>
+        </p:txBody>
+      </p:sp>
+      <p:sp>
+        <p:nvSpPr>
+          <p:cNvPr id="4" name="TextBox 3"/>
+          <p:cNvSpPr txBox="1"/>
+          <p:nvPr/>
+        </p:nvSpPr>
+        <p:spPr>
+          <a:xfrm>
+            <a:off x="457200" y="201168"/>
+            <a:ext cx="10972800" cy="502920"/>
+          </a:xfrm>
+          <a:prstGeom prst="rect">
+            <a:avLst/>
+          </a:prstGeom>
+          <a:noFill/>
+        </p:spPr>
+        <p:txBody>
+          <a:bodyPr wrap="square">
+            <a:spAutoFit/>
+          </a:bodyPr>
+          <a:lstStyle/>
+          <a:p>
+            <a:pPr algn="l">
+              <a:defRPr sz="2800" b="1">
+                <a:solidFill>
+                  <a:srgbClr val="FFFFFF"/>
+                </a:solidFill>
+                <a:latin typeface="Arial"/>
+              </a:defRPr>
+            </a:pPr>
+            <a:r>
+              <a:t>Trading Rules: Incremental Equity Curves</a:t>
+            </a:r>
           </a:p>
         </p:txBody>
       </p:sp>
@@ -7241,8 +7406,8 @@
         </p:blipFill>
         <p:spPr>
           <a:xfrm>
-            <a:off x="274320" y="1005840"/>
-            <a:ext cx="11612880" cy="7904292"/>
+            <a:off x="365760" y="914400"/>
+            <a:ext cx="11430000" cy="7779815"/>
           </a:xfrm>
           <a:prstGeom prst="rect">
             <a:avLst/>
@@ -7257,8 +7422,8 @@
         </p:nvSpPr>
         <p:spPr>
           <a:xfrm>
-            <a:off x="457200" y="6217920"/>
-            <a:ext cx="10972800" cy="457200"/>
+            <a:off x="457200" y="6309360"/>
+            <a:ext cx="11247120" cy="365760"/>
           </a:xfrm>
           <a:prstGeom prst="rect">
             <a:avLst/>
@@ -7271,22 +7436,16 @@
           </a:bodyPr>
           <a:lstStyle/>
           <a:p>
-            <a:pPr>
-              <a:spcBef>
-                <a:spcPts val="400"/>
-              </a:spcBef>
-              <a:spcAft>
-                <a:spcPts val="400"/>
-              </a:spcAft>
-              <a:defRPr sz="1400">
-                <a:solidFill>
-                  <a:srgbClr val="333333"/>
-                </a:solidFill>
-                <a:latin typeface="Arial"/>
-              </a:defRPr>
-            </a:pPr>
-            <a:r>
-              <a:t>Rule 0: Basic • Rule 1: +Max hold • Rule 2: +Stop loss • Rule 3: +OI filter • Gray: BTC buy-and-hold</a:t>
+            <a:pPr algn="ctr">
+              <a:defRPr sz="1300" b="0">
+                <a:solidFill>
+                  <a:srgbClr val="666666"/>
+                </a:solidFill>
+                <a:latin typeface="Arial"/>
+              </a:defRPr>
+            </a:pPr>
+            <a:r>
+              <a:t>Rule 0: Basic  →  Rule 1: +Max hold  →  Rule 2: +Stop loss  →  Rule 3: +OI filter  •  Gray: BTC buy-and-hold</a:t>
             </a:r>
           </a:p>
         </p:txBody>
@@ -7326,7 +7485,7 @@
         <p:spPr>
           <a:xfrm>
             <a:off x="0" y="0"/>
-            <a:ext cx="12191695" cy="914400"/>
+            <a:ext cx="12191695" cy="822960"/>
           </a:xfrm>
           <a:prstGeom prst="rect">
             <a:avLst/>
@@ -7362,50 +7521,14 @@
       </p:sp>
       <p:sp>
         <p:nvSpPr>
-          <p:cNvPr id="3" name="TextBox 2"/>
-          <p:cNvSpPr txBox="1"/>
-          <p:nvPr/>
-        </p:nvSpPr>
-        <p:spPr>
-          <a:xfrm>
-            <a:off x="457200" y="228600"/>
-            <a:ext cx="10972800" cy="548640"/>
-          </a:xfrm>
-          <a:prstGeom prst="rect">
-            <a:avLst/>
-          </a:prstGeom>
-          <a:noFill/>
-        </p:spPr>
-        <p:txBody>
-          <a:bodyPr wrap="none">
-            <a:spAutoFit/>
-          </a:bodyPr>
-          <a:lstStyle/>
-          <a:p>
-            <a:pPr>
-              <a:defRPr sz="2600" b="1">
-                <a:solidFill>
-                  <a:srgbClr val="FFFFFF"/>
-                </a:solidFill>
-                <a:latin typeface="Arial"/>
-              </a:defRPr>
-            </a:pPr>
-            <a:r>
-              <a:t>Parameter Optimization: Grid Search</a:t>
-            </a:r>
-          </a:p>
-        </p:txBody>
-      </p:sp>
-      <p:sp>
-        <p:nvSpPr>
-          <p:cNvPr id="4" name="Rectangle 3"/>
+          <p:cNvPr id="3" name="Rectangle 2"/>
           <p:cNvSpPr/>
           <p:nvPr/>
         </p:nvSpPr>
         <p:spPr>
           <a:xfrm>
-            <a:off x="0" y="914400"/>
-            <a:ext cx="12191695" cy="36576"/>
+            <a:off x="0" y="822960"/>
+            <a:ext cx="12191695" cy="32004"/>
           </a:xfrm>
           <a:prstGeom prst="rect">
             <a:avLst/>
@@ -7436,6 +7559,42 @@
           <a:lstStyle/>
           <a:p>
             <a:pPr algn="ctr"/>
+          </a:p>
+        </p:txBody>
+      </p:sp>
+      <p:sp>
+        <p:nvSpPr>
+          <p:cNvPr id="4" name="TextBox 3"/>
+          <p:cNvSpPr txBox="1"/>
+          <p:nvPr/>
+        </p:nvSpPr>
+        <p:spPr>
+          <a:xfrm>
+            <a:off x="457200" y="201168"/>
+            <a:ext cx="10972800" cy="502920"/>
+          </a:xfrm>
+          <a:prstGeom prst="rect">
+            <a:avLst/>
+          </a:prstGeom>
+          <a:noFill/>
+        </p:spPr>
+        <p:txBody>
+          <a:bodyPr wrap="square">
+            <a:spAutoFit/>
+          </a:bodyPr>
+          <a:lstStyle/>
+          <a:p>
+            <a:pPr algn="l">
+              <a:defRPr sz="2800" b="1">
+                <a:solidFill>
+                  <a:srgbClr val="FFFFFF"/>
+                </a:solidFill>
+                <a:latin typeface="Arial"/>
+              </a:defRPr>
+            </a:pPr>
+            <a:r>
+              <a:t>Parameter Optimization: Grid Search (120 combinations)</a:t>
+            </a:r>
           </a:p>
         </p:txBody>
       </p:sp>
@@ -7455,8 +7614,8 @@
         </p:blipFill>
         <p:spPr>
           <a:xfrm>
-            <a:off x="274320" y="1051560"/>
-            <a:ext cx="11612880" cy="4086787"/>
+            <a:off x="365760" y="960120"/>
+            <a:ext cx="11430000" cy="4022428"/>
           </a:xfrm>
           <a:prstGeom prst="rect">
             <a:avLst/>
@@ -7471,8 +7630,8 @@
         </p:nvSpPr>
         <p:spPr>
           <a:xfrm>
-            <a:off x="457200" y="6217920"/>
-            <a:ext cx="10972800" cy="457200"/>
+            <a:off x="457200" y="6309360"/>
+            <a:ext cx="11247120" cy="365760"/>
           </a:xfrm>
           <a:prstGeom prst="rect">
             <a:avLst/>
@@ -7485,22 +7644,16 @@
           </a:bodyPr>
           <a:lstStyle/>
           <a:p>
-            <a:pPr>
-              <a:spcBef>
-                <a:spcPts val="400"/>
-              </a:spcBef>
-              <a:spcAft>
-                <a:spcPts val="400"/>
-              </a:spcAft>
-              <a:defRPr sz="1400">
-                <a:solidFill>
-                  <a:srgbClr val="333333"/>
-                </a:solidFill>
-                <a:latin typeface="Arial"/>
-              </a:defRPr>
-            </a:pPr>
-            <a:r>
-              <a:t>Left: Threshold vs Window heatmap • Right: Pardo check — best not extreme outlier • H3 SUPPORTED: peaked, not corner</a:t>
+            <a:pPr algn="ctr">
+              <a:defRPr sz="1300" b="0">
+                <a:solidFill>
+                  <a:srgbClr val="666666"/>
+                </a:solidFill>
+                <a:latin typeface="Arial"/>
+              </a:defRPr>
+            </a:pPr>
+            <a:r>
+              <a:t>Left: Threshold × Window heatmap  •  Right: Pardo check (best not extreme outlier)  •  H3 SUPPORTED</a:t>
             </a:r>
           </a:p>
         </p:txBody>

</xml_diff>

<commit_message>
Fix PPT image overflow + verify all references
Image fixes:
- Add add_image_fit() with proper height/width constraints
- Define consistent CONTENT_TOP, CONTENT_BOTTOM, MARGIN
- All images now fit within slide bounds

References verified (all exist):
- Bailey & López de Prado (2014) - JPM 40(5), 94-107 ✓
- Brunnermeier & Pedersen (2009) - RFS 22(6), 2201-2238 ✓
- Liu, Tsyvinski & Wu (2022) - JF 77(2), 1133-1177 ✓
- Pardo (2008) - Wiley ✓
- Shleifer & Vishny (1997) - JF 52(1), 35-55 ✓

Co-Authored-By: Claude Opus 4.5 <noreply@anthropic.com>
</commit_message>
<xml_diff>
--- a/CFRM522_Presentation.pptx
+++ b/CFRM522_Presentation.pptx
@@ -3119,7 +3119,7 @@
         <p:spPr>
           <a:xfrm>
             <a:off x="731520" y="2743200"/>
-            <a:ext cx="10698480" cy="54864"/>
+            <a:ext cx="10698480" cy="45720"/>
           </a:xfrm>
           <a:prstGeom prst="rect">
             <a:avLst/>
@@ -3176,7 +3176,7 @@
           <a:lstStyle/>
           <a:p>
             <a:pPr algn="l">
-              <a:defRPr sz="4800" b="1">
+              <a:defRPr sz="4600" b="1">
                 <a:solidFill>
                   <a:srgbClr val="FFFFFF"/>
                 </a:solidFill>
@@ -3197,8 +3197,8 @@
         </p:nvSpPr>
         <p:spPr>
           <a:xfrm>
-            <a:off x="731520" y="3108960"/>
-            <a:ext cx="10058400" cy="548640"/>
+            <a:off x="731520" y="3017520"/>
+            <a:ext cx="10058400" cy="457200"/>
           </a:xfrm>
           <a:prstGeom prst="rect">
             <a:avLst/>
@@ -3212,7 +3212,7 @@
           <a:lstStyle/>
           <a:p>
             <a:pPr algn="l">
-              <a:defRPr sz="2400" b="0">
+              <a:defRPr sz="2200" b="0">
                 <a:solidFill>
                   <a:srgbClr val="E8E3D3"/>
                 </a:solidFill>
@@ -3233,8 +3233,8 @@
         </p:nvSpPr>
         <p:spPr>
           <a:xfrm>
-            <a:off x="731520" y="5029200"/>
-            <a:ext cx="4572000" cy="457200"/>
+            <a:off x="731520" y="4937760"/>
+            <a:ext cx="4572000" cy="365760"/>
           </a:xfrm>
           <a:prstGeom prst="rect">
             <a:avLst/>
@@ -3248,7 +3248,7 @@
           <a:lstStyle/>
           <a:p>
             <a:pPr algn="l">
-              <a:defRPr sz="2200" b="0">
+              <a:defRPr sz="2000" b="0">
                 <a:solidFill>
                   <a:srgbClr val="FFFFFF"/>
                 </a:solidFill>
@@ -3269,8 +3269,8 @@
         </p:nvSpPr>
         <p:spPr>
           <a:xfrm>
-            <a:off x="731520" y="5486400"/>
-            <a:ext cx="4572000" cy="457200"/>
+            <a:off x="731520" y="5394960"/>
+            <a:ext cx="4572000" cy="365760"/>
           </a:xfrm>
           <a:prstGeom prst="rect">
             <a:avLst/>
@@ -3284,7 +3284,7 @@
           <a:lstStyle/>
           <a:p>
             <a:pPr algn="l">
-              <a:defRPr sz="1800" b="0">
+              <a:defRPr sz="1600" b="0">
                 <a:solidFill>
                   <a:srgbClr val="E8E3D3"/>
                 </a:solidFill>
@@ -3375,7 +3375,7 @@
         <p:spPr>
           <a:xfrm>
             <a:off x="0" y="822960"/>
-            <a:ext cx="12191695" cy="32004"/>
+            <a:ext cx="12191695" cy="27432"/>
           </a:xfrm>
           <a:prstGeom prst="rect">
             <a:avLst/>
@@ -3417,8 +3417,8 @@
         </p:nvSpPr>
         <p:spPr>
           <a:xfrm>
-            <a:off x="457200" y="201168"/>
-            <a:ext cx="10972800" cy="502920"/>
+            <a:off x="365760" y="201168"/>
+            <a:ext cx="10972800" cy="457200"/>
           </a:xfrm>
           <a:prstGeom prst="rect">
             <a:avLst/>
@@ -3432,7 +3432,7 @@
           <a:lstStyle/>
           <a:p>
             <a:pPr algn="l">
-              <a:defRPr sz="2800" b="1">
+              <a:defRPr sz="2600" b="1">
                 <a:solidFill>
                   <a:srgbClr val="FFFFFF"/>
                 </a:solidFill>
@@ -3461,8 +3461,8 @@
         </p:blipFill>
         <p:spPr>
           <a:xfrm>
-            <a:off x="274320" y="960120"/>
-            <a:ext cx="11612880" cy="3041314"/>
+            <a:off x="274320" y="1005840"/>
+            <a:ext cx="11612880" cy="3041313"/>
           </a:xfrm>
           <a:prstGeom prst="rect">
             <a:avLst/>
@@ -3477,8 +3477,8 @@
         </p:nvSpPr>
         <p:spPr>
           <a:xfrm>
-            <a:off x="457200" y="6309360"/>
-            <a:ext cx="11247120" cy="365760"/>
+            <a:off x="365760" y="6217920"/>
+            <a:ext cx="11460175" cy="365760"/>
           </a:xfrm>
           <a:prstGeom prst="rect">
             <a:avLst/>
@@ -3492,7 +3492,7 @@
           <a:lstStyle/>
           <a:p>
             <a:pPr algn="ctr">
-              <a:defRPr sz="1300" b="0">
+              <a:defRPr sz="1200" b="0">
                 <a:solidFill>
                   <a:srgbClr val="666666"/>
                 </a:solidFill>
@@ -3500,7 +3500,7 @@
               </a:defRPr>
             </a:pPr>
             <a:r>
-              <a:t>Flat = robust to choice  •  Sharp peak = overfit risk  •  Threshold is most sensitive parameter</a:t>
+              <a:t>Flat = robust to choice  •  Sharp peak = overfit risk  •  Threshold is most sensitive</a:t>
             </a:r>
           </a:p>
         </p:txBody>
@@ -3583,7 +3583,7 @@
         <p:spPr>
           <a:xfrm>
             <a:off x="0" y="822960"/>
-            <a:ext cx="12191695" cy="32004"/>
+            <a:ext cx="12191695" cy="27432"/>
           </a:xfrm>
           <a:prstGeom prst="rect">
             <a:avLst/>
@@ -3625,8 +3625,8 @@
         </p:nvSpPr>
         <p:spPr>
           <a:xfrm>
-            <a:off x="457200" y="201168"/>
-            <a:ext cx="10972800" cy="502920"/>
+            <a:off x="365760" y="201168"/>
+            <a:ext cx="10972800" cy="457200"/>
           </a:xfrm>
           <a:prstGeom prst="rect">
             <a:avLst/>
@@ -3640,7 +3640,7 @@
           <a:lstStyle/>
           <a:p>
             <a:pPr algn="l">
-              <a:defRPr sz="2800" b="1">
+              <a:defRPr sz="2600" b="1">
                 <a:solidFill>
                   <a:srgbClr val="FFFFFF"/>
                 </a:solidFill>
@@ -3669,8 +3669,8 @@
         </p:blipFill>
         <p:spPr>
           <a:xfrm>
-            <a:off x="365760" y="914400"/>
-            <a:ext cx="11430000" cy="7598679"/>
+            <a:off x="274320" y="1005840"/>
+            <a:ext cx="6877242" cy="4572000"/>
           </a:xfrm>
           <a:prstGeom prst="rect">
             <a:avLst/>
@@ -3685,8 +3685,8 @@
         </p:nvSpPr>
         <p:spPr>
           <a:xfrm>
-            <a:off x="457200" y="6309360"/>
-            <a:ext cx="11247120" cy="365760"/>
+            <a:off x="365760" y="6217920"/>
+            <a:ext cx="11460175" cy="365760"/>
           </a:xfrm>
           <a:prstGeom prst="rect">
             <a:avLst/>
@@ -3700,7 +3700,7 @@
           <a:lstStyle/>
           <a:p>
             <a:pPr algn="ctr">
-              <a:defRPr sz="1300" b="0">
+              <a:defRPr sz="1200" b="0">
                 <a:solidFill>
                   <a:srgbClr val="666666"/>
                 </a:solidFill>
@@ -3708,7 +3708,7 @@
               </a:defRPr>
             </a:pPr>
             <a:r>
-              <a:t>Most OOS windows positive  •  WF ratio 0.3-0.6  •  Parameter drift → regime dependence  •  H4 PARTIALLY SUPPORTED</a:t>
+              <a:t>Most OOS windows positive  •  WF ratio 0.3-0.6  •  Parameter drift → regime dependence  •  H4 PARTIAL</a:t>
             </a:r>
           </a:p>
         </p:txBody>
@@ -3791,7 +3791,7 @@
         <p:spPr>
           <a:xfrm>
             <a:off x="0" y="822960"/>
-            <a:ext cx="12191695" cy="32004"/>
+            <a:ext cx="12191695" cy="27432"/>
           </a:xfrm>
           <a:prstGeom prst="rect">
             <a:avLst/>
@@ -3833,8 +3833,8 @@
         </p:nvSpPr>
         <p:spPr>
           <a:xfrm>
-            <a:off x="457200" y="201168"/>
-            <a:ext cx="10972800" cy="502920"/>
+            <a:off x="365760" y="201168"/>
+            <a:ext cx="10972800" cy="457200"/>
           </a:xfrm>
           <a:prstGeom prst="rect">
             <a:avLst/>
@@ -3848,7 +3848,7 @@
           <a:lstStyle/>
           <a:p>
             <a:pPr algn="l">
-              <a:defRPr sz="2800" b="1">
+              <a:defRPr sz="2600" b="1">
                 <a:solidFill>
                   <a:srgbClr val="FFFFFF"/>
                 </a:solidFill>
@@ -3877,8 +3877,8 @@
         </p:blipFill>
         <p:spPr>
           <a:xfrm>
-            <a:off x="365760" y="1005840"/>
-            <a:ext cx="6858000" cy="3008007"/>
+            <a:off x="365760" y="1097280"/>
+            <a:ext cx="6583680" cy="2887687"/>
           </a:xfrm>
           <a:prstGeom prst="rect">
             <a:avLst/>
@@ -3893,8 +3893,8 @@
         </p:nvSpPr>
         <p:spPr>
           <a:xfrm>
-            <a:off x="7498079" y="1097280"/>
-            <a:ext cx="4572000" cy="365760"/>
+            <a:off x="7315200" y="1005840"/>
+            <a:ext cx="4572000" cy="320040"/>
           </a:xfrm>
           <a:prstGeom prst="rect">
             <a:avLst/>
@@ -3908,7 +3908,7 @@
           <a:lstStyle/>
           <a:p>
             <a:pPr algn="l">
-              <a:defRPr sz="1800" b="1">
+              <a:defRPr sz="1700" b="1">
                 <a:solidFill>
                   <a:srgbClr val="4B2E83"/>
                 </a:solidFill>
@@ -3929,8 +3929,8 @@
         </p:nvSpPr>
         <p:spPr>
           <a:xfrm>
-            <a:off x="7498079" y="1508760"/>
-            <a:ext cx="4114800" cy="1645920"/>
+            <a:off x="7315200" y="1371600"/>
+            <a:ext cx="4389120" cy="1371600"/>
           </a:xfrm>
           <a:prstGeom prst="rect">
             <a:avLst/>
@@ -3945,12 +3945,12 @@
           <a:p>
             <a:pPr>
               <a:spcBef>
-                <a:spcPts val="800"/>
+                <a:spcPts val="600"/>
               </a:spcBef>
               <a:spcAft>
-                <a:spcPts val="800"/>
+                <a:spcPts val="600"/>
               </a:spcAft>
-              <a:defRPr sz="1500">
+              <a:defRPr sz="1300">
                 <a:solidFill>
                   <a:srgbClr val="2D2D2D"/>
                 </a:solidFill>
@@ -3964,12 +3964,12 @@
           <a:p>
             <a:pPr>
               <a:spcBef>
-                <a:spcPts val="800"/>
+                <a:spcPts val="600"/>
               </a:spcBef>
               <a:spcAft>
-                <a:spcPts val="800"/>
+                <a:spcPts val="600"/>
               </a:spcAft>
-              <a:defRPr sz="1500">
+              <a:defRPr sz="1300">
                 <a:solidFill>
                   <a:srgbClr val="2D2D2D"/>
                 </a:solidFill>
@@ -3983,12 +3983,12 @@
           <a:p>
             <a:pPr>
               <a:spcBef>
-                <a:spcPts val="800"/>
+                <a:spcPts val="600"/>
               </a:spcBef>
               <a:spcAft>
-                <a:spcPts val="800"/>
+                <a:spcPts val="600"/>
               </a:spcAft>
-              <a:defRPr sz="1500">
+              <a:defRPr sz="1300">
                 <a:solidFill>
                   <a:srgbClr val="2D2D2D"/>
                 </a:solidFill>
@@ -3996,7 +3996,7 @@
               </a:defRPr>
             </a:pPr>
             <a:r>
-              <a:t>• Wide CI reflects uncertainty</a:t>
+              <a:t>• Some inflation expected</a:t>
             </a:r>
           </a:p>
         </p:txBody>
@@ -4009,8 +4009,8 @@
         </p:nvSpPr>
         <p:spPr>
           <a:xfrm>
-            <a:off x="7498079" y="3291840"/>
-            <a:ext cx="4572000" cy="365760"/>
+            <a:off x="7315200" y="2926080"/>
+            <a:ext cx="4572000" cy="320040"/>
           </a:xfrm>
           <a:prstGeom prst="rect">
             <a:avLst/>
@@ -4024,7 +4024,7 @@
           <a:lstStyle/>
           <a:p>
             <a:pPr algn="l">
-              <a:defRPr sz="1800" b="1">
+              <a:defRPr sz="1700" b="1">
                 <a:solidFill>
                   <a:srgbClr val="4B2E83"/>
                 </a:solidFill>
@@ -4032,7 +4032,7 @@
               </a:defRPr>
             </a:pPr>
             <a:r>
-              <a:t>Top-N Removal Test</a:t>
+              <a:t>Top-N Removal</a:t>
             </a:r>
           </a:p>
         </p:txBody>
@@ -4045,8 +4045,8 @@
         </p:nvSpPr>
         <p:spPr>
           <a:xfrm>
-            <a:off x="7498079" y="3703320"/>
-            <a:ext cx="4114800" cy="1645920"/>
+            <a:off x="7315200" y="3291840"/>
+            <a:ext cx="4389120" cy="1371600"/>
           </a:xfrm>
           <a:prstGeom prst="rect">
             <a:avLst/>
@@ -4061,12 +4061,12 @@
           <a:p>
             <a:pPr>
               <a:spcBef>
-                <a:spcPts val="800"/>
+                <a:spcPts val="600"/>
               </a:spcBef>
               <a:spcAft>
-                <a:spcPts val="800"/>
+                <a:spcPts val="600"/>
               </a:spcAft>
-              <a:defRPr sz="1500">
+              <a:defRPr sz="1300">
                 <a:solidFill>
                   <a:srgbClr val="2D2D2D"/>
                 </a:solidFill>
@@ -4080,12 +4080,12 @@
           <a:p>
             <a:pPr>
               <a:spcBef>
-                <a:spcPts val="800"/>
+                <a:spcPts val="600"/>
               </a:spcBef>
               <a:spcAft>
-                <a:spcPts val="800"/>
+                <a:spcPts val="600"/>
               </a:spcAft>
-              <a:defRPr sz="1500">
+              <a:defRPr sz="1300">
                 <a:solidFill>
                   <a:srgbClr val="2D2D2D"/>
                 </a:solidFill>
@@ -4099,12 +4099,12 @@
           <a:p>
             <a:pPr>
               <a:spcBef>
-                <a:spcPts val="800"/>
+                <a:spcPts val="600"/>
               </a:spcBef>
               <a:spcAft>
-                <a:spcPts val="800"/>
+                <a:spcPts val="600"/>
               </a:spcAft>
-              <a:defRPr sz="1500">
+              <a:defRPr sz="1300">
                 <a:solidFill>
                   <a:srgbClr val="2D2D2D"/>
                 </a:solidFill>
@@ -4112,7 +4112,7 @@
               </a:defRPr>
             </a:pPr>
             <a:r>
-              <a:t>• Edge is distributed, not outlier-driven</a:t>
+              <a:t>• Edge is distributed</a:t>
             </a:r>
           </a:p>
         </p:txBody>
@@ -4125,8 +4125,8 @@
         </p:nvSpPr>
         <p:spPr>
           <a:xfrm>
-            <a:off x="7498079" y="5303520"/>
-            <a:ext cx="4572000" cy="365760"/>
+            <a:off x="7315200" y="4754880"/>
+            <a:ext cx="4572000" cy="320040"/>
           </a:xfrm>
           <a:prstGeom prst="rect">
             <a:avLst/>
@@ -4140,7 +4140,7 @@
           <a:lstStyle/>
           <a:p>
             <a:pPr algn="l">
-              <a:defRPr sz="1800" b="1">
+              <a:defRPr sz="1700" b="1">
                 <a:solidFill>
                   <a:srgbClr val="4B2E83"/>
                 </a:solidFill>
@@ -4161,8 +4161,8 @@
         </p:nvSpPr>
         <p:spPr>
           <a:xfrm>
-            <a:off x="7498079" y="5669280"/>
-            <a:ext cx="4114800" cy="548640"/>
+            <a:off x="7315200" y="5074920"/>
+            <a:ext cx="4389120" cy="457200"/>
           </a:xfrm>
           <a:prstGeom prst="rect">
             <a:avLst/>
@@ -4176,7 +4176,7 @@
           <a:lstStyle/>
           <a:p>
             <a:pPr algn="l">
-              <a:defRPr sz="1400" b="0">
+              <a:defRPr sz="1200" b="0">
                 <a:solidFill>
                   <a:srgbClr val="666666"/>
                 </a:solidFill>
@@ -4184,7 +4184,7 @@
               </a:defRPr>
             </a:pPr>
             <a:r>
-              <a:t>Half-sample optimization shows moderate parameter stability across time</a:t>
+              <a:t>Half-sample params show moderate stability</a:t>
             </a:r>
           </a:p>
         </p:txBody>
@@ -4267,7 +4267,7 @@
         <p:spPr>
           <a:xfrm>
             <a:off x="0" y="822960"/>
-            <a:ext cx="12191695" cy="32004"/>
+            <a:ext cx="12191695" cy="27432"/>
           </a:xfrm>
           <a:prstGeom prst="rect">
             <a:avLst/>
@@ -4309,8 +4309,8 @@
         </p:nvSpPr>
         <p:spPr>
           <a:xfrm>
-            <a:off x="457200" y="201168"/>
-            <a:ext cx="10972800" cy="502920"/>
+            <a:off x="365760" y="201168"/>
+            <a:ext cx="10972800" cy="457200"/>
           </a:xfrm>
           <a:prstGeom prst="rect">
             <a:avLst/>
@@ -4324,7 +4324,7 @@
           <a:lstStyle/>
           <a:p>
             <a:pPr algn="l">
-              <a:defRPr sz="2800" b="1">
+              <a:defRPr sz="2600" b="1">
                 <a:solidFill>
                   <a:srgbClr val="FFFFFF"/>
                 </a:solidFill>
@@ -4354,7 +4354,7 @@
         <p:spPr>
           <a:xfrm>
             <a:off x="274320" y="1005840"/>
-            <a:ext cx="5303520" cy="2620958"/>
+            <a:ext cx="5029200" cy="2485391"/>
           </a:xfrm>
           <a:prstGeom prst="rect">
             <a:avLst/>
@@ -4377,8 +4377,8 @@
         </p:blipFill>
         <p:spPr>
           <a:xfrm>
-            <a:off x="5760720" y="1005840"/>
-            <a:ext cx="6126480" cy="2012448"/>
+            <a:off x="5669280" y="1005840"/>
+            <a:ext cx="6217920" cy="2042484"/>
           </a:xfrm>
           <a:prstGeom prst="rect">
             <a:avLst/>
@@ -4393,8 +4393,8 @@
         </p:nvSpPr>
         <p:spPr>
           <a:xfrm>
-            <a:off x="457200" y="5029200"/>
-            <a:ext cx="5029200" cy="365760"/>
+            <a:off x="457200" y="4754880"/>
+            <a:ext cx="5029200" cy="274320"/>
           </a:xfrm>
           <a:prstGeom prst="rect">
             <a:avLst/>
@@ -4408,7 +4408,7 @@
           <a:lstStyle/>
           <a:p>
             <a:pPr algn="l">
-              <a:defRPr sz="1400" b="0">
+              <a:defRPr sz="1200" b="0">
                 <a:solidFill>
                   <a:srgbClr val="666666"/>
                 </a:solidFill>
@@ -4416,7 +4416,7 @@
               </a:defRPr>
             </a:pPr>
             <a:r>
-              <a:t>BTC-ETH correlation ~0.7+ (macro-driven)</a:t>
+              <a:t>BTC-ETH funding correlation ~0.7+</a:t>
             </a:r>
           </a:p>
         </p:txBody>
@@ -4429,8 +4429,8 @@
         </p:nvSpPr>
         <p:spPr>
           <a:xfrm>
-            <a:off x="5943600" y="5029200"/>
-            <a:ext cx="5760720" cy="365760"/>
+            <a:off x="5760720" y="4754880"/>
+            <a:ext cx="5943600" cy="274320"/>
           </a:xfrm>
           <a:prstGeom prst="rect">
             <a:avLst/>
@@ -4444,7 +4444,7 @@
           <a:lstStyle/>
           <a:p>
             <a:pPr algn="l">
-              <a:defRPr sz="1400" b="0">
+              <a:defRPr sz="1200" b="0">
                 <a:solidFill>
                   <a:srgbClr val="666666"/>
                 </a:solidFill>
@@ -4452,7 +4452,7 @@
               </a:defRPr>
             </a:pPr>
             <a:r>
-              <a:t>ETH positive Calmar with BTC params (no re-fit) → genuine effect</a:t>
+              <a:t>ETH positive Calmar with BTC params (no re-fit)</a:t>
             </a:r>
           </a:p>
         </p:txBody>
@@ -4465,8 +4465,8 @@
         </p:nvSpPr>
         <p:spPr>
           <a:xfrm>
-            <a:off x="457200" y="5669280"/>
-            <a:ext cx="11247120" cy="640080"/>
+            <a:off x="365760" y="5212080"/>
+            <a:ext cx="11430000" cy="594360"/>
           </a:xfrm>
           <a:prstGeom prst="roundRect">
             <a:avLst/>
@@ -4508,8 +4508,8 @@
         </p:nvSpPr>
         <p:spPr>
           <a:xfrm>
-            <a:off x="640080" y="5806440"/>
-            <a:ext cx="10972800" cy="457200"/>
+            <a:off x="548640" y="5349240"/>
+            <a:ext cx="11155680" cy="365760"/>
           </a:xfrm>
           <a:prstGeom prst="rect">
             <a:avLst/>
@@ -4523,7 +4523,7 @@
           <a:lstStyle/>
           <a:p>
             <a:pPr algn="ctr">
-              <a:defRPr sz="1500" b="1">
+              <a:defRPr sz="1400" b="1">
                 <a:solidFill>
                   <a:srgbClr val="4B2E83"/>
                 </a:solidFill>
@@ -4531,7 +4531,7 @@
               </a:defRPr>
             </a:pPr>
             <a:r>
-              <a:t>Cross-asset validation confirms: funding rate contrarian is a market microstructure effect, not BTC-specific noise</a:t>
+              <a:t>Cross-asset validation: funding contrarian is a microstructure effect, not BTC-specific noise</a:t>
             </a:r>
           </a:p>
         </p:txBody>
@@ -4614,7 +4614,7 @@
         <p:spPr>
           <a:xfrm>
             <a:off x="0" y="822960"/>
-            <a:ext cx="12191695" cy="32004"/>
+            <a:ext cx="12191695" cy="27432"/>
           </a:xfrm>
           <a:prstGeom prst="rect">
             <a:avLst/>
@@ -4656,8 +4656,8 @@
         </p:nvSpPr>
         <p:spPr>
           <a:xfrm>
-            <a:off x="457200" y="201168"/>
-            <a:ext cx="10972800" cy="502920"/>
+            <a:off x="365760" y="201168"/>
+            <a:ext cx="10972800" cy="457200"/>
           </a:xfrm>
           <a:prstGeom prst="rect">
             <a:avLst/>
@@ -4671,7 +4671,7 @@
           <a:lstStyle/>
           <a:p>
             <a:pPr algn="l">
-              <a:defRPr sz="2800" b="1">
+              <a:defRPr sz="2600" b="1">
                 <a:solidFill>
                   <a:srgbClr val="FFFFFF"/>
                 </a:solidFill>
@@ -4692,8 +4692,8 @@
         </p:nvSpPr>
         <p:spPr>
           <a:xfrm>
-            <a:off x="457200" y="1097280"/>
-            <a:ext cx="4572000" cy="365760"/>
+            <a:off x="365760" y="1005840"/>
+            <a:ext cx="4572000" cy="320040"/>
           </a:xfrm>
           <a:prstGeom prst="rect">
             <a:avLst/>
@@ -4707,7 +4707,7 @@
           <a:lstStyle/>
           <a:p>
             <a:pPr algn="l">
-              <a:defRPr sz="1800" b="1">
+              <a:defRPr sz="1700" b="1">
                 <a:solidFill>
                   <a:srgbClr val="4B2E83"/>
                 </a:solidFill>
@@ -4728,8 +4728,8 @@
         </p:nvSpPr>
         <p:spPr>
           <a:xfrm>
-            <a:off x="457200" y="1508760"/>
-            <a:ext cx="3657600" cy="2560320"/>
+            <a:off x="365760" y="1371600"/>
+            <a:ext cx="3657600" cy="2286000"/>
           </a:xfrm>
           <a:prstGeom prst="rect">
             <a:avLst/>
@@ -4744,12 +4744,12 @@
           <a:p>
             <a:pPr>
               <a:spcBef>
-                <a:spcPts val="800"/>
+                <a:spcPts val="600"/>
               </a:spcBef>
               <a:spcAft>
-                <a:spcPts val="800"/>
+                <a:spcPts val="600"/>
               </a:spcAft>
-              <a:defRPr sz="1400">
+              <a:defRPr sz="1300">
                 <a:solidFill>
                   <a:srgbClr val="2D2D2D"/>
                 </a:solidFill>
@@ -4763,12 +4763,12 @@
           <a:p>
             <a:pPr>
               <a:spcBef>
-                <a:spcPts val="800"/>
+                <a:spcPts val="600"/>
               </a:spcBef>
               <a:spcAft>
-                <a:spcPts val="800"/>
+                <a:spcPts val="600"/>
               </a:spcAft>
-              <a:defRPr sz="1400">
+              <a:defRPr sz="1300">
                 <a:solidFill>
                   <a:srgbClr val="2D2D2D"/>
                 </a:solidFill>
@@ -4782,12 +4782,12 @@
           <a:p>
             <a:pPr>
               <a:spcBef>
-                <a:spcPts val="800"/>
+                <a:spcPts val="600"/>
               </a:spcBef>
               <a:spcAft>
-                <a:spcPts val="800"/>
+                <a:spcPts val="600"/>
               </a:spcAft>
-              <a:defRPr sz="1400">
+              <a:defRPr sz="1300">
                 <a:solidFill>
                   <a:srgbClr val="2D2D2D"/>
                 </a:solidFill>
@@ -4795,18 +4795,18 @@
               </a:defRPr>
             </a:pPr>
             <a:r>
-              <a:t>• IC significant at 24h</a:t>
+              <a:t>• IC significant at 24h horizon</a:t>
             </a:r>
           </a:p>
           <a:p>
             <a:pPr>
               <a:spcBef>
-                <a:spcPts val="800"/>
+                <a:spcPts val="600"/>
               </a:spcBef>
               <a:spcAft>
-                <a:spcPts val="800"/>
+                <a:spcPts val="600"/>
               </a:spcAft>
-              <a:defRPr sz="1400">
+              <a:defRPr sz="1300">
                 <a:solidFill>
                   <a:srgbClr val="2D2D2D"/>
                 </a:solidFill>
@@ -4820,12 +4820,12 @@
           <a:p>
             <a:pPr>
               <a:spcBef>
-                <a:spcPts val="800"/>
+                <a:spcPts val="600"/>
               </a:spcBef>
               <a:spcAft>
-                <a:spcPts val="800"/>
+                <a:spcPts val="600"/>
               </a:spcAft>
-              <a:defRPr sz="1400">
+              <a:defRPr sz="1300">
                 <a:solidFill>
                   <a:srgbClr val="2D2D2D"/>
                 </a:solidFill>
@@ -4833,7 +4833,7 @@
               </a:defRPr>
             </a:pPr>
             <a:r>
-              <a:t>• Cross-asset validated</a:t>
+              <a:t>• Cross-asset validated on ETH</a:t>
             </a:r>
           </a:p>
         </p:txBody>
@@ -4846,8 +4846,8 @@
         </p:nvSpPr>
         <p:spPr>
           <a:xfrm>
-            <a:off x="4389120" y="1097280"/>
-            <a:ext cx="4572000" cy="365760"/>
+            <a:off x="4206240" y="1005840"/>
+            <a:ext cx="4572000" cy="320040"/>
           </a:xfrm>
           <a:prstGeom prst="rect">
             <a:avLst/>
@@ -4861,7 +4861,7 @@
           <a:lstStyle/>
           <a:p>
             <a:pPr algn="l">
-              <a:defRPr sz="1800" b="1">
+              <a:defRPr sz="1700" b="1">
                 <a:solidFill>
                   <a:srgbClr val="4B2E83"/>
                 </a:solidFill>
@@ -4882,8 +4882,8 @@
         </p:nvSpPr>
         <p:spPr>
           <a:xfrm>
-            <a:off x="4389120" y="1508760"/>
-            <a:ext cx="3200400" cy="2560320"/>
+            <a:off x="4206240" y="1371600"/>
+            <a:ext cx="3200400" cy="2286000"/>
           </a:xfrm>
           <a:prstGeom prst="rect">
             <a:avLst/>
@@ -4898,12 +4898,12 @@
           <a:p>
             <a:pPr>
               <a:spcBef>
-                <a:spcPts val="800"/>
+                <a:spcPts val="600"/>
               </a:spcBef>
               <a:spcAft>
-                <a:spcPts val="800"/>
+                <a:spcPts val="600"/>
               </a:spcAft>
-              <a:defRPr sz="1400">
+              <a:defRPr sz="1300">
                 <a:solidFill>
                   <a:srgbClr val="2D2D2D"/>
                 </a:solidFill>
@@ -4917,12 +4917,12 @@
           <a:p>
             <a:pPr>
               <a:spcBef>
-                <a:spcPts val="800"/>
+                <a:spcPts val="600"/>
               </a:spcBef>
               <a:spcAft>
-                <a:spcPts val="800"/>
+                <a:spcPts val="600"/>
               </a:spcAft>
-              <a:defRPr sz="1400">
+              <a:defRPr sz="1300">
                 <a:solidFill>
                   <a:srgbClr val="2D2D2D"/>
                 </a:solidFill>
@@ -4936,12 +4936,12 @@
           <a:p>
             <a:pPr>
               <a:spcBef>
-                <a:spcPts val="800"/>
+                <a:spcPts val="600"/>
               </a:spcBef>
               <a:spcAft>
-                <a:spcPts val="800"/>
+                <a:spcPts val="600"/>
               </a:spcAft>
-              <a:defRPr sz="1400">
+              <a:defRPr sz="1300">
                 <a:solidFill>
                   <a:srgbClr val="2D2D2D"/>
                 </a:solidFill>
@@ -4955,12 +4955,12 @@
           <a:p>
             <a:pPr>
               <a:spcBef>
-                <a:spcPts val="800"/>
+                <a:spcPts val="600"/>
               </a:spcBef>
               <a:spcAft>
-                <a:spcPts val="800"/>
+                <a:spcPts val="600"/>
               </a:spcAft>
-              <a:defRPr sz="1400">
+              <a:defRPr sz="1300">
                 <a:solidFill>
                   <a:srgbClr val="2D2D2D"/>
                 </a:solidFill>
@@ -4974,12 +4974,12 @@
           <a:p>
             <a:pPr>
               <a:spcBef>
-                <a:spcPts val="800"/>
+                <a:spcPts val="600"/>
               </a:spcBef>
               <a:spcAft>
-                <a:spcPts val="800"/>
+                <a:spcPts val="600"/>
               </a:spcAft>
-              <a:defRPr sz="1400">
+              <a:defRPr sz="1300">
                 <a:solidFill>
                   <a:srgbClr val="2D2D2D"/>
                 </a:solidFill>
@@ -4987,7 +4987,7 @@
               </a:defRPr>
             </a:pPr>
             <a:r>
-              <a:t>• Trades: ~125</a:t>
+              <a:t>• Trades: ~125 (4 years)</a:t>
             </a:r>
           </a:p>
         </p:txBody>
@@ -5000,8 +5000,8 @@
         </p:nvSpPr>
         <p:spPr>
           <a:xfrm>
-            <a:off x="8046720" y="1097280"/>
-            <a:ext cx="4572000" cy="365760"/>
+            <a:off x="7772400" y="1005840"/>
+            <a:ext cx="4572000" cy="320040"/>
           </a:xfrm>
           <a:prstGeom prst="rect">
             <a:avLst/>
@@ -5015,7 +5015,7 @@
           <a:lstStyle/>
           <a:p>
             <a:pPr algn="l">
-              <a:defRPr sz="1800" b="1">
+              <a:defRPr sz="1700" b="1">
                 <a:solidFill>
                   <a:srgbClr val="4B2E83"/>
                 </a:solidFill>
@@ -5036,8 +5036,8 @@
         </p:nvSpPr>
         <p:spPr>
           <a:xfrm>
-            <a:off x="8046720" y="1508760"/>
-            <a:ext cx="3657600" cy="2011680"/>
+            <a:off x="7772400" y="1371600"/>
+            <a:ext cx="3657600" cy="1828800"/>
           </a:xfrm>
           <a:prstGeom prst="rect">
             <a:avLst/>
@@ -5052,12 +5052,12 @@
           <a:p>
             <a:pPr>
               <a:spcBef>
-                <a:spcPts val="800"/>
+                <a:spcPts val="600"/>
               </a:spcBef>
               <a:spcAft>
-                <a:spcPts val="800"/>
+                <a:spcPts val="600"/>
               </a:spcAft>
-              <a:defRPr sz="1400">
+              <a:defRPr sz="1300">
                 <a:solidFill>
                   <a:srgbClr val="2D2D2D"/>
                 </a:solidFill>
@@ -5071,12 +5071,12 @@
           <a:p>
             <a:pPr>
               <a:spcBef>
-                <a:spcPts val="800"/>
+                <a:spcPts val="600"/>
               </a:spcBef>
               <a:spcAft>
-                <a:spcPts val="800"/>
+                <a:spcPts val="600"/>
               </a:spcAft>
-              <a:defRPr sz="1400">
+              <a:defRPr sz="1300">
                 <a:solidFill>
                   <a:srgbClr val="2D2D2D"/>
                 </a:solidFill>
@@ -5090,12 +5090,12 @@
           <a:p>
             <a:pPr>
               <a:spcBef>
-                <a:spcPts val="800"/>
+                <a:spcPts val="600"/>
               </a:spcBef>
               <a:spcAft>
-                <a:spcPts val="800"/>
+                <a:spcPts val="600"/>
               </a:spcAft>
-              <a:defRPr sz="1400">
+              <a:defRPr sz="1300">
                 <a:solidFill>
                   <a:srgbClr val="2D2D2D"/>
                 </a:solidFill>
@@ -5109,12 +5109,12 @@
           <a:p>
             <a:pPr>
               <a:spcBef>
-                <a:spcPts val="800"/>
+                <a:spcPts val="600"/>
               </a:spcBef>
               <a:spcAft>
-                <a:spcPts val="800"/>
+                <a:spcPts val="600"/>
               </a:spcAft>
-              <a:defRPr sz="1400">
+              <a:defRPr sz="1300">
                 <a:solidFill>
                   <a:srgbClr val="2D2D2D"/>
                 </a:solidFill>
@@ -5135,8 +5135,8 @@
         </p:nvSpPr>
         <p:spPr>
           <a:xfrm>
-            <a:off x="457200" y="4206240"/>
-            <a:ext cx="4572000" cy="365760"/>
+            <a:off x="365760" y="3840480"/>
+            <a:ext cx="4572000" cy="320040"/>
           </a:xfrm>
           <a:prstGeom prst="rect">
             <a:avLst/>
@@ -5150,7 +5150,7 @@
           <a:lstStyle/>
           <a:p>
             <a:pPr algn="l">
-              <a:defRPr sz="1800" b="1">
+              <a:defRPr sz="1700" b="1">
                 <a:solidFill>
                   <a:srgbClr val="4B2E83"/>
                 </a:solidFill>
@@ -5171,8 +5171,8 @@
         </p:nvSpPr>
         <p:spPr>
           <a:xfrm>
-            <a:off x="457200" y="4617720"/>
-            <a:ext cx="10972800" cy="1645920"/>
+            <a:off x="365760" y="4206240"/>
+            <a:ext cx="11430000" cy="1645920"/>
           </a:xfrm>
           <a:prstGeom prst="rect">
             <a:avLst/>
@@ -5187,12 +5187,12 @@
           <a:p>
             <a:pPr>
               <a:spcBef>
-                <a:spcPts val="800"/>
+                <a:spcPts val="600"/>
               </a:spcBef>
               <a:spcAft>
-                <a:spcPts val="800"/>
+                <a:spcPts val="600"/>
               </a:spcAft>
-              <a:defRPr sz="1400">
+              <a:defRPr sz="1300">
                 <a:solidFill>
                   <a:srgbClr val="2D2D2D"/>
                 </a:solidFill>
@@ -5200,18 +5200,18 @@
               </a:defRPr>
             </a:pPr>
             <a:r>
-              <a:t>• Tail events: LUNA-style collapse where funding stays extreme for extended periods</a:t>
+              <a:t>• Tail events: LUNA-style collapse where funding stays extreme</a:t>
             </a:r>
           </a:p>
           <a:p>
             <a:pPr>
               <a:spcBef>
-                <a:spcPts val="800"/>
+                <a:spcPts val="600"/>
               </a:spcBef>
               <a:spcAft>
-                <a:spcPts val="800"/>
+                <a:spcPts val="600"/>
               </a:spcAft>
-              <a:defRPr sz="1400">
+              <a:defRPr sz="1300">
                 <a:solidFill>
                   <a:srgbClr val="2D2D2D"/>
                 </a:solidFill>
@@ -5219,18 +5219,18 @@
               </a:defRPr>
             </a:pPr>
             <a:r>
-              <a:t>• Regime dependence: strategy performs better in high-volatility periods</a:t>
+              <a:t>• Regime dependence: better in high-volatility periods</a:t>
             </a:r>
           </a:p>
           <a:p>
             <a:pPr>
               <a:spcBef>
-                <a:spcPts val="800"/>
+                <a:spcPts val="600"/>
               </a:spcBef>
               <a:spcAft>
-                <a:spcPts val="800"/>
+                <a:spcPts val="600"/>
               </a:spcAft>
-              <a:defRPr sz="1400">
+              <a:defRPr sz="1300">
                 <a:solidFill>
                   <a:srgbClr val="2D2D2D"/>
                 </a:solidFill>
@@ -5238,18 +5238,18 @@
               </a:defRPr>
             </a:pPr>
             <a:r>
-              <a:t>• Market structure shift: post-FTX changes may reduce future effectiveness</a:t>
+              <a:t>• Market structure shift post-FTX may reduce effectiveness</a:t>
             </a:r>
           </a:p>
           <a:p>
             <a:pPr>
               <a:spcBef>
-                <a:spcPts val="800"/>
+                <a:spcPts val="600"/>
               </a:spcBef>
               <a:spcAft>
-                <a:spcPts val="800"/>
+                <a:spcPts val="600"/>
               </a:spcAft>
-              <a:defRPr sz="1400">
+              <a:defRPr sz="1300">
                 <a:solidFill>
                   <a:srgbClr val="2D2D2D"/>
                 </a:solidFill>
@@ -5257,7 +5257,7 @@
               </a:defRPr>
             </a:pPr>
             <a:r>
-              <a:t>• Crowding risk: if strategy becomes widely known, edge may disappear</a:t>
+              <a:t>• Crowding risk if strategy becomes widely adopted</a:t>
             </a:r>
           </a:p>
         </p:txBody>
@@ -5340,7 +5340,7 @@
         <p:spPr>
           <a:xfrm>
             <a:off x="0" y="822960"/>
-            <a:ext cx="12191695" cy="32004"/>
+            <a:ext cx="12191695" cy="27432"/>
           </a:xfrm>
           <a:prstGeom prst="rect">
             <a:avLst/>
@@ -5382,8 +5382,8 @@
         </p:nvSpPr>
         <p:spPr>
           <a:xfrm>
-            <a:off x="457200" y="201168"/>
-            <a:ext cx="10972800" cy="502920"/>
+            <a:off x="365760" y="201168"/>
+            <a:ext cx="10972800" cy="457200"/>
           </a:xfrm>
           <a:prstGeom prst="rect">
             <a:avLst/>
@@ -5397,7 +5397,7 @@
           <a:lstStyle/>
           <a:p>
             <a:pPr algn="l">
-              <a:defRPr sz="2800" b="1">
+              <a:defRPr sz="2600" b="1">
                 <a:solidFill>
                   <a:srgbClr val="FFFFFF"/>
                 </a:solidFill>
@@ -5418,8 +5418,8 @@
         </p:nvSpPr>
         <p:spPr>
           <a:xfrm>
-            <a:off x="457200" y="1188720"/>
-            <a:ext cx="10972800" cy="5029200"/>
+            <a:off x="365760" y="1097280"/>
+            <a:ext cx="11430000" cy="5029200"/>
           </a:xfrm>
           <a:prstGeom prst="rect">
             <a:avLst/>
@@ -5441,7 +5441,7 @@
               </a:defRPr>
             </a:pPr>
             <a:r>
-              <a:t>Bailey, D. H., &amp; Lopez de Prado, M. (2014). The Deflated Sharpe Ratio.</a:t>
+              <a:t>Bailey, D. H., &amp; López de Prado, M. (2014). The Deflated Sharpe Ratio: Correcting for</a:t>
             </a:r>
           </a:p>
           <a:p>
@@ -5454,7 +5454,7 @@
               </a:defRPr>
             </a:pPr>
             <a:r>
-              <a:t>    Journal of Portfolio Management, 40(5), 94-107.</a:t>
+              <a:t>    Selection Bias, Backtest Overfitting, and Non-Normality. Journal of Portfolio</a:t>
             </a:r>
           </a:p>
           <a:p>
@@ -5466,6 +5466,9 @@
                 <a:latin typeface="Arial"/>
               </a:defRPr>
             </a:pPr>
+            <a:r>
+              <a:t>    Management, 40(5), 94-107.</a:t>
+            </a:r>
           </a:p>
           <a:p>
             <a:pPr>
@@ -5476,9 +5479,6 @@
                 <a:latin typeface="Arial"/>
               </a:defRPr>
             </a:pPr>
-            <a:r>
-              <a:t>Brunnermeier, M. K., &amp; Pedersen, L. H. (2009). Market Liquidity and Funding Liquidity.</a:t>
-            </a:r>
           </a:p>
           <a:p>
             <a:pPr>
@@ -5490,7 +5490,7 @@
               </a:defRPr>
             </a:pPr>
             <a:r>
-              <a:t>    Review of Financial Studies, 22(6), 2201-2238.</a:t>
+              <a:t>Brunnermeier, M. K., &amp; Pedersen, L. H. (2009). Market Liquidity and Funding Liquidity.</a:t>
             </a:r>
           </a:p>
           <a:p>
@@ -5502,6 +5502,9 @@
                 <a:latin typeface="Arial"/>
               </a:defRPr>
             </a:pPr>
+            <a:r>
+              <a:t>    The Review of Financial Studies, 22(6), 2201-2238.</a:t>
+            </a:r>
           </a:p>
           <a:p>
             <a:pPr>
@@ -5512,9 +5515,6 @@
                 <a:latin typeface="Arial"/>
               </a:defRPr>
             </a:pPr>
-            <a:r>
-              <a:t>Liu, Y., Tsyvinski, A., &amp; Wu, X. (2022). Common Risk Factors in Cryptocurrency.</a:t>
-            </a:r>
           </a:p>
           <a:p>
             <a:pPr>
@@ -5526,7 +5526,7 @@
               </a:defRPr>
             </a:pPr>
             <a:r>
-              <a:t>    Journal of Finance, 77(2), 1133-1177.</a:t>
+              <a:t>Liu, Y., Tsyvinski, A., &amp; Wu, X. (2022). Common Risk Factors in Cryptocurrency.</a:t>
             </a:r>
           </a:p>
           <a:p>
@@ -5538,6 +5538,9 @@
                 <a:latin typeface="Arial"/>
               </a:defRPr>
             </a:pPr>
+            <a:r>
+              <a:t>    The Journal of Finance, 77(2), 1133-1177.</a:t>
+            </a:r>
           </a:p>
           <a:p>
             <a:pPr>
@@ -5548,9 +5551,6 @@
                 <a:latin typeface="Arial"/>
               </a:defRPr>
             </a:pPr>
-            <a:r>
-              <a:t>Pardo, R. (2008). The Evaluation and Optimization of Trading Strategies. Wiley.</a:t>
-            </a:r>
           </a:p>
           <a:p>
             <a:pPr>
@@ -5561,6 +5561,9 @@
                 <a:latin typeface="Arial"/>
               </a:defRPr>
             </a:pPr>
+            <a:r>
+              <a:t>Pardo, R. (2008). The Evaluation and Optimization of Trading Strategies (2nd ed.).</a:t>
+            </a:r>
           </a:p>
           <a:p>
             <a:pPr>
@@ -5572,7 +5575,7 @@
               </a:defRPr>
             </a:pPr>
             <a:r>
-              <a:t>Shleifer, A., &amp; Vishny, R. W. (1997). The Limits of Arbitrage.</a:t>
+              <a:t>    John Wiley &amp; Sons.</a:t>
             </a:r>
           </a:p>
           <a:p>
@@ -5584,8 +5587,31 @@
                 <a:latin typeface="Arial"/>
               </a:defRPr>
             </a:pPr>
-            <a:r>
-              <a:t>    Journal of Finance, 52(1), 35-55.</a:t>
+          </a:p>
+          <a:p>
+            <a:pPr>
+              <a:defRPr sz="1400">
+                <a:solidFill>
+                  <a:srgbClr val="2D2D2D"/>
+                </a:solidFill>
+                <a:latin typeface="Arial"/>
+              </a:defRPr>
+            </a:pPr>
+            <a:r>
+              <a:t>Shleifer, A., &amp; Vishny, R. W. (1997). The Limits of Arbitrage.</a:t>
+            </a:r>
+          </a:p>
+          <a:p>
+            <a:pPr>
+              <a:defRPr sz="1400">
+                <a:solidFill>
+                  <a:srgbClr val="2D2D2D"/>
+                </a:solidFill>
+                <a:latin typeface="Arial"/>
+              </a:defRPr>
+            </a:pPr>
+            <a:r>
+              <a:t>    The Journal of Finance, 52(1), 35-55.</a:t>
             </a:r>
           </a:p>
         </p:txBody>
@@ -5668,7 +5694,7 @@
         <p:spPr>
           <a:xfrm>
             <a:off x="0" y="822960"/>
-            <a:ext cx="12191695" cy="32004"/>
+            <a:ext cx="12191695" cy="27432"/>
           </a:xfrm>
           <a:prstGeom prst="rect">
             <a:avLst/>
@@ -5710,8 +5736,8 @@
         </p:nvSpPr>
         <p:spPr>
           <a:xfrm>
-            <a:off x="457200" y="201168"/>
-            <a:ext cx="10972800" cy="502920"/>
+            <a:off x="365760" y="201168"/>
+            <a:ext cx="10972800" cy="457200"/>
           </a:xfrm>
           <a:prstGeom prst="rect">
             <a:avLst/>
@@ -5725,7 +5751,7 @@
           <a:lstStyle/>
           <a:p>
             <a:pPr algn="l">
-              <a:defRPr sz="2800" b="1">
+              <a:defRPr sz="2600" b="1">
                 <a:solidFill>
                   <a:srgbClr val="FFFFFF"/>
                 </a:solidFill>
@@ -5746,8 +5772,8 @@
         </p:nvSpPr>
         <p:spPr>
           <a:xfrm>
-            <a:off x="457200" y="1097280"/>
-            <a:ext cx="4572000" cy="365760"/>
+            <a:off x="365760" y="1005840"/>
+            <a:ext cx="4572000" cy="320040"/>
           </a:xfrm>
           <a:prstGeom prst="rect">
             <a:avLst/>
@@ -5761,7 +5787,7 @@
           <a:lstStyle/>
           <a:p>
             <a:pPr algn="l">
-              <a:defRPr sz="1800" b="1">
+              <a:defRPr sz="1700" b="1">
                 <a:solidFill>
                   <a:srgbClr val="4B2E83"/>
                 </a:solidFill>
@@ -5782,8 +5808,8 @@
         </p:nvSpPr>
         <p:spPr>
           <a:xfrm>
-            <a:off x="457200" y="1508760"/>
-            <a:ext cx="5303520" cy="2560320"/>
+            <a:off x="365760" y="1371600"/>
+            <a:ext cx="5303520" cy="2377440"/>
           </a:xfrm>
           <a:prstGeom prst="rect">
             <a:avLst/>
@@ -5798,12 +5824,12 @@
           <a:p>
             <a:pPr>
               <a:spcBef>
-                <a:spcPts val="800"/>
+                <a:spcPts val="600"/>
               </a:spcBef>
               <a:spcAft>
-                <a:spcPts val="800"/>
+                <a:spcPts val="600"/>
               </a:spcAft>
-              <a:defRPr sz="1500">
+              <a:defRPr sz="1400">
                 <a:solidFill>
                   <a:srgbClr val="2D2D2D"/>
                 </a:solidFill>
@@ -5817,12 +5843,12 @@
           <a:p>
             <a:pPr>
               <a:spcBef>
-                <a:spcPts val="800"/>
+                <a:spcPts val="600"/>
               </a:spcBef>
               <a:spcAft>
-                <a:spcPts val="800"/>
+                <a:spcPts val="600"/>
               </a:spcAft>
-              <a:defRPr sz="1500">
+              <a:defRPr sz="1400">
                 <a:solidFill>
                   <a:srgbClr val="2D2D2D"/>
                 </a:solidFill>
@@ -5836,12 +5862,12 @@
           <a:p>
             <a:pPr>
               <a:spcBef>
-                <a:spcPts val="800"/>
+                <a:spcPts val="600"/>
               </a:spcBef>
               <a:spcAft>
-                <a:spcPts val="800"/>
+                <a:spcPts val="600"/>
               </a:spcAft>
-              <a:defRPr sz="1500">
+              <a:defRPr sz="1400">
                 <a:solidFill>
                   <a:srgbClr val="2D2D2D"/>
                 </a:solidFill>
@@ -5855,12 +5881,12 @@
           <a:p>
             <a:pPr>
               <a:spcBef>
-                <a:spcPts val="800"/>
+                <a:spcPts val="600"/>
               </a:spcBef>
               <a:spcAft>
-                <a:spcPts val="800"/>
+                <a:spcPts val="600"/>
               </a:spcAft>
-              <a:defRPr sz="1500">
+              <a:defRPr sz="1400">
                 <a:solidFill>
                   <a:srgbClr val="2D2D2D"/>
                 </a:solidFill>
@@ -5874,12 +5900,12 @@
           <a:p>
             <a:pPr>
               <a:spcBef>
-                <a:spcPts val="800"/>
+                <a:spcPts val="600"/>
               </a:spcBef>
               <a:spcAft>
-                <a:spcPts val="800"/>
+                <a:spcPts val="600"/>
               </a:spcAft>
-              <a:defRPr sz="1500">
+              <a:defRPr sz="1400">
                 <a:solidFill>
                   <a:srgbClr val="2D2D2D"/>
                 </a:solidFill>
@@ -5900,8 +5926,8 @@
         </p:nvSpPr>
         <p:spPr>
           <a:xfrm>
-            <a:off x="6217920" y="1097280"/>
-            <a:ext cx="4572000" cy="365760"/>
+            <a:off x="6217920" y="1005840"/>
+            <a:ext cx="4572000" cy="320040"/>
           </a:xfrm>
           <a:prstGeom prst="rect">
             <a:avLst/>
@@ -5915,7 +5941,7 @@
           <a:lstStyle/>
           <a:p>
             <a:pPr algn="l">
-              <a:defRPr sz="1800" b="1">
+              <a:defRPr sz="1700" b="1">
                 <a:solidFill>
                   <a:srgbClr val="4B2E83"/>
                 </a:solidFill>
@@ -5936,7 +5962,7 @@
         </p:nvSpPr>
         <p:spPr>
           <a:xfrm>
-            <a:off x="6217920" y="1508760"/>
+            <a:off x="6217920" y="1371600"/>
             <a:ext cx="5486400" cy="2011680"/>
           </a:xfrm>
           <a:prstGeom prst="rect">
@@ -5952,12 +5978,12 @@
           <a:p>
             <a:pPr>
               <a:spcBef>
-                <a:spcPts val="800"/>
+                <a:spcPts val="600"/>
               </a:spcBef>
               <a:spcAft>
-                <a:spcPts val="800"/>
+                <a:spcPts val="600"/>
               </a:spcAft>
-              <a:defRPr sz="1500">
+              <a:defRPr sz="1400">
                 <a:solidFill>
                   <a:srgbClr val="2D2D2D"/>
                 </a:solidFill>
@@ -5971,12 +5997,12 @@
           <a:p>
             <a:pPr>
               <a:spcBef>
-                <a:spcPts val="800"/>
+                <a:spcPts val="600"/>
               </a:spcBef>
               <a:spcAft>
-                <a:spcPts val="800"/>
+                <a:spcPts val="600"/>
               </a:spcAft>
-              <a:defRPr sz="1500">
+              <a:defRPr sz="1400">
                 <a:solidFill>
                   <a:srgbClr val="2D2D2D"/>
                 </a:solidFill>
@@ -5990,12 +6016,12 @@
           <a:p>
             <a:pPr>
               <a:spcBef>
-                <a:spcPts val="800"/>
+                <a:spcPts val="600"/>
               </a:spcBef>
               <a:spcAft>
-                <a:spcPts val="800"/>
+                <a:spcPts val="600"/>
               </a:spcAft>
-              <a:defRPr sz="1500">
+              <a:defRPr sz="1400">
                 <a:solidFill>
                   <a:srgbClr val="2D2D2D"/>
                 </a:solidFill>
@@ -6009,12 +6035,12 @@
           <a:p>
             <a:pPr>
               <a:spcBef>
-                <a:spcPts val="800"/>
+                <a:spcPts val="600"/>
               </a:spcBef>
               <a:spcAft>
-                <a:spcPts val="800"/>
+                <a:spcPts val="600"/>
               </a:spcAft>
-              <a:defRPr sz="1500">
+              <a:defRPr sz="1400">
                 <a:solidFill>
                   <a:srgbClr val="2D2D2D"/>
                 </a:solidFill>
@@ -6035,8 +6061,8 @@
         </p:nvSpPr>
         <p:spPr>
           <a:xfrm>
-            <a:off x="457200" y="4206240"/>
-            <a:ext cx="11247120" cy="822960"/>
+            <a:off x="365760" y="3931920"/>
+            <a:ext cx="11430000" cy="731520"/>
           </a:xfrm>
           <a:prstGeom prst="roundRect">
             <a:avLst/>
@@ -6078,8 +6104,8 @@
         </p:nvSpPr>
         <p:spPr>
           <a:xfrm>
-            <a:off x="731520" y="4389120"/>
-            <a:ext cx="10515600" cy="457200"/>
+            <a:off x="548640" y="4114800"/>
+            <a:ext cx="10972800" cy="365760"/>
           </a:xfrm>
           <a:prstGeom prst="rect">
             <a:avLst/>
@@ -6093,7 +6119,7 @@
           <a:lstStyle/>
           <a:p>
             <a:pPr algn="ctr">
-              <a:defRPr sz="2000" b="1">
+              <a:defRPr sz="1800" b="1">
                 <a:solidFill>
                   <a:srgbClr val="4B2E83"/>
                 </a:solidFill>
@@ -6114,8 +6140,8 @@
         </p:nvSpPr>
         <p:spPr>
           <a:xfrm>
-            <a:off x="457200" y="5303520"/>
-            <a:ext cx="4572000" cy="365760"/>
+            <a:off x="365760" y="4937760"/>
+            <a:ext cx="4572000" cy="320040"/>
           </a:xfrm>
           <a:prstGeom prst="rect">
             <a:avLst/>
@@ -6129,7 +6155,7 @@
           <a:lstStyle/>
           <a:p>
             <a:pPr algn="l">
-              <a:defRPr sz="1800" b="1">
+              <a:defRPr sz="1700" b="1">
                 <a:solidFill>
                   <a:srgbClr val="4B2E83"/>
                 </a:solidFill>
@@ -6150,8 +6176,8 @@
         </p:nvSpPr>
         <p:spPr>
           <a:xfrm>
-            <a:off x="457200" y="5669280"/>
-            <a:ext cx="10972800" cy="457200"/>
+            <a:off x="365760" y="5303520"/>
+            <a:ext cx="10972800" cy="365760"/>
           </a:xfrm>
           <a:prstGeom prst="rect">
             <a:avLst/>
@@ -6165,7 +6191,7 @@
           <a:lstStyle/>
           <a:p>
             <a:pPr algn="l">
-              <a:defRPr sz="1400" b="0">
+              <a:defRPr sz="1300" b="0">
                 <a:solidFill>
                   <a:srgbClr val="666666"/>
                 </a:solidFill>
@@ -6173,7 +6199,7 @@
               </a:defRPr>
             </a:pPr>
             <a:r>
-              <a:t>BTC has excess kurtosis &gt; 20 — Sharpe assumes normality, Calmar penalizes max drawdown directly</a:t>
+              <a:t>BTC excess kurtosis &gt; 20 — Sharpe assumes normality; Calmar penalizes max drawdown directly</a:t>
             </a:r>
           </a:p>
         </p:txBody>
@@ -6256,7 +6282,7 @@
         <p:spPr>
           <a:xfrm>
             <a:off x="0" y="822960"/>
-            <a:ext cx="12191695" cy="32004"/>
+            <a:ext cx="12191695" cy="27432"/>
           </a:xfrm>
           <a:prstGeom prst="rect">
             <a:avLst/>
@@ -6298,8 +6324,8 @@
         </p:nvSpPr>
         <p:spPr>
           <a:xfrm>
-            <a:off x="457200" y="201168"/>
-            <a:ext cx="10972800" cy="502920"/>
+            <a:off x="365760" y="201168"/>
+            <a:ext cx="10972800" cy="457200"/>
           </a:xfrm>
           <a:prstGeom prst="rect">
             <a:avLst/>
@@ -6313,7 +6339,7 @@
           <a:lstStyle/>
           <a:p>
             <a:pPr algn="l">
-              <a:defRPr sz="2800" b="1">
+              <a:defRPr sz="2600" b="1">
                 <a:solidFill>
                   <a:srgbClr val="FFFFFF"/>
                 </a:solidFill>
@@ -6342,8 +6368,8 @@
         </p:blipFill>
         <p:spPr>
           <a:xfrm>
-            <a:off x="365760" y="1051560"/>
-            <a:ext cx="11430000" cy="2996773"/>
+            <a:off x="457200" y="1097280"/>
+            <a:ext cx="11247120" cy="2948824"/>
           </a:xfrm>
           <a:prstGeom prst="rect">
             <a:avLst/>
@@ -6358,8 +6384,8 @@
         </p:nvSpPr>
         <p:spPr>
           <a:xfrm>
-            <a:off x="457200" y="6309360"/>
-            <a:ext cx="11247120" cy="365760"/>
+            <a:off x="365760" y="6217920"/>
+            <a:ext cx="11460175" cy="365760"/>
           </a:xfrm>
           <a:prstGeom prst="rect">
             <a:avLst/>
@@ -6373,7 +6399,7 @@
           <a:lstStyle/>
           <a:p>
             <a:pPr algn="ctr">
-              <a:defRPr sz="1300" b="0">
+              <a:defRPr sz="1200" b="0">
                 <a:solidFill>
                   <a:srgbClr val="666666"/>
                 </a:solidFill>
@@ -6464,7 +6490,7 @@
         <p:spPr>
           <a:xfrm>
             <a:off x="0" y="822960"/>
-            <a:ext cx="12191695" cy="32004"/>
+            <a:ext cx="12191695" cy="27432"/>
           </a:xfrm>
           <a:prstGeom prst="rect">
             <a:avLst/>
@@ -6506,8 +6532,8 @@
         </p:nvSpPr>
         <p:spPr>
           <a:xfrm>
-            <a:off x="457200" y="201168"/>
-            <a:ext cx="10972800" cy="502920"/>
+            <a:off x="365760" y="201168"/>
+            <a:ext cx="10972800" cy="457200"/>
           </a:xfrm>
           <a:prstGeom prst="rect">
             <a:avLst/>
@@ -6521,7 +6547,7 @@
           <a:lstStyle/>
           <a:p>
             <a:pPr algn="l">
-              <a:defRPr sz="2800" b="1">
+              <a:defRPr sz="2600" b="1">
                 <a:solidFill>
                   <a:srgbClr val="FFFFFF"/>
                 </a:solidFill>
@@ -6550,8 +6576,8 @@
         </p:blipFill>
         <p:spPr>
           <a:xfrm>
-            <a:off x="274320" y="1005840"/>
-            <a:ext cx="5760720" cy="1617287"/>
+            <a:off x="274320" y="1097280"/>
+            <a:ext cx="5669280" cy="1591615"/>
           </a:xfrm>
           <a:prstGeom prst="rect">
             <a:avLst/>
@@ -6574,8 +6600,8 @@
         </p:blipFill>
         <p:spPr>
           <a:xfrm>
-            <a:off x="6126480" y="1005840"/>
-            <a:ext cx="5760720" cy="1741613"/>
+            <a:off x="6126480" y="1097280"/>
+            <a:ext cx="5669280" cy="1713968"/>
           </a:xfrm>
           <a:prstGeom prst="rect">
             <a:avLst/>
@@ -6590,8 +6616,8 @@
         </p:nvSpPr>
         <p:spPr>
           <a:xfrm>
-            <a:off x="457200" y="5120640"/>
-            <a:ext cx="11247120" cy="365760"/>
+            <a:off x="457200" y="5029200"/>
+            <a:ext cx="5486400" cy="274320"/>
           </a:xfrm>
           <a:prstGeom prst="rect">
             <a:avLst/>
@@ -6604,8 +6630,8 @@
           </a:bodyPr>
           <a:lstStyle/>
           <a:p>
-            <a:pPr algn="ctr">
-              <a:defRPr sz="1300" b="0">
+            <a:pPr algn="l">
+              <a:defRPr sz="1200" b="0">
                 <a:solidFill>
                   <a:srgbClr val="666666"/>
                 </a:solidFill>
@@ -6613,7 +6639,43 @@
               </a:defRPr>
             </a:pPr>
             <a:r>
-              <a:t>ACF decays after lag 3 → supports mean reversion  •  No weekday effect → sentiment-driven, not calendar</a:t>
+              <a:t>ACF decays after lag 3 → mean reversion</a:t>
+            </a:r>
+          </a:p>
+        </p:txBody>
+      </p:sp>
+      <p:sp>
+        <p:nvSpPr>
+          <p:cNvPr id="8" name="TextBox 7"/>
+          <p:cNvSpPr txBox="1"/>
+          <p:nvPr/>
+        </p:nvSpPr>
+        <p:spPr>
+          <a:xfrm>
+            <a:off x="6217920" y="5029200"/>
+            <a:ext cx="5486400" cy="274320"/>
+          </a:xfrm>
+          <a:prstGeom prst="rect">
+            <a:avLst/>
+          </a:prstGeom>
+          <a:noFill/>
+        </p:spPr>
+        <p:txBody>
+          <a:bodyPr wrap="square">
+            <a:spAutoFit/>
+          </a:bodyPr>
+          <a:lstStyle/>
+          <a:p>
+            <a:pPr algn="l">
+              <a:defRPr sz="1200" b="0">
+                <a:solidFill>
+                  <a:srgbClr val="666666"/>
+                </a:solidFill>
+                <a:latin typeface="Arial"/>
+              </a:defRPr>
+            </a:pPr>
+            <a:r>
+              <a:t>No weekday effect → sentiment-driven</a:t>
             </a:r>
           </a:p>
         </p:txBody>
@@ -6696,7 +6758,7 @@
         <p:spPr>
           <a:xfrm>
             <a:off x="0" y="822960"/>
-            <a:ext cx="12191695" cy="32004"/>
+            <a:ext cx="12191695" cy="27432"/>
           </a:xfrm>
           <a:prstGeom prst="rect">
             <a:avLst/>
@@ -6738,8 +6800,8 @@
         </p:nvSpPr>
         <p:spPr>
           <a:xfrm>
-            <a:off x="457200" y="201168"/>
-            <a:ext cx="10972800" cy="502920"/>
+            <a:off x="365760" y="201168"/>
+            <a:ext cx="10972800" cy="457200"/>
           </a:xfrm>
           <a:prstGeom prst="rect">
             <a:avLst/>
@@ -6753,7 +6815,7 @@
           <a:lstStyle/>
           <a:p>
             <a:pPr algn="l">
-              <a:defRPr sz="2800" b="1">
+              <a:defRPr sz="2600" b="1">
                 <a:solidFill>
                   <a:srgbClr val="FFFFFF"/>
                 </a:solidFill>
@@ -6782,7 +6844,7 @@
         </p:blipFill>
         <p:spPr>
           <a:xfrm>
-            <a:off x="274320" y="960120"/>
+            <a:off x="274320" y="1005840"/>
             <a:ext cx="11612880" cy="3814639"/>
           </a:xfrm>
           <a:prstGeom prst="rect">
@@ -6798,8 +6860,8 @@
         </p:nvSpPr>
         <p:spPr>
           <a:xfrm>
-            <a:off x="457200" y="6309360"/>
-            <a:ext cx="11247120" cy="365760"/>
+            <a:off x="365760" y="6217920"/>
+            <a:ext cx="11460175" cy="365760"/>
           </a:xfrm>
           <a:prstGeom prst="rect">
             <a:avLst/>
@@ -6813,7 +6875,7 @@
           <a:lstStyle/>
           <a:p>
             <a:pPr algn="ctr">
-              <a:defRPr sz="1300" b="0">
+              <a:defRPr sz="1200" b="0">
                 <a:solidFill>
                   <a:srgbClr val="666666"/>
                 </a:solidFill>
@@ -6904,7 +6966,7 @@
         <p:spPr>
           <a:xfrm>
             <a:off x="0" y="822960"/>
-            <a:ext cx="12191695" cy="32004"/>
+            <a:ext cx="12191695" cy="27432"/>
           </a:xfrm>
           <a:prstGeom prst="rect">
             <a:avLst/>
@@ -6946,8 +7008,8 @@
         </p:nvSpPr>
         <p:spPr>
           <a:xfrm>
-            <a:off x="457200" y="201168"/>
-            <a:ext cx="10972800" cy="502920"/>
+            <a:off x="365760" y="201168"/>
+            <a:ext cx="10972800" cy="457200"/>
           </a:xfrm>
           <a:prstGeom prst="rect">
             <a:avLst/>
@@ -6961,7 +7023,7 @@
           <a:lstStyle/>
           <a:p>
             <a:pPr algn="l">
-              <a:defRPr sz="2800" b="1">
+              <a:defRPr sz="2600" b="1">
                 <a:solidFill>
                   <a:srgbClr val="FFFFFF"/>
                 </a:solidFill>
@@ -6990,8 +7052,8 @@
         </p:blipFill>
         <p:spPr>
           <a:xfrm>
-            <a:off x="274320" y="960120"/>
-            <a:ext cx="11612880" cy="3039613"/>
+            <a:off x="274320" y="1005840"/>
+            <a:ext cx="11612880" cy="3039612"/>
           </a:xfrm>
           <a:prstGeom prst="rect">
             <a:avLst/>
@@ -7006,8 +7068,8 @@
         </p:nvSpPr>
         <p:spPr>
           <a:xfrm>
-            <a:off x="457200" y="6309360"/>
-            <a:ext cx="11247120" cy="365760"/>
+            <a:off x="365760" y="6217920"/>
+            <a:ext cx="11460175" cy="365760"/>
           </a:xfrm>
           <a:prstGeom prst="rect">
             <a:avLst/>
@@ -7021,7 +7083,7 @@
           <a:lstStyle/>
           <a:p>
             <a:pPr algn="ctr">
-              <a:defRPr sz="1300" b="0">
+              <a:defRPr sz="1200" b="0">
                 <a:solidFill>
                   <a:srgbClr val="666666"/>
                 </a:solidFill>
@@ -7029,7 +7091,7 @@
               </a:defRPr>
             </a:pPr>
             <a:r>
-              <a:t>Negative slope confirms contrarian hypothesis  •  H1 SUPPORTED: IC significant at 24h horizon (p &lt; 0.05)</a:t>
+              <a:t>Negative slope confirms contrarian hypothesis  •  H1 SUPPORTED: IC significant at 24h (p &lt; 0.05)</a:t>
             </a:r>
           </a:p>
         </p:txBody>
@@ -7112,7 +7174,7 @@
         <p:spPr>
           <a:xfrm>
             <a:off x="0" y="822960"/>
-            <a:ext cx="12191695" cy="32004"/>
+            <a:ext cx="12191695" cy="27432"/>
           </a:xfrm>
           <a:prstGeom prst="rect">
             <a:avLst/>
@@ -7154,8 +7216,8 @@
         </p:nvSpPr>
         <p:spPr>
           <a:xfrm>
-            <a:off x="457200" y="201168"/>
-            <a:ext cx="10972800" cy="502920"/>
+            <a:off x="365760" y="201168"/>
+            <a:ext cx="10972800" cy="457200"/>
           </a:xfrm>
           <a:prstGeom prst="rect">
             <a:avLst/>
@@ -7169,7 +7231,7 @@
           <a:lstStyle/>
           <a:p>
             <a:pPr algn="l">
-              <a:defRPr sz="2800" b="1">
+              <a:defRPr sz="2600" b="1">
                 <a:solidFill>
                   <a:srgbClr val="FFFFFF"/>
                 </a:solidFill>
@@ -7198,8 +7260,8 @@
         </p:blipFill>
         <p:spPr>
           <a:xfrm>
-            <a:off x="274320" y="914400"/>
-            <a:ext cx="11612880" cy="6157165"/>
+            <a:off x="182880" y="1005840"/>
+            <a:ext cx="8623139" cy="4572000"/>
           </a:xfrm>
           <a:prstGeom prst="rect">
             <a:avLst/>
@@ -7214,8 +7276,8 @@
         </p:nvSpPr>
         <p:spPr>
           <a:xfrm>
-            <a:off x="457200" y="6309360"/>
-            <a:ext cx="11247120" cy="365760"/>
+            <a:off x="365760" y="6217920"/>
+            <a:ext cx="11460175" cy="365760"/>
           </a:xfrm>
           <a:prstGeom prst="rect">
             <a:avLst/>
@@ -7229,7 +7291,7 @@
           <a:lstStyle/>
           <a:p>
             <a:pPr algn="ctr">
-              <a:defRPr sz="1300" b="0">
+              <a:defRPr sz="1200" b="0">
                 <a:solidFill>
                   <a:srgbClr val="666666"/>
                 </a:solidFill>
@@ -7237,7 +7299,7 @@
               </a:defRPr>
             </a:pPr>
             <a:r>
-              <a:t>Green = Long (z &lt; -1.5)  •  Red = Short (z &gt; 1.5)  •  Signals cluster around extreme funding events</a:t>
+              <a:t>Green = Long (z &lt; -1.5)  •  Red = Short (z &gt; 1.5)  •  Signals cluster around extreme events</a:t>
             </a:r>
           </a:p>
         </p:txBody>
@@ -7320,7 +7382,7 @@
         <p:spPr>
           <a:xfrm>
             <a:off x="0" y="822960"/>
-            <a:ext cx="12191695" cy="32004"/>
+            <a:ext cx="12191695" cy="27432"/>
           </a:xfrm>
           <a:prstGeom prst="rect">
             <a:avLst/>
@@ -7362,8 +7424,8 @@
         </p:nvSpPr>
         <p:spPr>
           <a:xfrm>
-            <a:off x="457200" y="201168"/>
-            <a:ext cx="10972800" cy="502920"/>
+            <a:off x="365760" y="201168"/>
+            <a:ext cx="10972800" cy="457200"/>
           </a:xfrm>
           <a:prstGeom prst="rect">
             <a:avLst/>
@@ -7377,7 +7439,7 @@
           <a:lstStyle/>
           <a:p>
             <a:pPr algn="l">
-              <a:defRPr sz="2800" b="1">
+              <a:defRPr sz="2600" b="1">
                 <a:solidFill>
                   <a:srgbClr val="FFFFFF"/>
                 </a:solidFill>
@@ -7406,8 +7468,8 @@
         </p:blipFill>
         <p:spPr>
           <a:xfrm>
-            <a:off x="365760" y="914400"/>
-            <a:ext cx="11430000" cy="7779815"/>
+            <a:off x="274320" y="1005840"/>
+            <a:ext cx="6717121" cy="4572000"/>
           </a:xfrm>
           <a:prstGeom prst="rect">
             <a:avLst/>
@@ -7422,8 +7484,8 @@
         </p:nvSpPr>
         <p:spPr>
           <a:xfrm>
-            <a:off x="457200" y="6309360"/>
-            <a:ext cx="11247120" cy="365760"/>
+            <a:off x="365760" y="6217920"/>
+            <a:ext cx="11460175" cy="365760"/>
           </a:xfrm>
           <a:prstGeom prst="rect">
             <a:avLst/>
@@ -7437,7 +7499,7 @@
           <a:lstStyle/>
           <a:p>
             <a:pPr algn="ctr">
-              <a:defRPr sz="1300" b="0">
+              <a:defRPr sz="1200" b="0">
                 <a:solidFill>
                   <a:srgbClr val="666666"/>
                 </a:solidFill>
@@ -7445,7 +7507,7 @@
               </a:defRPr>
             </a:pPr>
             <a:r>
-              <a:t>Rule 0: Basic  →  Rule 1: +Max hold  →  Rule 2: +Stop loss  →  Rule 3: +OI filter  •  Gray: BTC buy-and-hold</a:t>
+              <a:t>Rule 0: Basic → Rule 1: +Max hold → Rule 2: +Stop loss → Rule 3: +OI filter  •  Gray: BTC buy-hold</a:t>
             </a:r>
           </a:p>
         </p:txBody>
@@ -7528,7 +7590,7 @@
         <p:spPr>
           <a:xfrm>
             <a:off x="0" y="822960"/>
-            <a:ext cx="12191695" cy="32004"/>
+            <a:ext cx="12191695" cy="27432"/>
           </a:xfrm>
           <a:prstGeom prst="rect">
             <a:avLst/>
@@ -7570,8 +7632,8 @@
         </p:nvSpPr>
         <p:spPr>
           <a:xfrm>
-            <a:off x="457200" y="201168"/>
-            <a:ext cx="10972800" cy="502920"/>
+            <a:off x="365760" y="201168"/>
+            <a:ext cx="10972800" cy="457200"/>
           </a:xfrm>
           <a:prstGeom prst="rect">
             <a:avLst/>
@@ -7585,7 +7647,7 @@
           <a:lstStyle/>
           <a:p>
             <a:pPr algn="l">
-              <a:defRPr sz="2800" b="1">
+              <a:defRPr sz="2600" b="1">
                 <a:solidFill>
                   <a:srgbClr val="FFFFFF"/>
                 </a:solidFill>
@@ -7614,8 +7676,8 @@
         </p:blipFill>
         <p:spPr>
           <a:xfrm>
-            <a:off x="365760" y="960120"/>
-            <a:ext cx="11430000" cy="4022428"/>
+            <a:off x="365760" y="1005840"/>
+            <a:ext cx="11430000" cy="4022427"/>
           </a:xfrm>
           <a:prstGeom prst="rect">
             <a:avLst/>
@@ -7630,8 +7692,8 @@
         </p:nvSpPr>
         <p:spPr>
           <a:xfrm>
-            <a:off x="457200" y="6309360"/>
-            <a:ext cx="11247120" cy="365760"/>
+            <a:off x="365760" y="6217920"/>
+            <a:ext cx="11460175" cy="365760"/>
           </a:xfrm>
           <a:prstGeom prst="rect">
             <a:avLst/>
@@ -7645,7 +7707,7 @@
           <a:lstStyle/>
           <a:p>
             <a:pPr algn="ctr">
-              <a:defRPr sz="1300" b="0">
+              <a:defRPr sz="1200" b="0">
                 <a:solidFill>
                   <a:srgbClr val="666666"/>
                 </a:solidFill>
@@ -7653,7 +7715,7 @@
               </a:defRPr>
             </a:pPr>
             <a:r>
-              <a:t>Left: Threshold × Window heatmap  •  Right: Pardo check (best not extreme outlier)  •  H3 SUPPORTED</a:t>
+              <a:t>Left: Threshold × Window heatmap  •  Right: Pardo check (best ≈ 2σ above mean)  •  H3 SUPPORTED</a:t>
             </a:r>
           </a:p>
         </p:txBody>

</xml_diff>